<commit_message>
Route DP44 stage outputs to their input queues
</commit_message>
<xml_diff>
--- a/docs/presentations_files/dp-comparison/VIA-DP44-implementation-comparison.pptx
+++ b/docs/presentations_files/dp-comparison/VIA-DP44-implementation-comparison.pptx
@@ -2,13 +2,13 @@
 <file path=ppt/presentation.xml><?xml version="1.0" encoding="utf-8"?>
 <p:presentation xmlns:p="http://schemas.openxmlformats.org/presentationml/2006/main">
   <p:sldMasterIdLst>
-    <p:sldMasterId xmlns:r="http://schemas.openxmlformats.org/officeDocument/2006/relationships" id="2147483648" r:id="Rda4957346d634669"/>
+    <p:sldMasterId xmlns:r="http://schemas.openxmlformats.org/officeDocument/2006/relationships" id="2147483648" r:id="R40acd1fd36ea48b5"/>
   </p:sldMasterIdLst>
   <p:notesMasterIdLst>
-    <p:notesMasterId xmlns:r="http://schemas.openxmlformats.org/officeDocument/2006/relationships" r:id="Rc559b8d0e8224eed"/>
+    <p:notesMasterId xmlns:r="http://schemas.openxmlformats.org/officeDocument/2006/relationships" r:id="R1834ee575b0d4d85"/>
   </p:notesMasterIdLst>
   <p:sldIdLst>
-    <p:sldId xmlns:r="http://schemas.openxmlformats.org/officeDocument/2006/relationships" id="256" r:id="R64ed24f253d74316"/>
+    <p:sldId xmlns:r="http://schemas.openxmlformats.org/officeDocument/2006/relationships" id="256" r:id="Race8ca3f670c4913"/>
   </p:sldIdLst>
   <p:sldSz cx="18288000" cy="10287000"/>
   <p:notesSz cx="6858000" cy="9144000"/>
@@ -514,7 +514,7 @@
           <p:cNvPr id="3" name="Title">
             <a:extLst xmlns:a="http://schemas.openxmlformats.org/drawingml/2006/main">
               <a:ext uri="{FF2B5EF4-FFF2-40B4-BE49-F238E27FC236}">
-                <a16:creationId xmlns:a16="http://schemas.microsoft.com/office/drawing/2014/main" id="{B0EE4812-7D33-4743-A3C6-29EACAF98530}"/>
+                <a16:creationId xmlns:a16="http://schemas.microsoft.com/office/drawing/2014/main" id="{FF26F29C-81D2-4D66-BE0C-F7A112806D05}"/>
               </a:ext>
             </a:extLst>
           </p:cNvPr>
@@ -671,7 +671,7 @@
           <p:cNvPr id="2" name="Subtitle">
             <a:extLst xmlns:a="http://schemas.openxmlformats.org/drawingml/2006/main">
               <a:ext uri="{FF2B5EF4-FFF2-40B4-BE49-F238E27FC236}">
-                <a16:creationId xmlns:a16="http://schemas.microsoft.com/office/drawing/2014/main" id="{C1217C64-6493-4DFC-A66F-7AB404EB7FFA}"/>
+                <a16:creationId xmlns:a16="http://schemas.microsoft.com/office/drawing/2014/main" id="{555BE52F-FB7B-4BA7-B689-3C9C601466AB}"/>
               </a:ext>
             </a:extLst>
           </p:cNvPr>
@@ -845,7 +845,7 @@
           <p:cNvPr id="2" name="Section title">
             <a:extLst xmlns:a="http://schemas.openxmlformats.org/drawingml/2006/main">
               <a:ext uri="{FF2B5EF4-FFF2-40B4-BE49-F238E27FC236}">
-                <a16:creationId xmlns:a16="http://schemas.microsoft.com/office/drawing/2014/main" id="{72FC7ADF-13A7-4BAD-A4E5-F525F42DD88E}"/>
+                <a16:creationId xmlns:a16="http://schemas.microsoft.com/office/drawing/2014/main" id="{9FDDED9D-36B3-4237-B30F-A9948EA82EB8}"/>
               </a:ext>
             </a:extLst>
           </p:cNvPr>
@@ -1019,7 +1019,7 @@
           <p:cNvPr id="3" name="Title">
             <a:extLst xmlns:a="http://schemas.openxmlformats.org/drawingml/2006/main">
               <a:ext uri="{FF2B5EF4-FFF2-40B4-BE49-F238E27FC236}">
-                <a16:creationId xmlns:a16="http://schemas.microsoft.com/office/drawing/2014/main" id="{6ED683F0-AA30-4F0A-9E38-0D320979F1BF}"/>
+                <a16:creationId xmlns:a16="http://schemas.microsoft.com/office/drawing/2014/main" id="{4E22D514-8F80-4F0C-AB74-A966BFE8B1FA}"/>
               </a:ext>
             </a:extLst>
           </p:cNvPr>
@@ -1176,7 +1176,7 @@
           <p:cNvPr id="2" name="Body">
             <a:extLst xmlns:a="http://schemas.openxmlformats.org/drawingml/2006/main">
               <a:ext uri="{FF2B5EF4-FFF2-40B4-BE49-F238E27FC236}">
-                <a16:creationId xmlns:a16="http://schemas.microsoft.com/office/drawing/2014/main" id="{4B7805DA-EB9B-438A-923C-2C521F9F6707}"/>
+                <a16:creationId xmlns:a16="http://schemas.microsoft.com/office/drawing/2014/main" id="{E2ED3A7E-31AB-412C-975D-847921587087}"/>
               </a:ext>
             </a:extLst>
           </p:cNvPr>
@@ -1350,7 +1350,7 @@
           <p:cNvPr id="4" name="Title">
             <a:extLst xmlns:a="http://schemas.openxmlformats.org/drawingml/2006/main">
               <a:ext uri="{FF2B5EF4-FFF2-40B4-BE49-F238E27FC236}">
-                <a16:creationId xmlns:a16="http://schemas.microsoft.com/office/drawing/2014/main" id="{2DB346DB-2140-43F7-909D-E939709385C4}"/>
+                <a16:creationId xmlns:a16="http://schemas.microsoft.com/office/drawing/2014/main" id="{5E9BAD18-4506-49D2-A8C6-C2E038849482}"/>
               </a:ext>
             </a:extLst>
           </p:cNvPr>
@@ -1507,7 +1507,7 @@
           <p:cNvPr id="2" name="Left column">
             <a:extLst xmlns:a="http://schemas.openxmlformats.org/drawingml/2006/main">
               <a:ext uri="{FF2B5EF4-FFF2-40B4-BE49-F238E27FC236}">
-                <a16:creationId xmlns:a16="http://schemas.microsoft.com/office/drawing/2014/main" id="{4B271D16-825E-4BB0-AE5A-E95E2A284373}"/>
+                <a16:creationId xmlns:a16="http://schemas.microsoft.com/office/drawing/2014/main" id="{F3686C2C-12DF-47F4-BEA1-DB14A71E458B}"/>
               </a:ext>
             </a:extLst>
           </p:cNvPr>
@@ -1664,7 +1664,7 @@
           <p:cNvPr id="3" name="Right column">
             <a:extLst xmlns:a="http://schemas.openxmlformats.org/drawingml/2006/main">
               <a:ext uri="{FF2B5EF4-FFF2-40B4-BE49-F238E27FC236}">
-                <a16:creationId xmlns:a16="http://schemas.microsoft.com/office/drawing/2014/main" id="{F8C09662-BDD6-44F6-A620-D5049ACCCDFA}"/>
+                <a16:creationId xmlns:a16="http://schemas.microsoft.com/office/drawing/2014/main" id="{C762B095-C5A0-4F71-9AD4-730E7C35A346}"/>
               </a:ext>
             </a:extLst>
           </p:cNvPr>
@@ -1838,7 +1838,7 @@
           <p:cNvPr id="3" name="Title">
             <a:extLst xmlns:a="http://schemas.openxmlformats.org/drawingml/2006/main">
               <a:ext uri="{FF2B5EF4-FFF2-40B4-BE49-F238E27FC236}">
-                <a16:creationId xmlns:a16="http://schemas.microsoft.com/office/drawing/2014/main" id="{B76DFC12-B929-4928-84D3-30A0CCF62B88}"/>
+                <a16:creationId xmlns:a16="http://schemas.microsoft.com/office/drawing/2014/main" id="{8EAD6F81-F3F3-4491-A3C7-2015EAD00590}"/>
               </a:ext>
             </a:extLst>
           </p:cNvPr>
@@ -1995,7 +1995,7 @@
           <p:cNvPr id="2" name="Left column">
             <a:extLst xmlns:a="http://schemas.openxmlformats.org/drawingml/2006/main">
               <a:ext uri="{FF2B5EF4-FFF2-40B4-BE49-F238E27FC236}">
-                <a16:creationId xmlns:a16="http://schemas.microsoft.com/office/drawing/2014/main" id="{7F4B79A8-2F46-4F32-882A-AE62878B2BE0}"/>
+                <a16:creationId xmlns:a16="http://schemas.microsoft.com/office/drawing/2014/main" id="{F5AA72FA-2D44-44FA-8610-9B0BC0FD830F}"/>
               </a:ext>
             </a:extLst>
           </p:cNvPr>
@@ -2190,12 +2190,12 @@
   </p:cSld>
   <p:clrMap bg1="lt1" tx1="dk1" bg2="lt2" tx2="dk2" accent1="accent1" accent2="accent2" accent3="accent3" accent4="accent4" accent5="accent5" accent6="accent6" hlink="hlink" folHlink="folHlink"/>
   <p:sldLayoutIdLst>
-    <p:sldLayoutId xmlns:r="http://schemas.openxmlformats.org/officeDocument/2006/relationships" id="2147483649" r:id="R23b17ee263d14b65"/>
-    <p:sldLayoutId xmlns:r="http://schemas.openxmlformats.org/officeDocument/2006/relationships" id="2147483650" r:id="R7cebe42c79604d3d"/>
-    <p:sldLayoutId xmlns:r="http://schemas.openxmlformats.org/officeDocument/2006/relationships" id="2147483651" r:id="R4ee9fe893df64cd1"/>
-    <p:sldLayoutId xmlns:r="http://schemas.openxmlformats.org/officeDocument/2006/relationships" id="2147483652" r:id="Ra430f31cc2314d12"/>
-    <p:sldLayoutId xmlns:r="http://schemas.openxmlformats.org/officeDocument/2006/relationships" id="2147483653" r:id="Rbb34bb99d1514474"/>
-    <p:sldLayoutId xmlns:r="http://schemas.openxmlformats.org/officeDocument/2006/relationships" id="2147483654" r:id="Re818334bee9c429e"/>
+    <p:sldLayoutId xmlns:r="http://schemas.openxmlformats.org/officeDocument/2006/relationships" id="2147483649" r:id="R76b620d4758a4c4c"/>
+    <p:sldLayoutId xmlns:r="http://schemas.openxmlformats.org/officeDocument/2006/relationships" id="2147483650" r:id="R1da6e1bb3a7a4459"/>
+    <p:sldLayoutId xmlns:r="http://schemas.openxmlformats.org/officeDocument/2006/relationships" id="2147483651" r:id="Re597ca399da845ae"/>
+    <p:sldLayoutId xmlns:r="http://schemas.openxmlformats.org/officeDocument/2006/relationships" id="2147483652" r:id="R7e29575551344c45"/>
+    <p:sldLayoutId xmlns:r="http://schemas.openxmlformats.org/officeDocument/2006/relationships" id="2147483653" r:id="R0ebbd2505b4848c7"/>
+    <p:sldLayoutId xmlns:r="http://schemas.openxmlformats.org/officeDocument/2006/relationships" id="2147483654" r:id="R77cc2c17786f4eb4"/>
   </p:sldLayoutIdLst>
   <p:txStyles>
     <p:titleStyle>
@@ -2743,10 +2743,10 @@
       </p:grpSpPr>
       <p:sp>
         <p:nvSpPr>
-          <p:cNvPr id="223" name="dp44-implementation-comparison / n1">
-            <a:extLst xmlns:a="http://schemas.openxmlformats.org/drawingml/2006/main">
-              <a:ext uri="{FF2B5EF4-FFF2-40B4-BE49-F238E27FC236}">
-                <a16:creationId xmlns:a16="http://schemas.microsoft.com/office/drawing/2014/main" id="{82A17C33-D17F-476B-B9F4-A98305D0DAFA}"/>
+          <p:cNvPr id="225" name="dp44-implementation-comparison / n1">
+            <a:extLst xmlns:a="http://schemas.openxmlformats.org/drawingml/2006/main">
+              <a:ext uri="{FF2B5EF4-FFF2-40B4-BE49-F238E27FC236}">
+                <a16:creationId xmlns:a16="http://schemas.microsoft.com/office/drawing/2014/main" id="{7041E3CA-1D3F-4981-B8DF-AFDA332E3171}"/>
               </a:ext>
             </a:extLst>
           </p:cNvPr>
@@ -2777,7 +2777,7 @@
           <p:cNvPr id="2" name="dp44-implementation-comparison / n2 / text 1">
             <a:extLst xmlns:a="http://schemas.openxmlformats.org/drawingml/2006/main">
               <a:ext uri="{FF2B5EF4-FFF2-40B4-BE49-F238E27FC236}">
-                <a16:creationId xmlns:a16="http://schemas.microsoft.com/office/drawing/2014/main" id="{5FF0963E-8F54-4770-BCC1-C339E997D6F3}"/>
+                <a16:creationId xmlns:a16="http://schemas.microsoft.com/office/drawing/2014/main" id="{D9F67D3A-426F-4401-A42C-F4DE83680ADA}"/>
               </a:ext>
             </a:extLst>
           </p:cNvPr>
@@ -2846,7 +2846,7 @@
           <p:cNvPr id="3" name="dp44-implementation-comparison / n3 / path">
             <a:extLst xmlns:a="http://schemas.openxmlformats.org/drawingml/2006/main">
               <a:ext uri="{FF2B5EF4-FFF2-40B4-BE49-F238E27FC236}">
-                <a16:creationId xmlns:a16="http://schemas.microsoft.com/office/drawing/2014/main" id="{4A9D6BB0-D255-4C9E-B2F3-3038011D49A6}"/>
+                <a16:creationId xmlns:a16="http://schemas.microsoft.com/office/drawing/2014/main" id="{96702953-28B7-43C6-973E-C0E5CE563085}"/>
               </a:ext>
             </a:extLst>
           </p:cNvPr>
@@ -2886,7 +2886,7 @@
           <p:cNvPr id="4" name="dp44-implementation-comparison / n4 / text 1">
             <a:extLst xmlns:a="http://schemas.openxmlformats.org/drawingml/2006/main">
               <a:ext uri="{FF2B5EF4-FFF2-40B4-BE49-F238E27FC236}">
-                <a16:creationId xmlns:a16="http://schemas.microsoft.com/office/drawing/2014/main" id="{2B9D32DF-579F-4310-A923-72139692F4BE}"/>
+                <a16:creationId xmlns:a16="http://schemas.microsoft.com/office/drawing/2014/main" id="{6B81C772-0685-4C2C-B306-9D4696F541E0}"/>
               </a:ext>
             </a:extLst>
           </p:cNvPr>
@@ -2955,7 +2955,7 @@
           <p:cNvPr id="5" name="dp44-implementation-comparison / n5 / text 1">
             <a:extLst xmlns:a="http://schemas.openxmlformats.org/drawingml/2006/main">
               <a:ext uri="{FF2B5EF4-FFF2-40B4-BE49-F238E27FC236}">
-                <a16:creationId xmlns:a16="http://schemas.microsoft.com/office/drawing/2014/main" id="{B9CA10F1-84F4-4C39-A752-27B71E842C32}"/>
+                <a16:creationId xmlns:a16="http://schemas.microsoft.com/office/drawing/2014/main" id="{E5ECCBDF-EAAD-43B4-86E6-E7934703B02F}"/>
               </a:ext>
             </a:extLst>
           </p:cNvPr>
@@ -3024,7 +3024,7 @@
           <p:cNvPr id="6" name="dp44-implementation-comparison / n6">
             <a:extLst xmlns:a="http://schemas.openxmlformats.org/drawingml/2006/main">
               <a:ext uri="{FF2B5EF4-FFF2-40B4-BE49-F238E27FC236}">
-                <a16:creationId xmlns:a16="http://schemas.microsoft.com/office/drawing/2014/main" id="{1DD2D899-7415-4923-B2EF-DD2E058757EA}"/>
+                <a16:creationId xmlns:a16="http://schemas.microsoft.com/office/drawing/2014/main" id="{830834FB-3F27-4DB3-83FE-EDA90BEA911C}"/>
               </a:ext>
             </a:extLst>
           </p:cNvPr>
@@ -3057,7 +3057,7 @@
           <p:cNvPr id="7" name="dp44-implementation-comparison / n7">
             <a:extLst xmlns:a="http://schemas.openxmlformats.org/drawingml/2006/main">
               <a:ext uri="{FF2B5EF4-FFF2-40B4-BE49-F238E27FC236}">
-                <a16:creationId xmlns:a16="http://schemas.microsoft.com/office/drawing/2014/main" id="{ACFC8545-DB2F-424E-932B-3CAE0412786C}"/>
+                <a16:creationId xmlns:a16="http://schemas.microsoft.com/office/drawing/2014/main" id="{52E91E71-B729-46C5-B34E-B1EE27E8BFCB}"/>
               </a:ext>
             </a:extLst>
           </p:cNvPr>
@@ -3090,7 +3090,7 @@
           <p:cNvPr id="8" name="dp44-implementation-comparison / n8 / text 1">
             <a:extLst xmlns:a="http://schemas.openxmlformats.org/drawingml/2006/main">
               <a:ext uri="{FF2B5EF4-FFF2-40B4-BE49-F238E27FC236}">
-                <a16:creationId xmlns:a16="http://schemas.microsoft.com/office/drawing/2014/main" id="{FE6BFBD3-0550-4C3A-A4B1-557923A9215B}"/>
+                <a16:creationId xmlns:a16="http://schemas.microsoft.com/office/drawing/2014/main" id="{18FE8336-080E-424D-9A64-F67462479AC6}"/>
               </a:ext>
             </a:extLst>
           </p:cNvPr>
@@ -3159,7 +3159,7 @@
           <p:cNvPr id="9" name="dp44-implementation-comparison / n9 / text 1">
             <a:extLst xmlns:a="http://schemas.openxmlformats.org/drawingml/2006/main">
               <a:ext uri="{FF2B5EF4-FFF2-40B4-BE49-F238E27FC236}">
-                <a16:creationId xmlns:a16="http://schemas.microsoft.com/office/drawing/2014/main" id="{BAB77E2E-FC59-4D6C-A7AC-A59B26395F5C}"/>
+                <a16:creationId xmlns:a16="http://schemas.microsoft.com/office/drawing/2014/main" id="{0694E713-96F2-4661-BBEB-CBAE955233B4}"/>
               </a:ext>
             </a:extLst>
           </p:cNvPr>
@@ -3228,7 +3228,7 @@
           <p:cNvPr id="10" name="dp44-implementation-comparison / n10">
             <a:extLst xmlns:a="http://schemas.openxmlformats.org/drawingml/2006/main">
               <a:ext uri="{FF2B5EF4-FFF2-40B4-BE49-F238E27FC236}">
-                <a16:creationId xmlns:a16="http://schemas.microsoft.com/office/drawing/2014/main" id="{743DA428-F7F4-4583-8716-6F0B741192DF}"/>
+                <a16:creationId xmlns:a16="http://schemas.microsoft.com/office/drawing/2014/main" id="{27637FE0-8362-4DE3-B32E-1B2DC12753E9}"/>
               </a:ext>
             </a:extLst>
           </p:cNvPr>
@@ -3261,7 +3261,7 @@
           <p:cNvPr id="11" name="dp44-implementation-comparison / n11 / text 1">
             <a:extLst xmlns:a="http://schemas.openxmlformats.org/drawingml/2006/main">
               <a:ext uri="{FF2B5EF4-FFF2-40B4-BE49-F238E27FC236}">
-                <a16:creationId xmlns:a16="http://schemas.microsoft.com/office/drawing/2014/main" id="{A95F54D5-9558-4208-93A3-AC517CA20EBE}"/>
+                <a16:creationId xmlns:a16="http://schemas.microsoft.com/office/drawing/2014/main" id="{0B544A77-BFC7-4619-84AD-B0FEBBC7A180}"/>
               </a:ext>
             </a:extLst>
           </p:cNvPr>
@@ -3330,7 +3330,7 @@
           <p:cNvPr id="12" name="dp44-implementation-comparison / n12 / text 1">
             <a:extLst xmlns:a="http://schemas.openxmlformats.org/drawingml/2006/main">
               <a:ext uri="{FF2B5EF4-FFF2-40B4-BE49-F238E27FC236}">
-                <a16:creationId xmlns:a16="http://schemas.microsoft.com/office/drawing/2014/main" id="{7D16D2A0-8A52-43F9-B278-9A9F10ECAF60}"/>
+                <a16:creationId xmlns:a16="http://schemas.microsoft.com/office/drawing/2014/main" id="{C466B2A1-D76F-4F1E-A9EA-9EF8B87360D4}"/>
               </a:ext>
             </a:extLst>
           </p:cNvPr>
@@ -3399,7 +3399,7 @@
           <p:cNvPr id="13" name="dp44-implementation-comparison / n13 / text 1">
             <a:extLst xmlns:a="http://schemas.openxmlformats.org/drawingml/2006/main">
               <a:ext uri="{FF2B5EF4-FFF2-40B4-BE49-F238E27FC236}">
-                <a16:creationId xmlns:a16="http://schemas.microsoft.com/office/drawing/2014/main" id="{1066C240-CF35-45AA-99DC-4B0B4C103C32}"/>
+                <a16:creationId xmlns:a16="http://schemas.microsoft.com/office/drawing/2014/main" id="{161A809F-36E4-43BC-BF06-1D19772FBFF6}"/>
               </a:ext>
             </a:extLst>
           </p:cNvPr>
@@ -3468,7 +3468,7 @@
           <p:cNvPr id="14" name="dp44-implementation-comparison / n14">
             <a:extLst xmlns:a="http://schemas.openxmlformats.org/drawingml/2006/main">
               <a:ext uri="{FF2B5EF4-FFF2-40B4-BE49-F238E27FC236}">
-                <a16:creationId xmlns:a16="http://schemas.microsoft.com/office/drawing/2014/main" id="{701FDFD8-76ED-42C4-B168-DB2E364F3215}"/>
+                <a16:creationId xmlns:a16="http://schemas.microsoft.com/office/drawing/2014/main" id="{BA66504E-21F9-4211-AC9F-EAA4227EF29D}"/>
               </a:ext>
             </a:extLst>
           </p:cNvPr>
@@ -3501,7 +3501,7 @@
           <p:cNvPr id="15" name="dp44-implementation-comparison / n15 / text 1">
             <a:extLst xmlns:a="http://schemas.openxmlformats.org/drawingml/2006/main">
               <a:ext uri="{FF2B5EF4-FFF2-40B4-BE49-F238E27FC236}">
-                <a16:creationId xmlns:a16="http://schemas.microsoft.com/office/drawing/2014/main" id="{AF052D5F-784D-4A34-B908-4419459809CF}"/>
+                <a16:creationId xmlns:a16="http://schemas.microsoft.com/office/drawing/2014/main" id="{65881BBC-D4BE-4791-A781-568E1AF3DD3D}"/>
               </a:ext>
             </a:extLst>
           </p:cNvPr>
@@ -3570,7 +3570,7 @@
           <p:cNvPr id="16" name="dp44-implementation-comparison / n16 / text 1">
             <a:extLst xmlns:a="http://schemas.openxmlformats.org/drawingml/2006/main">
               <a:ext uri="{FF2B5EF4-FFF2-40B4-BE49-F238E27FC236}">
-                <a16:creationId xmlns:a16="http://schemas.microsoft.com/office/drawing/2014/main" id="{FB9E26F5-C44B-41BF-89F8-BB1B2E10BC9D}"/>
+                <a16:creationId xmlns:a16="http://schemas.microsoft.com/office/drawing/2014/main" id="{BD6BDDAA-688F-48E6-ACF4-8F315AD7F80A}"/>
               </a:ext>
             </a:extLst>
           </p:cNvPr>
@@ -3639,7 +3639,7 @@
           <p:cNvPr id="17" name="dp44-implementation-comparison / n17">
             <a:extLst xmlns:a="http://schemas.openxmlformats.org/drawingml/2006/main">
               <a:ext uri="{FF2B5EF4-FFF2-40B4-BE49-F238E27FC236}">
-                <a16:creationId xmlns:a16="http://schemas.microsoft.com/office/drawing/2014/main" id="{D39080CF-5D7B-46FA-8673-A31967A8E69F}"/>
+                <a16:creationId xmlns:a16="http://schemas.microsoft.com/office/drawing/2014/main" id="{8F490524-74EB-433E-AC22-F37F04444828}"/>
               </a:ext>
             </a:extLst>
           </p:cNvPr>
@@ -3672,7 +3672,7 @@
           <p:cNvPr id="18" name="dp44-implementation-comparison / n18">
             <a:extLst xmlns:a="http://schemas.openxmlformats.org/drawingml/2006/main">
               <a:ext uri="{FF2B5EF4-FFF2-40B4-BE49-F238E27FC236}">
-                <a16:creationId xmlns:a16="http://schemas.microsoft.com/office/drawing/2014/main" id="{585E7B81-1243-4675-9C62-58AF5DFE6270}"/>
+                <a16:creationId xmlns:a16="http://schemas.microsoft.com/office/drawing/2014/main" id="{6E1CA90A-76FD-4E72-8E99-E12E468B118D}"/>
               </a:ext>
             </a:extLst>
           </p:cNvPr>
@@ -3705,7 +3705,7 @@
           <p:cNvPr id="19" name="dp44-implementation-comparison / n19">
             <a:extLst xmlns:a="http://schemas.openxmlformats.org/drawingml/2006/main">
               <a:ext uri="{FF2B5EF4-FFF2-40B4-BE49-F238E27FC236}">
-                <a16:creationId xmlns:a16="http://schemas.microsoft.com/office/drawing/2014/main" id="{869DE988-EE35-4D0D-93D4-8A25EB82B01B}"/>
+                <a16:creationId xmlns:a16="http://schemas.microsoft.com/office/drawing/2014/main" id="{AF7B1311-EA70-4DCF-9CDD-CB8E95E1E7B8}"/>
               </a:ext>
             </a:extLst>
           </p:cNvPr>
@@ -3738,7 +3738,7 @@
           <p:cNvPr id="20" name="dp44-implementation-comparison / n20">
             <a:extLst xmlns:a="http://schemas.openxmlformats.org/drawingml/2006/main">
               <a:ext uri="{FF2B5EF4-FFF2-40B4-BE49-F238E27FC236}">
-                <a16:creationId xmlns:a16="http://schemas.microsoft.com/office/drawing/2014/main" id="{0D468641-83EF-41AB-BAD5-3CBFEA92A3EF}"/>
+                <a16:creationId xmlns:a16="http://schemas.microsoft.com/office/drawing/2014/main" id="{C208D239-B8D8-446A-A1A8-445448157C1B}"/>
               </a:ext>
             </a:extLst>
           </p:cNvPr>
@@ -3771,7 +3771,7 @@
           <p:cNvPr id="21" name="dp44-implementation-comparison / n21">
             <a:extLst xmlns:a="http://schemas.openxmlformats.org/drawingml/2006/main">
               <a:ext uri="{FF2B5EF4-FFF2-40B4-BE49-F238E27FC236}">
-                <a16:creationId xmlns:a16="http://schemas.microsoft.com/office/drawing/2014/main" id="{F8A64587-024A-4D11-80AB-1237D92217F7}"/>
+                <a16:creationId xmlns:a16="http://schemas.microsoft.com/office/drawing/2014/main" id="{D34A8471-3C76-4705-885C-459AF73051D3}"/>
               </a:ext>
             </a:extLst>
           </p:cNvPr>
@@ -3804,7 +3804,7 @@
           <p:cNvPr id="22" name="dp44-implementation-comparison / n22 / text 1">
             <a:extLst xmlns:a="http://schemas.openxmlformats.org/drawingml/2006/main">
               <a:ext uri="{FF2B5EF4-FFF2-40B4-BE49-F238E27FC236}">
-                <a16:creationId xmlns:a16="http://schemas.microsoft.com/office/drawing/2014/main" id="{7D92F8A6-9E89-4EEC-A344-0A96E99BA813}"/>
+                <a16:creationId xmlns:a16="http://schemas.microsoft.com/office/drawing/2014/main" id="{58A17F71-18B8-4A7A-8DDA-482AE7227674}"/>
               </a:ext>
             </a:extLst>
           </p:cNvPr>
@@ -3873,7 +3873,7 @@
           <p:cNvPr id="23" name="dp44-implementation-comparison / n23 / text 1">
             <a:extLst xmlns:a="http://schemas.openxmlformats.org/drawingml/2006/main">
               <a:ext uri="{FF2B5EF4-FFF2-40B4-BE49-F238E27FC236}">
-                <a16:creationId xmlns:a16="http://schemas.microsoft.com/office/drawing/2014/main" id="{D593FEBE-873A-4D18-B66A-E14853EE79F6}"/>
+                <a16:creationId xmlns:a16="http://schemas.microsoft.com/office/drawing/2014/main" id="{E70D0DAF-A231-4CCA-B5E9-DE9E08EF450C}"/>
               </a:ext>
             </a:extLst>
           </p:cNvPr>
@@ -3942,7 +3942,7 @@
           <p:cNvPr id="24" name="dp44-implementation-comparison / n24">
             <a:extLst xmlns:a="http://schemas.openxmlformats.org/drawingml/2006/main">
               <a:ext uri="{FF2B5EF4-FFF2-40B4-BE49-F238E27FC236}">
-                <a16:creationId xmlns:a16="http://schemas.microsoft.com/office/drawing/2014/main" id="{6A9BBA31-1179-4C51-B4D7-016B54D7DB5D}"/>
+                <a16:creationId xmlns:a16="http://schemas.microsoft.com/office/drawing/2014/main" id="{36FBC991-0313-4CB7-92F6-84152F771879}"/>
               </a:ext>
             </a:extLst>
           </p:cNvPr>
@@ -3975,7 +3975,7 @@
           <p:cNvPr id="25" name="dp44-implementation-comparison / n25">
             <a:extLst xmlns:a="http://schemas.openxmlformats.org/drawingml/2006/main">
               <a:ext uri="{FF2B5EF4-FFF2-40B4-BE49-F238E27FC236}">
-                <a16:creationId xmlns:a16="http://schemas.microsoft.com/office/drawing/2014/main" id="{FD4534D8-8688-47D6-9B4D-8D3B43DC250E}"/>
+                <a16:creationId xmlns:a16="http://schemas.microsoft.com/office/drawing/2014/main" id="{A63C553D-C679-4718-AE2E-64D4111CBAB3}"/>
               </a:ext>
             </a:extLst>
           </p:cNvPr>
@@ -4008,7 +4008,7 @@
           <p:cNvPr id="26" name="dp44-implementation-comparison / n26">
             <a:extLst xmlns:a="http://schemas.openxmlformats.org/drawingml/2006/main">
               <a:ext uri="{FF2B5EF4-FFF2-40B4-BE49-F238E27FC236}">
-                <a16:creationId xmlns:a16="http://schemas.microsoft.com/office/drawing/2014/main" id="{CD4C62F5-2204-4D68-82AD-134ADEA6F390}"/>
+                <a16:creationId xmlns:a16="http://schemas.microsoft.com/office/drawing/2014/main" id="{E0667D8F-ECCC-4D70-BF4B-3A2B5469EB42}"/>
               </a:ext>
             </a:extLst>
           </p:cNvPr>
@@ -4041,7 +4041,7 @@
           <p:cNvPr id="27" name="dp44-implementation-comparison / n27">
             <a:extLst xmlns:a="http://schemas.openxmlformats.org/drawingml/2006/main">
               <a:ext uri="{FF2B5EF4-FFF2-40B4-BE49-F238E27FC236}">
-                <a16:creationId xmlns:a16="http://schemas.microsoft.com/office/drawing/2014/main" id="{8099ED28-6BAE-4DF5-BC6D-E4DB7465BDBF}"/>
+                <a16:creationId xmlns:a16="http://schemas.microsoft.com/office/drawing/2014/main" id="{61A2E153-397C-49F7-885A-123499BC2F40}"/>
               </a:ext>
             </a:extLst>
           </p:cNvPr>
@@ -4074,7 +4074,7 @@
           <p:cNvPr id="28" name="dp44-implementation-comparison / n28 / path">
             <a:extLst xmlns:a="http://schemas.openxmlformats.org/drawingml/2006/main">
               <a:ext uri="{FF2B5EF4-FFF2-40B4-BE49-F238E27FC236}">
-                <a16:creationId xmlns:a16="http://schemas.microsoft.com/office/drawing/2014/main" id="{6E98BFAD-0355-448D-ACD7-B81AF797D6EE}"/>
+                <a16:creationId xmlns:a16="http://schemas.microsoft.com/office/drawing/2014/main" id="{0341591C-3D2E-445A-9CBC-266F3922A811}"/>
               </a:ext>
             </a:extLst>
           </p:cNvPr>
@@ -4117,7 +4117,7 @@
           <p:cNvPr id="29" name="dp44-implementation-comparison / n28 / arrow">
             <a:extLst xmlns:a="http://schemas.openxmlformats.org/drawingml/2006/main">
               <a:ext uri="{FF2B5EF4-FFF2-40B4-BE49-F238E27FC236}">
-                <a16:creationId xmlns:a16="http://schemas.microsoft.com/office/drawing/2014/main" id="{90B68A75-5A73-46D7-956B-BAEC4A6D760F}"/>
+                <a16:creationId xmlns:a16="http://schemas.microsoft.com/office/drawing/2014/main" id="{8B3398E3-A53F-493C-9045-FF8F21F94090}"/>
               </a:ext>
             </a:extLst>
           </p:cNvPr>
@@ -4160,7 +4160,7 @@
           <p:cNvPr id="30" name="dp44-implementation-comparison / n29">
             <a:extLst xmlns:a="http://schemas.openxmlformats.org/drawingml/2006/main">
               <a:ext uri="{FF2B5EF4-FFF2-40B4-BE49-F238E27FC236}">
-                <a16:creationId xmlns:a16="http://schemas.microsoft.com/office/drawing/2014/main" id="{4EC2065A-93EE-4472-B79A-DEA50B45C417}"/>
+                <a16:creationId xmlns:a16="http://schemas.microsoft.com/office/drawing/2014/main" id="{DABA8EB0-ECC2-4EFE-BEC3-7D76AB0AC844}"/>
               </a:ext>
             </a:extLst>
           </p:cNvPr>
@@ -4193,7 +4193,7 @@
           <p:cNvPr id="31" name="dp44-implementation-comparison / n30 / text 1">
             <a:extLst xmlns:a="http://schemas.openxmlformats.org/drawingml/2006/main">
               <a:ext uri="{FF2B5EF4-FFF2-40B4-BE49-F238E27FC236}">
-                <a16:creationId xmlns:a16="http://schemas.microsoft.com/office/drawing/2014/main" id="{1883217E-9EFB-4857-B1BA-D9FA39681977}"/>
+                <a16:creationId xmlns:a16="http://schemas.microsoft.com/office/drawing/2014/main" id="{0BD478FB-EC02-4727-893F-3A2564F3855A}"/>
               </a:ext>
             </a:extLst>
           </p:cNvPr>
@@ -4262,7 +4262,7 @@
           <p:cNvPr id="32" name="dp44-implementation-comparison / n31 / text 1">
             <a:extLst xmlns:a="http://schemas.openxmlformats.org/drawingml/2006/main">
               <a:ext uri="{FF2B5EF4-FFF2-40B4-BE49-F238E27FC236}">
-                <a16:creationId xmlns:a16="http://schemas.microsoft.com/office/drawing/2014/main" id="{F9DD8635-0C0D-460E-9C16-2F02EBE7D82A}"/>
+                <a16:creationId xmlns:a16="http://schemas.microsoft.com/office/drawing/2014/main" id="{55E8434A-1F23-4533-9A88-00835489837D}"/>
               </a:ext>
             </a:extLst>
           </p:cNvPr>
@@ -4331,7 +4331,7 @@
           <p:cNvPr id="33" name="dp44-implementation-comparison / n32">
             <a:extLst xmlns:a="http://schemas.openxmlformats.org/drawingml/2006/main">
               <a:ext uri="{FF2B5EF4-FFF2-40B4-BE49-F238E27FC236}">
-                <a16:creationId xmlns:a16="http://schemas.microsoft.com/office/drawing/2014/main" id="{DADAB15C-EB36-43AC-9931-F2AAB0ABC47D}"/>
+                <a16:creationId xmlns:a16="http://schemas.microsoft.com/office/drawing/2014/main" id="{4B0C5E67-2545-4254-AB4F-EC5038D240C2}"/>
               </a:ext>
             </a:extLst>
           </p:cNvPr>
@@ -4364,7 +4364,7 @@
           <p:cNvPr id="34" name="dp44-implementation-comparison / n33 / text 1">
             <a:extLst xmlns:a="http://schemas.openxmlformats.org/drawingml/2006/main">
               <a:ext uri="{FF2B5EF4-FFF2-40B4-BE49-F238E27FC236}">
-                <a16:creationId xmlns:a16="http://schemas.microsoft.com/office/drawing/2014/main" id="{58FC07B7-3BBB-4D17-8010-2F507D44B0BB}"/>
+                <a16:creationId xmlns:a16="http://schemas.microsoft.com/office/drawing/2014/main" id="{3DA3852B-27D5-4B18-859B-2FABB3774696}"/>
               </a:ext>
             </a:extLst>
           </p:cNvPr>
@@ -4433,7 +4433,7 @@
           <p:cNvPr id="35" name="dp44-implementation-comparison / n34">
             <a:extLst xmlns:a="http://schemas.openxmlformats.org/drawingml/2006/main">
               <a:ext uri="{FF2B5EF4-FFF2-40B4-BE49-F238E27FC236}">
-                <a16:creationId xmlns:a16="http://schemas.microsoft.com/office/drawing/2014/main" id="{B3FB760C-EBE1-4116-B0F6-E31CE26DACC1}"/>
+                <a16:creationId xmlns:a16="http://schemas.microsoft.com/office/drawing/2014/main" id="{A07F894D-BD60-4158-A280-377C8ED7554E}"/>
               </a:ext>
             </a:extLst>
           </p:cNvPr>
@@ -4466,7 +4466,7 @@
           <p:cNvPr id="36" name="dp44-implementation-comparison / n35 / text 1">
             <a:extLst xmlns:a="http://schemas.openxmlformats.org/drawingml/2006/main">
               <a:ext uri="{FF2B5EF4-FFF2-40B4-BE49-F238E27FC236}">
-                <a16:creationId xmlns:a16="http://schemas.microsoft.com/office/drawing/2014/main" id="{07C10AB4-8565-47A3-9E3C-9CA51CD4BDC5}"/>
+                <a16:creationId xmlns:a16="http://schemas.microsoft.com/office/drawing/2014/main" id="{04770FDE-E8CC-4523-A550-B92E66B8B835}"/>
               </a:ext>
             </a:extLst>
           </p:cNvPr>
@@ -4535,7 +4535,7 @@
           <p:cNvPr id="37" name="dp44-implementation-comparison / n36 / path">
             <a:extLst xmlns:a="http://schemas.openxmlformats.org/drawingml/2006/main">
               <a:ext uri="{FF2B5EF4-FFF2-40B4-BE49-F238E27FC236}">
-                <a16:creationId xmlns:a16="http://schemas.microsoft.com/office/drawing/2014/main" id="{78A7BE55-4806-4F40-BCDD-2688B09D4793}"/>
+                <a16:creationId xmlns:a16="http://schemas.microsoft.com/office/drawing/2014/main" id="{158F5A4A-00CE-46EA-84F8-FC80DB4CCBF3}"/>
               </a:ext>
             </a:extLst>
           </p:cNvPr>
@@ -4581,7 +4581,7 @@
           <p:cNvPr id="38" name="dp44-implementation-comparison / n36 / arrow">
             <a:extLst xmlns:a="http://schemas.openxmlformats.org/drawingml/2006/main">
               <a:ext uri="{FF2B5EF4-FFF2-40B4-BE49-F238E27FC236}">
-                <a16:creationId xmlns:a16="http://schemas.microsoft.com/office/drawing/2014/main" id="{085730CB-EFE3-4D6C-8C8E-133B1DE00537}"/>
+                <a16:creationId xmlns:a16="http://schemas.microsoft.com/office/drawing/2014/main" id="{5E3156BC-2304-47EA-8745-B1EBEE6B6FDA}"/>
               </a:ext>
             </a:extLst>
           </p:cNvPr>
@@ -4624,7 +4624,7 @@
           <p:cNvPr id="39" name="dp44-implementation-comparison / n37 / path">
             <a:extLst xmlns:a="http://schemas.openxmlformats.org/drawingml/2006/main">
               <a:ext uri="{FF2B5EF4-FFF2-40B4-BE49-F238E27FC236}">
-                <a16:creationId xmlns:a16="http://schemas.microsoft.com/office/drawing/2014/main" id="{7EB37862-3D7F-405D-9E66-7BB29C5FA9CA}"/>
+                <a16:creationId xmlns:a16="http://schemas.microsoft.com/office/drawing/2014/main" id="{47E11408-7B6C-4790-B5EA-8B7D9135E2C9}"/>
               </a:ext>
             </a:extLst>
           </p:cNvPr>
@@ -4670,7 +4670,7 @@
           <p:cNvPr id="40" name="dp44-implementation-comparison / n37 / arrow">
             <a:extLst xmlns:a="http://schemas.openxmlformats.org/drawingml/2006/main">
               <a:ext uri="{FF2B5EF4-FFF2-40B4-BE49-F238E27FC236}">
-                <a16:creationId xmlns:a16="http://schemas.microsoft.com/office/drawing/2014/main" id="{A243E8CD-8DCF-4CE5-BECC-6BBADC0015DA}"/>
+                <a16:creationId xmlns:a16="http://schemas.microsoft.com/office/drawing/2014/main" id="{58B639B4-E4AA-48AB-92FC-407B1018DA71}"/>
               </a:ext>
             </a:extLst>
           </p:cNvPr>
@@ -4713,7 +4713,7 @@
           <p:cNvPr id="41" name="dp44-implementation-comparison / n38 / path">
             <a:extLst xmlns:a="http://schemas.openxmlformats.org/drawingml/2006/main">
               <a:ext uri="{FF2B5EF4-FFF2-40B4-BE49-F238E27FC236}">
-                <a16:creationId xmlns:a16="http://schemas.microsoft.com/office/drawing/2014/main" id="{F359D078-127D-4D56-A364-59ECED9FDB2B}"/>
+                <a16:creationId xmlns:a16="http://schemas.microsoft.com/office/drawing/2014/main" id="{C6E231F5-B9F5-4188-A28D-9899C3208D63}"/>
               </a:ext>
             </a:extLst>
           </p:cNvPr>
@@ -4759,7 +4759,7 @@
           <p:cNvPr id="42" name="dp44-implementation-comparison / n38 / arrow">
             <a:extLst xmlns:a="http://schemas.openxmlformats.org/drawingml/2006/main">
               <a:ext uri="{FF2B5EF4-FFF2-40B4-BE49-F238E27FC236}">
-                <a16:creationId xmlns:a16="http://schemas.microsoft.com/office/drawing/2014/main" id="{0D9FCFBD-C636-46DA-8CDD-28F570F8CD63}"/>
+                <a16:creationId xmlns:a16="http://schemas.microsoft.com/office/drawing/2014/main" id="{55FA3232-D016-406E-8A79-8B397C0BEE9E}"/>
               </a:ext>
             </a:extLst>
           </p:cNvPr>
@@ -4802,7 +4802,7 @@
           <p:cNvPr id="43" name="dp44-implementation-comparison / n39 / path">
             <a:extLst xmlns:a="http://schemas.openxmlformats.org/drawingml/2006/main">
               <a:ext uri="{FF2B5EF4-FFF2-40B4-BE49-F238E27FC236}">
-                <a16:creationId xmlns:a16="http://schemas.microsoft.com/office/drawing/2014/main" id="{8EF358B1-D599-436A-84DE-91FD357D08D7}"/>
+                <a16:creationId xmlns:a16="http://schemas.microsoft.com/office/drawing/2014/main" id="{7628A4FE-3BC9-4F86-9579-4AB3B8D966D8}"/>
               </a:ext>
             </a:extLst>
           </p:cNvPr>
@@ -4848,7 +4848,7 @@
           <p:cNvPr id="44" name="dp44-implementation-comparison / n39 / arrow">
             <a:extLst xmlns:a="http://schemas.openxmlformats.org/drawingml/2006/main">
               <a:ext uri="{FF2B5EF4-FFF2-40B4-BE49-F238E27FC236}">
-                <a16:creationId xmlns:a16="http://schemas.microsoft.com/office/drawing/2014/main" id="{FE5B5B61-948F-4341-AD98-EBD0CB9346E4}"/>
+                <a16:creationId xmlns:a16="http://schemas.microsoft.com/office/drawing/2014/main" id="{F23F2AD1-25B4-4D49-A290-B1692D5E7E91}"/>
               </a:ext>
             </a:extLst>
           </p:cNvPr>
@@ -4891,7 +4891,7 @@
           <p:cNvPr id="45" name="dp44-implementation-comparison / n40 / path">
             <a:extLst xmlns:a="http://schemas.openxmlformats.org/drawingml/2006/main">
               <a:ext uri="{FF2B5EF4-FFF2-40B4-BE49-F238E27FC236}">
-                <a16:creationId xmlns:a16="http://schemas.microsoft.com/office/drawing/2014/main" id="{D0361F48-02B0-4EC7-BB38-3E8210B8674B}"/>
+                <a16:creationId xmlns:a16="http://schemas.microsoft.com/office/drawing/2014/main" id="{335B905B-CCCE-4589-A3B9-D025CA111D78}"/>
               </a:ext>
             </a:extLst>
           </p:cNvPr>
@@ -4931,7 +4931,7 @@
           <p:cNvPr id="46" name="dp44-implementation-comparison / n40 / arrow">
             <a:extLst xmlns:a="http://schemas.openxmlformats.org/drawingml/2006/main">
               <a:ext uri="{FF2B5EF4-FFF2-40B4-BE49-F238E27FC236}">
-                <a16:creationId xmlns:a16="http://schemas.microsoft.com/office/drawing/2014/main" id="{75334D72-13E5-4281-8857-D219B78C4C74}"/>
+                <a16:creationId xmlns:a16="http://schemas.microsoft.com/office/drawing/2014/main" id="{B4FE825B-11D4-4096-A139-4400908E2299}"/>
               </a:ext>
             </a:extLst>
           </p:cNvPr>
@@ -4974,7 +4974,7 @@
           <p:cNvPr id="47" name="dp44-implementation-comparison / n41">
             <a:extLst xmlns:a="http://schemas.openxmlformats.org/drawingml/2006/main">
               <a:ext uri="{FF2B5EF4-FFF2-40B4-BE49-F238E27FC236}">
-                <a16:creationId xmlns:a16="http://schemas.microsoft.com/office/drawing/2014/main" id="{97F1D978-7F21-4182-BE43-1C1E333CA71C}"/>
+                <a16:creationId xmlns:a16="http://schemas.microsoft.com/office/drawing/2014/main" id="{8612BA0D-93FC-4B0D-9AC7-5D2F7404CCB2}"/>
               </a:ext>
             </a:extLst>
           </p:cNvPr>
@@ -5007,7 +5007,7 @@
           <p:cNvPr id="48" name="dp44-implementation-comparison / n42 / text 1">
             <a:extLst xmlns:a="http://schemas.openxmlformats.org/drawingml/2006/main">
               <a:ext uri="{FF2B5EF4-FFF2-40B4-BE49-F238E27FC236}">
-                <a16:creationId xmlns:a16="http://schemas.microsoft.com/office/drawing/2014/main" id="{520C9F6B-DDE2-44A5-9626-3C7B21B83BC4}"/>
+                <a16:creationId xmlns:a16="http://schemas.microsoft.com/office/drawing/2014/main" id="{B26BCFBA-E01B-43BC-8243-EB80B3D89792}"/>
               </a:ext>
             </a:extLst>
           </p:cNvPr>
@@ -5076,7 +5076,7 @@
           <p:cNvPr id="49" name="dp44-implementation-comparison / n43 / text 1">
             <a:extLst xmlns:a="http://schemas.openxmlformats.org/drawingml/2006/main">
               <a:ext uri="{FF2B5EF4-FFF2-40B4-BE49-F238E27FC236}">
-                <a16:creationId xmlns:a16="http://schemas.microsoft.com/office/drawing/2014/main" id="{2A930ECF-E2A9-4914-8824-B6400386DC36}"/>
+                <a16:creationId xmlns:a16="http://schemas.microsoft.com/office/drawing/2014/main" id="{2F07E54A-D8D3-40F6-ABBC-B91E9505171F}"/>
               </a:ext>
             </a:extLst>
           </p:cNvPr>
@@ -5145,7 +5145,7 @@
           <p:cNvPr id="50" name="dp44-implementation-comparison / n44">
             <a:extLst xmlns:a="http://schemas.openxmlformats.org/drawingml/2006/main">
               <a:ext uri="{FF2B5EF4-FFF2-40B4-BE49-F238E27FC236}">
-                <a16:creationId xmlns:a16="http://schemas.microsoft.com/office/drawing/2014/main" id="{84301A9F-E277-4AF2-B529-C363AF6974A9}"/>
+                <a16:creationId xmlns:a16="http://schemas.microsoft.com/office/drawing/2014/main" id="{1897DFA0-1D2F-4D99-9696-1640D8A45194}"/>
               </a:ext>
             </a:extLst>
           </p:cNvPr>
@@ -5178,7 +5178,7 @@
           <p:cNvPr id="51" name="dp44-implementation-comparison / n45 / text 1">
             <a:extLst xmlns:a="http://schemas.openxmlformats.org/drawingml/2006/main">
               <a:ext uri="{FF2B5EF4-FFF2-40B4-BE49-F238E27FC236}">
-                <a16:creationId xmlns:a16="http://schemas.microsoft.com/office/drawing/2014/main" id="{E56673CF-7BC4-424A-8B0C-29C6BB888AAF}"/>
+                <a16:creationId xmlns:a16="http://schemas.microsoft.com/office/drawing/2014/main" id="{3F992009-6C64-4B5C-848A-9B7188742783}"/>
               </a:ext>
             </a:extLst>
           </p:cNvPr>
@@ -5247,7 +5247,7 @@
           <p:cNvPr id="52" name="dp44-implementation-comparison / n46">
             <a:extLst xmlns:a="http://schemas.openxmlformats.org/drawingml/2006/main">
               <a:ext uri="{FF2B5EF4-FFF2-40B4-BE49-F238E27FC236}">
-                <a16:creationId xmlns:a16="http://schemas.microsoft.com/office/drawing/2014/main" id="{CC65D97F-337F-4D49-B719-DF0DB99518A3}"/>
+                <a16:creationId xmlns:a16="http://schemas.microsoft.com/office/drawing/2014/main" id="{CB079C86-E96B-4186-B49C-4C309360566E}"/>
               </a:ext>
             </a:extLst>
           </p:cNvPr>
@@ -5280,7 +5280,7 @@
           <p:cNvPr id="53" name="dp44-implementation-comparison / n47 / text 1">
             <a:extLst xmlns:a="http://schemas.openxmlformats.org/drawingml/2006/main">
               <a:ext uri="{FF2B5EF4-FFF2-40B4-BE49-F238E27FC236}">
-                <a16:creationId xmlns:a16="http://schemas.microsoft.com/office/drawing/2014/main" id="{35717A64-2CBF-4DA0-8B3B-806B3FCDFAD9}"/>
+                <a16:creationId xmlns:a16="http://schemas.microsoft.com/office/drawing/2014/main" id="{450CFDE1-BF78-483A-BC74-4867CC0E9A8D}"/>
               </a:ext>
             </a:extLst>
           </p:cNvPr>
@@ -5349,7 +5349,7 @@
           <p:cNvPr id="54" name="dp44-implementation-comparison / n48 / text 1">
             <a:extLst xmlns:a="http://schemas.openxmlformats.org/drawingml/2006/main">
               <a:ext uri="{FF2B5EF4-FFF2-40B4-BE49-F238E27FC236}">
-                <a16:creationId xmlns:a16="http://schemas.microsoft.com/office/drawing/2014/main" id="{50AE3D64-0F5E-499B-8C82-7DD9C6602840}"/>
+                <a16:creationId xmlns:a16="http://schemas.microsoft.com/office/drawing/2014/main" id="{E9A078D1-5885-450A-844E-A328436EC32F}"/>
               </a:ext>
             </a:extLst>
           </p:cNvPr>
@@ -5418,7 +5418,7 @@
           <p:cNvPr id="55" name="dp44-implementation-comparison / n49">
             <a:extLst xmlns:a="http://schemas.openxmlformats.org/drawingml/2006/main">
               <a:ext uri="{FF2B5EF4-FFF2-40B4-BE49-F238E27FC236}">
-                <a16:creationId xmlns:a16="http://schemas.microsoft.com/office/drawing/2014/main" id="{9EF9EDEF-FEA9-4630-9B3C-B4FF8528FE9E}"/>
+                <a16:creationId xmlns:a16="http://schemas.microsoft.com/office/drawing/2014/main" id="{EA9536E6-1006-416B-AEE0-BDC303C5EAA4}"/>
               </a:ext>
             </a:extLst>
           </p:cNvPr>
@@ -5451,7 +5451,7 @@
           <p:cNvPr id="56" name="dp44-implementation-comparison / n50 / text 1">
             <a:extLst xmlns:a="http://schemas.openxmlformats.org/drawingml/2006/main">
               <a:ext uri="{FF2B5EF4-FFF2-40B4-BE49-F238E27FC236}">
-                <a16:creationId xmlns:a16="http://schemas.microsoft.com/office/drawing/2014/main" id="{87109649-59C1-4A46-B526-B3F27D51D627}"/>
+                <a16:creationId xmlns:a16="http://schemas.microsoft.com/office/drawing/2014/main" id="{4C1926F2-BABD-41F6-B993-60190E23EE3B}"/>
               </a:ext>
             </a:extLst>
           </p:cNvPr>
@@ -5520,7 +5520,7 @@
           <p:cNvPr id="57" name="dp44-implementation-comparison / n51 / text 1">
             <a:extLst xmlns:a="http://schemas.openxmlformats.org/drawingml/2006/main">
               <a:ext uri="{FF2B5EF4-FFF2-40B4-BE49-F238E27FC236}">
-                <a16:creationId xmlns:a16="http://schemas.microsoft.com/office/drawing/2014/main" id="{61B7F484-6F34-47EE-A24D-051B08985B07}"/>
+                <a16:creationId xmlns:a16="http://schemas.microsoft.com/office/drawing/2014/main" id="{D8CDA048-7527-44E9-825D-475CA4787D2A}"/>
               </a:ext>
             </a:extLst>
           </p:cNvPr>
@@ -5589,7 +5589,7 @@
           <p:cNvPr id="58" name="dp44-implementation-comparison / n52 / path">
             <a:extLst xmlns:a="http://schemas.openxmlformats.org/drawingml/2006/main">
               <a:ext uri="{FF2B5EF4-FFF2-40B4-BE49-F238E27FC236}">
-                <a16:creationId xmlns:a16="http://schemas.microsoft.com/office/drawing/2014/main" id="{E517C5C7-5292-4FF2-8EBB-62CB8F27EFCE}"/>
+                <a16:creationId xmlns:a16="http://schemas.microsoft.com/office/drawing/2014/main" id="{72F1D658-D5EF-4646-A890-29FD263FB90E}"/>
               </a:ext>
             </a:extLst>
           </p:cNvPr>
@@ -5638,7 +5638,7 @@
           <p:cNvPr id="59" name="dp44-implementation-comparison / n52 / arrow">
             <a:extLst xmlns:a="http://schemas.openxmlformats.org/drawingml/2006/main">
               <a:ext uri="{FF2B5EF4-FFF2-40B4-BE49-F238E27FC236}">
-                <a16:creationId xmlns:a16="http://schemas.microsoft.com/office/drawing/2014/main" id="{EFDDB487-45BF-4B56-8DFE-0D97E46C3B5A}"/>
+                <a16:creationId xmlns:a16="http://schemas.microsoft.com/office/drawing/2014/main" id="{27CC6E90-020E-4452-A632-01CAD1E7A7DE}"/>
               </a:ext>
             </a:extLst>
           </p:cNvPr>
@@ -5681,7 +5681,7 @@
           <p:cNvPr id="60" name="dp44-implementation-comparison / n53 / path">
             <a:extLst xmlns:a="http://schemas.openxmlformats.org/drawingml/2006/main">
               <a:ext uri="{FF2B5EF4-FFF2-40B4-BE49-F238E27FC236}">
-                <a16:creationId xmlns:a16="http://schemas.microsoft.com/office/drawing/2014/main" id="{7D2FCEDF-8308-47BF-9B71-488A7949A8AB}"/>
+                <a16:creationId xmlns:a16="http://schemas.microsoft.com/office/drawing/2014/main" id="{E33C7163-C295-4805-9EE8-6032D2BD4A1A}"/>
               </a:ext>
             </a:extLst>
           </p:cNvPr>
@@ -5727,7 +5727,7 @@
           <p:cNvPr id="61" name="dp44-implementation-comparison / n53 / arrow">
             <a:extLst xmlns:a="http://schemas.openxmlformats.org/drawingml/2006/main">
               <a:ext uri="{FF2B5EF4-FFF2-40B4-BE49-F238E27FC236}">
-                <a16:creationId xmlns:a16="http://schemas.microsoft.com/office/drawing/2014/main" id="{7CBC3BDF-76C9-46B2-9F9B-D1E81265B700}"/>
+                <a16:creationId xmlns:a16="http://schemas.microsoft.com/office/drawing/2014/main" id="{44B6CD6B-A8FC-47EE-B396-7D0525CA26E5}"/>
               </a:ext>
             </a:extLst>
           </p:cNvPr>
@@ -5770,7 +5770,7 @@
           <p:cNvPr id="62" name="dp44-implementation-comparison / n54 / path">
             <a:extLst xmlns:a="http://schemas.openxmlformats.org/drawingml/2006/main">
               <a:ext uri="{FF2B5EF4-FFF2-40B4-BE49-F238E27FC236}">
-                <a16:creationId xmlns:a16="http://schemas.microsoft.com/office/drawing/2014/main" id="{D8F1EFDD-3789-44A9-9622-5421D87CB3EE}"/>
+                <a16:creationId xmlns:a16="http://schemas.microsoft.com/office/drawing/2014/main" id="{C3EEDE61-6160-479F-A7E6-8732C91321C2}"/>
               </a:ext>
             </a:extLst>
           </p:cNvPr>
@@ -5819,7 +5819,7 @@
           <p:cNvPr id="63" name="dp44-implementation-comparison / n54 / arrow">
             <a:extLst xmlns:a="http://schemas.openxmlformats.org/drawingml/2006/main">
               <a:ext uri="{FF2B5EF4-FFF2-40B4-BE49-F238E27FC236}">
-                <a16:creationId xmlns:a16="http://schemas.microsoft.com/office/drawing/2014/main" id="{281B9D58-FDB7-44FA-BDEA-8BF7629D7C54}"/>
+                <a16:creationId xmlns:a16="http://schemas.microsoft.com/office/drawing/2014/main" id="{36CECD2E-E74B-47BD-A5C6-99E79BFFB682}"/>
               </a:ext>
             </a:extLst>
           </p:cNvPr>
@@ -5862,7 +5862,7 @@
           <p:cNvPr id="64" name="dp44-implementation-comparison / n55 / path">
             <a:extLst xmlns:a="http://schemas.openxmlformats.org/drawingml/2006/main">
               <a:ext uri="{FF2B5EF4-FFF2-40B4-BE49-F238E27FC236}">
-                <a16:creationId xmlns:a16="http://schemas.microsoft.com/office/drawing/2014/main" id="{84FBE2B9-198A-4FCC-97DF-7CCEA95026BF}"/>
+                <a16:creationId xmlns:a16="http://schemas.microsoft.com/office/drawing/2014/main" id="{DCEEAF66-191A-4E7E-80B7-9911044E96F2}"/>
               </a:ext>
             </a:extLst>
           </p:cNvPr>
@@ -5914,7 +5914,7 @@
           <p:cNvPr id="65" name="dp44-implementation-comparison / n55 / arrow">
             <a:extLst xmlns:a="http://schemas.openxmlformats.org/drawingml/2006/main">
               <a:ext uri="{FF2B5EF4-FFF2-40B4-BE49-F238E27FC236}">
-                <a16:creationId xmlns:a16="http://schemas.microsoft.com/office/drawing/2014/main" id="{1A7EA737-A067-4EE4-85C5-BB68BAB32308}"/>
+                <a16:creationId xmlns:a16="http://schemas.microsoft.com/office/drawing/2014/main" id="{EBB70164-4264-48FC-9A98-80CBE1A479EC}"/>
               </a:ext>
             </a:extLst>
           </p:cNvPr>
@@ -5957,7 +5957,7 @@
           <p:cNvPr id="66" name="dp44-implementation-comparison / n56 / path">
             <a:extLst xmlns:a="http://schemas.openxmlformats.org/drawingml/2006/main">
               <a:ext uri="{FF2B5EF4-FFF2-40B4-BE49-F238E27FC236}">
-                <a16:creationId xmlns:a16="http://schemas.microsoft.com/office/drawing/2014/main" id="{4FB8BECF-AAA3-4109-8CA6-837480B72549}"/>
+                <a16:creationId xmlns:a16="http://schemas.microsoft.com/office/drawing/2014/main" id="{55780E26-7F5C-4B0C-8136-972ADB0D2D75}"/>
               </a:ext>
             </a:extLst>
           </p:cNvPr>
@@ -6015,7 +6015,7 @@
           <p:cNvPr id="67" name="dp44-implementation-comparison / n56 / arrow">
             <a:extLst xmlns:a="http://schemas.openxmlformats.org/drawingml/2006/main">
               <a:ext uri="{FF2B5EF4-FFF2-40B4-BE49-F238E27FC236}">
-                <a16:creationId xmlns:a16="http://schemas.microsoft.com/office/drawing/2014/main" id="{59A87F5A-87B6-4997-982B-AF436DDC8930}"/>
+                <a16:creationId xmlns:a16="http://schemas.microsoft.com/office/drawing/2014/main" id="{50401EED-88B4-4C64-9763-0B437268DD6D}"/>
               </a:ext>
             </a:extLst>
           </p:cNvPr>
@@ -6058,7 +6058,7 @@
           <p:cNvPr id="68" name="dp44-implementation-comparison / n57 / text 1">
             <a:extLst xmlns:a="http://schemas.openxmlformats.org/drawingml/2006/main">
               <a:ext uri="{FF2B5EF4-FFF2-40B4-BE49-F238E27FC236}">
-                <a16:creationId xmlns:a16="http://schemas.microsoft.com/office/drawing/2014/main" id="{A7D0858A-C8C7-48CD-A44B-A77F334368EA}"/>
+                <a16:creationId xmlns:a16="http://schemas.microsoft.com/office/drawing/2014/main" id="{E473620D-3B7A-4C64-8B29-48DA1C110928}"/>
               </a:ext>
             </a:extLst>
           </p:cNvPr>
@@ -6127,7 +6127,7 @@
           <p:cNvPr id="69" name="dp44-implementation-comparison / n58 / text 1">
             <a:extLst xmlns:a="http://schemas.openxmlformats.org/drawingml/2006/main">
               <a:ext uri="{FF2B5EF4-FFF2-40B4-BE49-F238E27FC236}">
-                <a16:creationId xmlns:a16="http://schemas.microsoft.com/office/drawing/2014/main" id="{26EA5D81-2022-49A1-B199-2BF57F8102D3}"/>
+                <a16:creationId xmlns:a16="http://schemas.microsoft.com/office/drawing/2014/main" id="{677CE3AA-1DDC-44E6-B868-E8E1D6BEF5AA}"/>
               </a:ext>
             </a:extLst>
           </p:cNvPr>
@@ -6196,7 +6196,7 @@
           <p:cNvPr id="70" name="dp44-implementation-comparison / n59">
             <a:extLst xmlns:a="http://schemas.openxmlformats.org/drawingml/2006/main">
               <a:ext uri="{FF2B5EF4-FFF2-40B4-BE49-F238E27FC236}">
-                <a16:creationId xmlns:a16="http://schemas.microsoft.com/office/drawing/2014/main" id="{5C61AEFE-ACB9-4B13-897B-00BFFF73B755}"/>
+                <a16:creationId xmlns:a16="http://schemas.microsoft.com/office/drawing/2014/main" id="{CB3DA4D8-00FA-4257-B560-07C5AD2509B9}"/>
               </a:ext>
             </a:extLst>
           </p:cNvPr>
@@ -6229,7 +6229,7 @@
           <p:cNvPr id="71" name="dp44-implementation-comparison / n60 / text 1">
             <a:extLst xmlns:a="http://schemas.openxmlformats.org/drawingml/2006/main">
               <a:ext uri="{FF2B5EF4-FFF2-40B4-BE49-F238E27FC236}">
-                <a16:creationId xmlns:a16="http://schemas.microsoft.com/office/drawing/2014/main" id="{E056931C-2D0C-4123-BCA3-E1C4C23D5982}"/>
+                <a16:creationId xmlns:a16="http://schemas.microsoft.com/office/drawing/2014/main" id="{9F1F438C-244A-46A0-9686-3F33425D7B10}"/>
               </a:ext>
             </a:extLst>
           </p:cNvPr>
@@ -6298,7 +6298,7 @@
           <p:cNvPr id="72" name="dp44-implementation-comparison / n61 / text 1">
             <a:extLst xmlns:a="http://schemas.openxmlformats.org/drawingml/2006/main">
               <a:ext uri="{FF2B5EF4-FFF2-40B4-BE49-F238E27FC236}">
-                <a16:creationId xmlns:a16="http://schemas.microsoft.com/office/drawing/2014/main" id="{81428E15-F2B4-4737-AD53-F7AC0D705DEE}"/>
+                <a16:creationId xmlns:a16="http://schemas.microsoft.com/office/drawing/2014/main" id="{BA780781-5BB2-4D69-8B32-66A7FB0F5222}"/>
               </a:ext>
             </a:extLst>
           </p:cNvPr>
@@ -6367,7 +6367,7 @@
           <p:cNvPr id="73" name="dp44-implementation-comparison / n62 / path">
             <a:extLst xmlns:a="http://schemas.openxmlformats.org/drawingml/2006/main">
               <a:ext uri="{FF2B5EF4-FFF2-40B4-BE49-F238E27FC236}">
-                <a16:creationId xmlns:a16="http://schemas.microsoft.com/office/drawing/2014/main" id="{F39B1665-4850-446C-B54C-2F1D2FB8464C}"/>
+                <a16:creationId xmlns:a16="http://schemas.microsoft.com/office/drawing/2014/main" id="{F6EAE9F7-0B02-4BA1-956E-01F16C474B9A}"/>
               </a:ext>
             </a:extLst>
           </p:cNvPr>
@@ -6407,7 +6407,7 @@
           <p:cNvPr id="74" name="dp44-implementation-comparison / n63 / path">
             <a:extLst xmlns:a="http://schemas.openxmlformats.org/drawingml/2006/main">
               <a:ext uri="{FF2B5EF4-FFF2-40B4-BE49-F238E27FC236}">
-                <a16:creationId xmlns:a16="http://schemas.microsoft.com/office/drawing/2014/main" id="{0231E32C-863B-49E6-B660-038267890D41}"/>
+                <a16:creationId xmlns:a16="http://schemas.microsoft.com/office/drawing/2014/main" id="{B36810EF-68A5-4290-A03E-57ACC20F468D}"/>
               </a:ext>
             </a:extLst>
           </p:cNvPr>
@@ -6447,7 +6447,7 @@
           <p:cNvPr id="75" name="dp44-implementation-comparison / n64 / path">
             <a:extLst xmlns:a="http://schemas.openxmlformats.org/drawingml/2006/main">
               <a:ext uri="{FF2B5EF4-FFF2-40B4-BE49-F238E27FC236}">
-                <a16:creationId xmlns:a16="http://schemas.microsoft.com/office/drawing/2014/main" id="{10B50459-6979-42F5-A553-4590E96E82A1}"/>
+                <a16:creationId xmlns:a16="http://schemas.microsoft.com/office/drawing/2014/main" id="{F9BC6D35-84A4-48B2-9D71-A609A8ED31C4}"/>
               </a:ext>
             </a:extLst>
           </p:cNvPr>
@@ -6487,7 +6487,7 @@
           <p:cNvPr id="76" name="dp44-implementation-comparison / n65 / path">
             <a:extLst xmlns:a="http://schemas.openxmlformats.org/drawingml/2006/main">
               <a:ext uri="{FF2B5EF4-FFF2-40B4-BE49-F238E27FC236}">
-                <a16:creationId xmlns:a16="http://schemas.microsoft.com/office/drawing/2014/main" id="{D54288BF-500B-4A83-82D9-4DF1948B6638}"/>
+                <a16:creationId xmlns:a16="http://schemas.microsoft.com/office/drawing/2014/main" id="{C1F57DAC-5515-47E8-A838-A150A72337DF}"/>
               </a:ext>
             </a:extLst>
           </p:cNvPr>
@@ -6527,7 +6527,7 @@
           <p:cNvPr id="77" name="dp44-implementation-comparison / n65 / arrow">
             <a:extLst xmlns:a="http://schemas.openxmlformats.org/drawingml/2006/main">
               <a:ext uri="{FF2B5EF4-FFF2-40B4-BE49-F238E27FC236}">
-                <a16:creationId xmlns:a16="http://schemas.microsoft.com/office/drawing/2014/main" id="{44DE5B1A-D55F-43CA-9C3E-F460D9D33D53}"/>
+                <a16:creationId xmlns:a16="http://schemas.microsoft.com/office/drawing/2014/main" id="{238CC08F-404D-479C-BA30-C696862ED7AA}"/>
               </a:ext>
             </a:extLst>
           </p:cNvPr>
@@ -6570,7 +6570,7 @@
           <p:cNvPr id="78" name="dp44-implementation-comparison / n66 / path">
             <a:extLst xmlns:a="http://schemas.openxmlformats.org/drawingml/2006/main">
               <a:ext uri="{FF2B5EF4-FFF2-40B4-BE49-F238E27FC236}">
-                <a16:creationId xmlns:a16="http://schemas.microsoft.com/office/drawing/2014/main" id="{3E4A6EFD-22A4-417A-A4F2-1F7ED809124D}"/>
+                <a16:creationId xmlns:a16="http://schemas.microsoft.com/office/drawing/2014/main" id="{E06E1079-86EB-4EC0-A5C7-D00755321E2B}"/>
               </a:ext>
             </a:extLst>
           </p:cNvPr>
@@ -6610,7 +6610,7 @@
           <p:cNvPr id="79" name="dp44-implementation-comparison / n66 / arrow">
             <a:extLst xmlns:a="http://schemas.openxmlformats.org/drawingml/2006/main">
               <a:ext uri="{FF2B5EF4-FFF2-40B4-BE49-F238E27FC236}">
-                <a16:creationId xmlns:a16="http://schemas.microsoft.com/office/drawing/2014/main" id="{7FE0DCAA-F6E7-4068-AAD5-005EC1502583}"/>
+                <a16:creationId xmlns:a16="http://schemas.microsoft.com/office/drawing/2014/main" id="{EDE11EE4-7FC8-419E-9983-0B14740B7A18}"/>
               </a:ext>
             </a:extLst>
           </p:cNvPr>
@@ -6653,7 +6653,7 @@
           <p:cNvPr id="80" name="dp44-implementation-comparison / n67 / path">
             <a:extLst xmlns:a="http://schemas.openxmlformats.org/drawingml/2006/main">
               <a:ext uri="{FF2B5EF4-FFF2-40B4-BE49-F238E27FC236}">
-                <a16:creationId xmlns:a16="http://schemas.microsoft.com/office/drawing/2014/main" id="{48F30386-409D-4AB4-B3FF-29E0192C3542}"/>
+                <a16:creationId xmlns:a16="http://schemas.microsoft.com/office/drawing/2014/main" id="{0B0BBD8C-C12E-4CCC-B11F-FA4D03E24B69}"/>
               </a:ext>
             </a:extLst>
           </p:cNvPr>
@@ -6693,7 +6693,7 @@
           <p:cNvPr id="81" name="dp44-implementation-comparison / n67 / arrow">
             <a:extLst xmlns:a="http://schemas.openxmlformats.org/drawingml/2006/main">
               <a:ext uri="{FF2B5EF4-FFF2-40B4-BE49-F238E27FC236}">
-                <a16:creationId xmlns:a16="http://schemas.microsoft.com/office/drawing/2014/main" id="{37775349-0416-4A4D-B52E-33CDD72FA5E4}"/>
+                <a16:creationId xmlns:a16="http://schemas.microsoft.com/office/drawing/2014/main" id="{7A1850CA-93B5-45DC-B64E-36B9D30A1D44}"/>
               </a:ext>
             </a:extLst>
           </p:cNvPr>
@@ -6736,7 +6736,7 @@
           <p:cNvPr id="82" name="dp44-implementation-comparison / n68 / path">
             <a:extLst xmlns:a="http://schemas.openxmlformats.org/drawingml/2006/main">
               <a:ext uri="{FF2B5EF4-FFF2-40B4-BE49-F238E27FC236}">
-                <a16:creationId xmlns:a16="http://schemas.microsoft.com/office/drawing/2014/main" id="{6BFFC4F6-4B45-4D38-8DE4-A124BCF07478}"/>
+                <a16:creationId xmlns:a16="http://schemas.microsoft.com/office/drawing/2014/main" id="{ED16A88B-474D-4098-A046-1C5BAE1CF93C}"/>
               </a:ext>
             </a:extLst>
           </p:cNvPr>
@@ -6776,7 +6776,7 @@
           <p:cNvPr id="83" name="dp44-implementation-comparison / n68 / arrow">
             <a:extLst xmlns:a="http://schemas.openxmlformats.org/drawingml/2006/main">
               <a:ext uri="{FF2B5EF4-FFF2-40B4-BE49-F238E27FC236}">
-                <a16:creationId xmlns:a16="http://schemas.microsoft.com/office/drawing/2014/main" id="{3B3E38A1-A98F-43F9-A9D3-8E9F6DFD54A8}"/>
+                <a16:creationId xmlns:a16="http://schemas.microsoft.com/office/drawing/2014/main" id="{CF5AEA80-DCB5-481E-8A78-856638DC225A}"/>
               </a:ext>
             </a:extLst>
           </p:cNvPr>
@@ -6819,7 +6819,7 @@
           <p:cNvPr id="84" name="dp44-implementation-comparison / n69">
             <a:extLst xmlns:a="http://schemas.openxmlformats.org/drawingml/2006/main">
               <a:ext uri="{FF2B5EF4-FFF2-40B4-BE49-F238E27FC236}">
-                <a16:creationId xmlns:a16="http://schemas.microsoft.com/office/drawing/2014/main" id="{BBAA18B7-FFE3-45F7-92D6-1826E26465AF}"/>
+                <a16:creationId xmlns:a16="http://schemas.microsoft.com/office/drawing/2014/main" id="{3686D44F-A7A0-442B-8724-8CB76F88838B}"/>
               </a:ext>
             </a:extLst>
           </p:cNvPr>
@@ -6852,7 +6852,7 @@
           <p:cNvPr id="85" name="dp44-implementation-comparison / n70 / text 1">
             <a:extLst xmlns:a="http://schemas.openxmlformats.org/drawingml/2006/main">
               <a:ext uri="{FF2B5EF4-FFF2-40B4-BE49-F238E27FC236}">
-                <a16:creationId xmlns:a16="http://schemas.microsoft.com/office/drawing/2014/main" id="{167C8434-52D5-46F1-A5BD-0EF3A85492C4}"/>
+                <a16:creationId xmlns:a16="http://schemas.microsoft.com/office/drawing/2014/main" id="{CFAFBB05-2271-47C6-AD68-8C29A3B8FFEB}"/>
               </a:ext>
             </a:extLst>
           </p:cNvPr>
@@ -6921,7 +6921,7 @@
           <p:cNvPr id="86" name="dp44-implementation-comparison / n71">
             <a:extLst xmlns:a="http://schemas.openxmlformats.org/drawingml/2006/main">
               <a:ext uri="{FF2B5EF4-FFF2-40B4-BE49-F238E27FC236}">
-                <a16:creationId xmlns:a16="http://schemas.microsoft.com/office/drawing/2014/main" id="{672C43A5-6C08-4C2B-A0FD-94E23028BC05}"/>
+                <a16:creationId xmlns:a16="http://schemas.microsoft.com/office/drawing/2014/main" id="{74A4EF63-EA71-4DB6-838F-9F63DA84288F}"/>
               </a:ext>
             </a:extLst>
           </p:cNvPr>
@@ -6954,7 +6954,7 @@
           <p:cNvPr id="87" name="dp44-implementation-comparison / n72 / text 1">
             <a:extLst xmlns:a="http://schemas.openxmlformats.org/drawingml/2006/main">
               <a:ext uri="{FF2B5EF4-FFF2-40B4-BE49-F238E27FC236}">
-                <a16:creationId xmlns:a16="http://schemas.microsoft.com/office/drawing/2014/main" id="{BA34415A-70DF-4C64-9B59-A74BFE3A4B85}"/>
+                <a16:creationId xmlns:a16="http://schemas.microsoft.com/office/drawing/2014/main" id="{E83EB627-EF0D-4A1B-AC13-3872FDEC306B}"/>
               </a:ext>
             </a:extLst>
           </p:cNvPr>
@@ -7023,7 +7023,7 @@
           <p:cNvPr id="88" name="dp44-implementation-comparison / n73">
             <a:extLst xmlns:a="http://schemas.openxmlformats.org/drawingml/2006/main">
               <a:ext uri="{FF2B5EF4-FFF2-40B4-BE49-F238E27FC236}">
-                <a16:creationId xmlns:a16="http://schemas.microsoft.com/office/drawing/2014/main" id="{B2DA8CEB-D64E-4CBE-9204-6024A69EC257}"/>
+                <a16:creationId xmlns:a16="http://schemas.microsoft.com/office/drawing/2014/main" id="{17097A50-B022-4FB2-8870-F67EB8E9A800}"/>
               </a:ext>
             </a:extLst>
           </p:cNvPr>
@@ -7056,7 +7056,7 @@
           <p:cNvPr id="89" name="dp44-implementation-comparison / n74">
             <a:extLst xmlns:a="http://schemas.openxmlformats.org/drawingml/2006/main">
               <a:ext uri="{FF2B5EF4-FFF2-40B4-BE49-F238E27FC236}">
-                <a16:creationId xmlns:a16="http://schemas.microsoft.com/office/drawing/2014/main" id="{AC69EA6E-BC9F-4BA8-8392-093143937A85}"/>
+                <a16:creationId xmlns:a16="http://schemas.microsoft.com/office/drawing/2014/main" id="{2D9E3049-FF9F-404E-96F4-A2056A94BF8F}"/>
               </a:ext>
             </a:extLst>
           </p:cNvPr>
@@ -7089,7 +7089,7 @@
           <p:cNvPr id="90" name="dp44-implementation-comparison / n75">
             <a:extLst xmlns:a="http://schemas.openxmlformats.org/drawingml/2006/main">
               <a:ext uri="{FF2B5EF4-FFF2-40B4-BE49-F238E27FC236}">
-                <a16:creationId xmlns:a16="http://schemas.microsoft.com/office/drawing/2014/main" id="{8197979B-155C-4A0C-BB55-9F5FBC693FF8}"/>
+                <a16:creationId xmlns:a16="http://schemas.microsoft.com/office/drawing/2014/main" id="{DA54AD8B-F4CF-4357-963B-9B94DC40A65F}"/>
               </a:ext>
             </a:extLst>
           </p:cNvPr>
@@ -7122,7 +7122,7 @@
           <p:cNvPr id="91" name="dp44-implementation-comparison / n76">
             <a:extLst xmlns:a="http://schemas.openxmlformats.org/drawingml/2006/main">
               <a:ext uri="{FF2B5EF4-FFF2-40B4-BE49-F238E27FC236}">
-                <a16:creationId xmlns:a16="http://schemas.microsoft.com/office/drawing/2014/main" id="{82B7FBFA-7EC5-4EB8-B0E6-8350D78FA985}"/>
+                <a16:creationId xmlns:a16="http://schemas.microsoft.com/office/drawing/2014/main" id="{739ADA1B-65FD-4C6A-8F0E-FC39D2F6273D}"/>
               </a:ext>
             </a:extLst>
           </p:cNvPr>
@@ -7155,7 +7155,7 @@
           <p:cNvPr id="92" name="dp44-implementation-comparison / n77">
             <a:extLst xmlns:a="http://schemas.openxmlformats.org/drawingml/2006/main">
               <a:ext uri="{FF2B5EF4-FFF2-40B4-BE49-F238E27FC236}">
-                <a16:creationId xmlns:a16="http://schemas.microsoft.com/office/drawing/2014/main" id="{0B6DCCF7-D789-4B68-B4B5-44B86C835643}"/>
+                <a16:creationId xmlns:a16="http://schemas.microsoft.com/office/drawing/2014/main" id="{5D97749A-772A-45F0-8C15-16D34647B76D}"/>
               </a:ext>
             </a:extLst>
           </p:cNvPr>
@@ -7188,7 +7188,7 @@
           <p:cNvPr id="93" name="dp44-implementation-comparison / n78 / text 1">
             <a:extLst xmlns:a="http://schemas.openxmlformats.org/drawingml/2006/main">
               <a:ext uri="{FF2B5EF4-FFF2-40B4-BE49-F238E27FC236}">
-                <a16:creationId xmlns:a16="http://schemas.microsoft.com/office/drawing/2014/main" id="{694B6FEA-464A-46ED-9576-2E407D0E76F6}"/>
+                <a16:creationId xmlns:a16="http://schemas.microsoft.com/office/drawing/2014/main" id="{DC106162-D14E-4E91-B239-6F2550117697}"/>
               </a:ext>
             </a:extLst>
           </p:cNvPr>
@@ -7257,7 +7257,7 @@
           <p:cNvPr id="94" name="dp44-implementation-comparison / n79">
             <a:extLst xmlns:a="http://schemas.openxmlformats.org/drawingml/2006/main">
               <a:ext uri="{FF2B5EF4-FFF2-40B4-BE49-F238E27FC236}">
-                <a16:creationId xmlns:a16="http://schemas.microsoft.com/office/drawing/2014/main" id="{2021B18B-25BB-4420-AE54-DEA660BADFCE}"/>
+                <a16:creationId xmlns:a16="http://schemas.microsoft.com/office/drawing/2014/main" id="{9F0C6421-8F8F-49C6-9EA7-B9B88DEEB02E}"/>
               </a:ext>
             </a:extLst>
           </p:cNvPr>
@@ -7290,7 +7290,7 @@
           <p:cNvPr id="95" name="dp44-implementation-comparison / n80">
             <a:extLst xmlns:a="http://schemas.openxmlformats.org/drawingml/2006/main">
               <a:ext uri="{FF2B5EF4-FFF2-40B4-BE49-F238E27FC236}">
-                <a16:creationId xmlns:a16="http://schemas.microsoft.com/office/drawing/2014/main" id="{788A5880-8780-48C6-86A2-1E6E63F06EAC}"/>
+                <a16:creationId xmlns:a16="http://schemas.microsoft.com/office/drawing/2014/main" id="{657862B7-A1FB-40A6-B58C-47880446FB44}"/>
               </a:ext>
             </a:extLst>
           </p:cNvPr>
@@ -7323,7 +7323,7 @@
           <p:cNvPr id="96" name="dp44-implementation-comparison / n81">
             <a:extLst xmlns:a="http://schemas.openxmlformats.org/drawingml/2006/main">
               <a:ext uri="{FF2B5EF4-FFF2-40B4-BE49-F238E27FC236}">
-                <a16:creationId xmlns:a16="http://schemas.microsoft.com/office/drawing/2014/main" id="{E5818D53-B304-4694-876A-BCB471D0C099}"/>
+                <a16:creationId xmlns:a16="http://schemas.microsoft.com/office/drawing/2014/main" id="{4E9C3DEB-314A-4656-A2E3-31577E0AFA63}"/>
               </a:ext>
             </a:extLst>
           </p:cNvPr>
@@ -7356,7 +7356,7 @@
           <p:cNvPr id="97" name="dp44-implementation-comparison / n82">
             <a:extLst xmlns:a="http://schemas.openxmlformats.org/drawingml/2006/main">
               <a:ext uri="{FF2B5EF4-FFF2-40B4-BE49-F238E27FC236}">
-                <a16:creationId xmlns:a16="http://schemas.microsoft.com/office/drawing/2014/main" id="{48641A56-C0A7-4E56-96DB-16DCEE029680}"/>
+                <a16:creationId xmlns:a16="http://schemas.microsoft.com/office/drawing/2014/main" id="{B6F0AC46-8F8B-4E20-8FBE-36A050A6AD84}"/>
               </a:ext>
             </a:extLst>
           </p:cNvPr>
@@ -7389,7 +7389,7 @@
           <p:cNvPr id="98" name="dp44-implementation-comparison / n83">
             <a:extLst xmlns:a="http://schemas.openxmlformats.org/drawingml/2006/main">
               <a:ext uri="{FF2B5EF4-FFF2-40B4-BE49-F238E27FC236}">
-                <a16:creationId xmlns:a16="http://schemas.microsoft.com/office/drawing/2014/main" id="{4CC2DCCF-747E-42A6-931A-DDBA7CB13C29}"/>
+                <a16:creationId xmlns:a16="http://schemas.microsoft.com/office/drawing/2014/main" id="{D52571D2-7516-472A-B86F-13CE8F3F4789}"/>
               </a:ext>
             </a:extLst>
           </p:cNvPr>
@@ -7422,7 +7422,7 @@
           <p:cNvPr id="99" name="dp44-implementation-comparison / n84 / text 1">
             <a:extLst xmlns:a="http://schemas.openxmlformats.org/drawingml/2006/main">
               <a:ext uri="{FF2B5EF4-FFF2-40B4-BE49-F238E27FC236}">
-                <a16:creationId xmlns:a16="http://schemas.microsoft.com/office/drawing/2014/main" id="{7A0970D3-94A5-40AF-9BC2-258C6F02CEEA}"/>
+                <a16:creationId xmlns:a16="http://schemas.microsoft.com/office/drawing/2014/main" id="{3AC12158-F84B-4B04-93BF-56805B24B792}"/>
               </a:ext>
             </a:extLst>
           </p:cNvPr>
@@ -7491,7 +7491,7 @@
           <p:cNvPr id="100" name="dp44-implementation-comparison / n85">
             <a:extLst xmlns:a="http://schemas.openxmlformats.org/drawingml/2006/main">
               <a:ext uri="{FF2B5EF4-FFF2-40B4-BE49-F238E27FC236}">
-                <a16:creationId xmlns:a16="http://schemas.microsoft.com/office/drawing/2014/main" id="{99942692-3651-43CA-B02D-206E83398306}"/>
+                <a16:creationId xmlns:a16="http://schemas.microsoft.com/office/drawing/2014/main" id="{FD5E27E9-568D-4EF7-93AB-5E0651F87202}"/>
               </a:ext>
             </a:extLst>
           </p:cNvPr>
@@ -7524,7 +7524,7 @@
           <p:cNvPr id="101" name="dp44-implementation-comparison / n86">
             <a:extLst xmlns:a="http://schemas.openxmlformats.org/drawingml/2006/main">
               <a:ext uri="{FF2B5EF4-FFF2-40B4-BE49-F238E27FC236}">
-                <a16:creationId xmlns:a16="http://schemas.microsoft.com/office/drawing/2014/main" id="{64A5B404-F12E-41DF-AE5F-025A0AF13E3C}"/>
+                <a16:creationId xmlns:a16="http://schemas.microsoft.com/office/drawing/2014/main" id="{90F6A07B-10F2-466C-8D90-23F236FF6F86}"/>
               </a:ext>
             </a:extLst>
           </p:cNvPr>
@@ -7557,7 +7557,7 @@
           <p:cNvPr id="102" name="dp44-implementation-comparison / n87">
             <a:extLst xmlns:a="http://schemas.openxmlformats.org/drawingml/2006/main">
               <a:ext uri="{FF2B5EF4-FFF2-40B4-BE49-F238E27FC236}">
-                <a16:creationId xmlns:a16="http://schemas.microsoft.com/office/drawing/2014/main" id="{A7330C7D-6FF7-4FE6-82E1-CF7ECE55AD01}"/>
+                <a16:creationId xmlns:a16="http://schemas.microsoft.com/office/drawing/2014/main" id="{22CBEAAA-FB35-4137-82B2-03656C584568}"/>
               </a:ext>
             </a:extLst>
           </p:cNvPr>
@@ -7590,7 +7590,7 @@
           <p:cNvPr id="103" name="dp44-implementation-comparison / n88">
             <a:extLst xmlns:a="http://schemas.openxmlformats.org/drawingml/2006/main">
               <a:ext uri="{FF2B5EF4-FFF2-40B4-BE49-F238E27FC236}">
-                <a16:creationId xmlns:a16="http://schemas.microsoft.com/office/drawing/2014/main" id="{5B7E5A8E-D0BA-4927-8F7D-3D4CF6EC565C}"/>
+                <a16:creationId xmlns:a16="http://schemas.microsoft.com/office/drawing/2014/main" id="{B2F75FF2-5D7C-41DC-85CF-702981B1028F}"/>
               </a:ext>
             </a:extLst>
           </p:cNvPr>
@@ -7623,7 +7623,7 @@
           <p:cNvPr id="104" name="dp44-implementation-comparison / n89">
             <a:extLst xmlns:a="http://schemas.openxmlformats.org/drawingml/2006/main">
               <a:ext uri="{FF2B5EF4-FFF2-40B4-BE49-F238E27FC236}">
-                <a16:creationId xmlns:a16="http://schemas.microsoft.com/office/drawing/2014/main" id="{8F84B158-2F87-4CBC-B7ED-5316546851AD}"/>
+                <a16:creationId xmlns:a16="http://schemas.microsoft.com/office/drawing/2014/main" id="{CC9FE7DE-61C5-4813-8A59-907AED69D19F}"/>
               </a:ext>
             </a:extLst>
           </p:cNvPr>
@@ -7656,7 +7656,7 @@
           <p:cNvPr id="105" name="dp44-implementation-comparison / n90 / text 1">
             <a:extLst xmlns:a="http://schemas.openxmlformats.org/drawingml/2006/main">
               <a:ext uri="{FF2B5EF4-FFF2-40B4-BE49-F238E27FC236}">
-                <a16:creationId xmlns:a16="http://schemas.microsoft.com/office/drawing/2014/main" id="{C4A1E950-B995-44A2-A472-8F47DBED1411}"/>
+                <a16:creationId xmlns:a16="http://schemas.microsoft.com/office/drawing/2014/main" id="{9320E13F-F040-4C14-92D1-1B3EB62CDA5F}"/>
               </a:ext>
             </a:extLst>
           </p:cNvPr>
@@ -7725,7 +7725,7 @@
           <p:cNvPr id="106" name="dp44-implementation-comparison / n91">
             <a:extLst xmlns:a="http://schemas.openxmlformats.org/drawingml/2006/main">
               <a:ext uri="{FF2B5EF4-FFF2-40B4-BE49-F238E27FC236}">
-                <a16:creationId xmlns:a16="http://schemas.microsoft.com/office/drawing/2014/main" id="{BC2AA588-1E1D-478A-837D-1BAC790DEAF3}"/>
+                <a16:creationId xmlns:a16="http://schemas.microsoft.com/office/drawing/2014/main" id="{89F9D897-F286-4944-93DA-0D71EE45FDBE}"/>
               </a:ext>
             </a:extLst>
           </p:cNvPr>
@@ -7758,7 +7758,7 @@
           <p:cNvPr id="107" name="dp44-implementation-comparison / n92 / text 1">
             <a:extLst xmlns:a="http://schemas.openxmlformats.org/drawingml/2006/main">
               <a:ext uri="{FF2B5EF4-FFF2-40B4-BE49-F238E27FC236}">
-                <a16:creationId xmlns:a16="http://schemas.microsoft.com/office/drawing/2014/main" id="{1658F23B-0B7A-45D6-ABE8-7FC79F680BE2}"/>
+                <a16:creationId xmlns:a16="http://schemas.microsoft.com/office/drawing/2014/main" id="{C82D68E0-E8A2-4880-92CD-696C96937F35}"/>
               </a:ext>
             </a:extLst>
           </p:cNvPr>
@@ -7827,7 +7827,7 @@
           <p:cNvPr id="108" name="dp44-implementation-comparison / n93 / path">
             <a:extLst xmlns:a="http://schemas.openxmlformats.org/drawingml/2006/main">
               <a:ext uri="{FF2B5EF4-FFF2-40B4-BE49-F238E27FC236}">
-                <a16:creationId xmlns:a16="http://schemas.microsoft.com/office/drawing/2014/main" id="{E6C06232-4A0D-4607-B23D-592182988C5D}"/>
+                <a16:creationId xmlns:a16="http://schemas.microsoft.com/office/drawing/2014/main" id="{EBD6576D-A11C-485E-98FD-E698AD6B49A3}"/>
               </a:ext>
             </a:extLst>
           </p:cNvPr>
@@ -7873,7 +7873,7 @@
           <p:cNvPr id="109" name="dp44-implementation-comparison / n93 / arrow">
             <a:extLst xmlns:a="http://schemas.openxmlformats.org/drawingml/2006/main">
               <a:ext uri="{FF2B5EF4-FFF2-40B4-BE49-F238E27FC236}">
-                <a16:creationId xmlns:a16="http://schemas.microsoft.com/office/drawing/2014/main" id="{508F3AA0-F2E7-4AC4-B370-FAA5AA55F078}"/>
+                <a16:creationId xmlns:a16="http://schemas.microsoft.com/office/drawing/2014/main" id="{6239E9FA-E655-448E-9DA6-4BDF777FC9E8}"/>
               </a:ext>
             </a:extLst>
           </p:cNvPr>
@@ -7916,7 +7916,7 @@
           <p:cNvPr id="110" name="dp44-implementation-comparison / n94">
             <a:extLst xmlns:a="http://schemas.openxmlformats.org/drawingml/2006/main">
               <a:ext uri="{FF2B5EF4-FFF2-40B4-BE49-F238E27FC236}">
-                <a16:creationId xmlns:a16="http://schemas.microsoft.com/office/drawing/2014/main" id="{E9A16330-3605-4B11-A4C1-B042E718CF79}"/>
+                <a16:creationId xmlns:a16="http://schemas.microsoft.com/office/drawing/2014/main" id="{83F28933-3C9F-414F-94DE-2563778D0C82}"/>
               </a:ext>
             </a:extLst>
           </p:cNvPr>
@@ -7949,7 +7949,7 @@
           <p:cNvPr id="111" name="dp44-implementation-comparison / n95 / text 1">
             <a:extLst xmlns:a="http://schemas.openxmlformats.org/drawingml/2006/main">
               <a:ext uri="{FF2B5EF4-FFF2-40B4-BE49-F238E27FC236}">
-                <a16:creationId xmlns:a16="http://schemas.microsoft.com/office/drawing/2014/main" id="{24E9FE22-883B-4571-88C9-0011A6E4495B}"/>
+                <a16:creationId xmlns:a16="http://schemas.microsoft.com/office/drawing/2014/main" id="{4A6C927D-44BA-4D40-950A-E9EA96612345}"/>
               </a:ext>
             </a:extLst>
           </p:cNvPr>
@@ -8018,7 +8018,7 @@
           <p:cNvPr id="112" name="dp44-implementation-comparison / n96">
             <a:extLst xmlns:a="http://schemas.openxmlformats.org/drawingml/2006/main">
               <a:ext uri="{FF2B5EF4-FFF2-40B4-BE49-F238E27FC236}">
-                <a16:creationId xmlns:a16="http://schemas.microsoft.com/office/drawing/2014/main" id="{87A7BCDA-DA8C-402B-879B-8D63EB30B135}"/>
+                <a16:creationId xmlns:a16="http://schemas.microsoft.com/office/drawing/2014/main" id="{D7E071DA-18E2-4BC7-9F2E-95EDE4E09B0C}"/>
               </a:ext>
             </a:extLst>
           </p:cNvPr>
@@ -8051,7 +8051,7 @@
           <p:cNvPr id="113" name="dp44-implementation-comparison / n97 / text 1">
             <a:extLst xmlns:a="http://schemas.openxmlformats.org/drawingml/2006/main">
               <a:ext uri="{FF2B5EF4-FFF2-40B4-BE49-F238E27FC236}">
-                <a16:creationId xmlns:a16="http://schemas.microsoft.com/office/drawing/2014/main" id="{8322AB48-D0B4-4134-9D02-F865A4ECD147}"/>
+                <a16:creationId xmlns:a16="http://schemas.microsoft.com/office/drawing/2014/main" id="{BD1842C6-8771-456A-841D-561C2567963F}"/>
               </a:ext>
             </a:extLst>
           </p:cNvPr>
@@ -8120,7 +8120,7 @@
           <p:cNvPr id="114" name="dp44-implementation-comparison / n98">
             <a:extLst xmlns:a="http://schemas.openxmlformats.org/drawingml/2006/main">
               <a:ext uri="{FF2B5EF4-FFF2-40B4-BE49-F238E27FC236}">
-                <a16:creationId xmlns:a16="http://schemas.microsoft.com/office/drawing/2014/main" id="{02843DFB-E1DC-4F52-B531-B51E9C062278}"/>
+                <a16:creationId xmlns:a16="http://schemas.microsoft.com/office/drawing/2014/main" id="{90EF6DF9-FE2B-4692-BE18-9AF7884A7D7A}"/>
               </a:ext>
             </a:extLst>
           </p:cNvPr>
@@ -8153,7 +8153,7 @@
           <p:cNvPr id="115" name="dp44-implementation-comparison / n99">
             <a:extLst xmlns:a="http://schemas.openxmlformats.org/drawingml/2006/main">
               <a:ext uri="{FF2B5EF4-FFF2-40B4-BE49-F238E27FC236}">
-                <a16:creationId xmlns:a16="http://schemas.microsoft.com/office/drawing/2014/main" id="{0868AA96-C2C9-4688-B318-5A851D7E9C64}"/>
+                <a16:creationId xmlns:a16="http://schemas.microsoft.com/office/drawing/2014/main" id="{C79A2433-C304-4A71-9B4E-5120D340BFDE}"/>
               </a:ext>
             </a:extLst>
           </p:cNvPr>
@@ -8186,7 +8186,7 @@
           <p:cNvPr id="116" name="dp44-implementation-comparison / n100">
             <a:extLst xmlns:a="http://schemas.openxmlformats.org/drawingml/2006/main">
               <a:ext uri="{FF2B5EF4-FFF2-40B4-BE49-F238E27FC236}">
-                <a16:creationId xmlns:a16="http://schemas.microsoft.com/office/drawing/2014/main" id="{7CC6A7D0-86EE-4A60-8638-B22535A0A9C3}"/>
+                <a16:creationId xmlns:a16="http://schemas.microsoft.com/office/drawing/2014/main" id="{03C1B7F0-E8AB-41E1-9883-199FFC793014}"/>
               </a:ext>
             </a:extLst>
           </p:cNvPr>
@@ -8219,7 +8219,7 @@
           <p:cNvPr id="117" name="dp44-implementation-comparison / n101">
             <a:extLst xmlns:a="http://schemas.openxmlformats.org/drawingml/2006/main">
               <a:ext uri="{FF2B5EF4-FFF2-40B4-BE49-F238E27FC236}">
-                <a16:creationId xmlns:a16="http://schemas.microsoft.com/office/drawing/2014/main" id="{B4B660F9-D35E-44E7-8D37-3495E0504A81}"/>
+                <a16:creationId xmlns:a16="http://schemas.microsoft.com/office/drawing/2014/main" id="{3FAEE270-E59B-4D9F-BF93-BECB8DA427C7}"/>
               </a:ext>
             </a:extLst>
           </p:cNvPr>
@@ -8252,7 +8252,7 @@
           <p:cNvPr id="118" name="dp44-implementation-comparison / n102">
             <a:extLst xmlns:a="http://schemas.openxmlformats.org/drawingml/2006/main">
               <a:ext uri="{FF2B5EF4-FFF2-40B4-BE49-F238E27FC236}">
-                <a16:creationId xmlns:a16="http://schemas.microsoft.com/office/drawing/2014/main" id="{DBB19BBD-74C1-4E4D-9E04-76B9C0219403}"/>
+                <a16:creationId xmlns:a16="http://schemas.microsoft.com/office/drawing/2014/main" id="{25267D25-3747-4ABE-8412-932FF29FE9AA}"/>
               </a:ext>
             </a:extLst>
           </p:cNvPr>
@@ -8285,7 +8285,7 @@
           <p:cNvPr id="119" name="dp44-implementation-comparison / n103 / text 1">
             <a:extLst xmlns:a="http://schemas.openxmlformats.org/drawingml/2006/main">
               <a:ext uri="{FF2B5EF4-FFF2-40B4-BE49-F238E27FC236}">
-                <a16:creationId xmlns:a16="http://schemas.microsoft.com/office/drawing/2014/main" id="{D8982034-6985-45E9-84D3-FE7E800D738B}"/>
+                <a16:creationId xmlns:a16="http://schemas.microsoft.com/office/drawing/2014/main" id="{5568A2B5-6E61-4DE0-B2DE-A1E8A8F132C8}"/>
               </a:ext>
             </a:extLst>
           </p:cNvPr>
@@ -8354,7 +8354,7 @@
           <p:cNvPr id="120" name="dp44-implementation-comparison / n104">
             <a:extLst xmlns:a="http://schemas.openxmlformats.org/drawingml/2006/main">
               <a:ext uri="{FF2B5EF4-FFF2-40B4-BE49-F238E27FC236}">
-                <a16:creationId xmlns:a16="http://schemas.microsoft.com/office/drawing/2014/main" id="{9110CE30-9ADC-43BB-BDB0-ABCB9415ACF5}"/>
+                <a16:creationId xmlns:a16="http://schemas.microsoft.com/office/drawing/2014/main" id="{899BF249-CC53-4776-9D45-6E272B52E725}"/>
               </a:ext>
             </a:extLst>
           </p:cNvPr>
@@ -8387,7 +8387,7 @@
           <p:cNvPr id="121" name="dp44-implementation-comparison / n105">
             <a:extLst xmlns:a="http://schemas.openxmlformats.org/drawingml/2006/main">
               <a:ext uri="{FF2B5EF4-FFF2-40B4-BE49-F238E27FC236}">
-                <a16:creationId xmlns:a16="http://schemas.microsoft.com/office/drawing/2014/main" id="{A804F05E-F2E9-46D9-AA50-CE6E6B2E9E11}"/>
+                <a16:creationId xmlns:a16="http://schemas.microsoft.com/office/drawing/2014/main" id="{90703299-B445-4534-ABC9-2A39830FA4CC}"/>
               </a:ext>
             </a:extLst>
           </p:cNvPr>
@@ -8420,7 +8420,7 @@
           <p:cNvPr id="122" name="dp44-implementation-comparison / n106">
             <a:extLst xmlns:a="http://schemas.openxmlformats.org/drawingml/2006/main">
               <a:ext uri="{FF2B5EF4-FFF2-40B4-BE49-F238E27FC236}">
-                <a16:creationId xmlns:a16="http://schemas.microsoft.com/office/drawing/2014/main" id="{40D842C4-A228-420D-8DAE-4472C8829F6F}"/>
+                <a16:creationId xmlns:a16="http://schemas.microsoft.com/office/drawing/2014/main" id="{7FBB533B-6D67-42DE-9077-8ED4ADE89497}"/>
               </a:ext>
             </a:extLst>
           </p:cNvPr>
@@ -8453,7 +8453,7 @@
           <p:cNvPr id="123" name="dp44-implementation-comparison / n107">
             <a:extLst xmlns:a="http://schemas.openxmlformats.org/drawingml/2006/main">
               <a:ext uri="{FF2B5EF4-FFF2-40B4-BE49-F238E27FC236}">
-                <a16:creationId xmlns:a16="http://schemas.microsoft.com/office/drawing/2014/main" id="{E261DB45-A4B3-4182-A84F-FB90E5003972}"/>
+                <a16:creationId xmlns:a16="http://schemas.microsoft.com/office/drawing/2014/main" id="{879E82C7-71A5-4F95-8F4D-F04DFA165DED}"/>
               </a:ext>
             </a:extLst>
           </p:cNvPr>
@@ -8486,7 +8486,7 @@
           <p:cNvPr id="124" name="dp44-implementation-comparison / n108">
             <a:extLst xmlns:a="http://schemas.openxmlformats.org/drawingml/2006/main">
               <a:ext uri="{FF2B5EF4-FFF2-40B4-BE49-F238E27FC236}">
-                <a16:creationId xmlns:a16="http://schemas.microsoft.com/office/drawing/2014/main" id="{66318BE1-70D8-40CE-8225-BCD4DC5F739C}"/>
+                <a16:creationId xmlns:a16="http://schemas.microsoft.com/office/drawing/2014/main" id="{C13B220C-22AD-435E-9495-44B897848C14}"/>
               </a:ext>
             </a:extLst>
           </p:cNvPr>
@@ -8519,7 +8519,7 @@
           <p:cNvPr id="125" name="dp44-implementation-comparison / n109 / text 1">
             <a:extLst xmlns:a="http://schemas.openxmlformats.org/drawingml/2006/main">
               <a:ext uri="{FF2B5EF4-FFF2-40B4-BE49-F238E27FC236}">
-                <a16:creationId xmlns:a16="http://schemas.microsoft.com/office/drawing/2014/main" id="{A5E00862-54B8-4464-BBD6-B3B9164BC4F3}"/>
+                <a16:creationId xmlns:a16="http://schemas.microsoft.com/office/drawing/2014/main" id="{20E40BB0-AF71-40FF-9BD9-BD476CF1E384}"/>
               </a:ext>
             </a:extLst>
           </p:cNvPr>
@@ -8588,7 +8588,7 @@
           <p:cNvPr id="126" name="dp44-implementation-comparison / n110">
             <a:extLst xmlns:a="http://schemas.openxmlformats.org/drawingml/2006/main">
               <a:ext uri="{FF2B5EF4-FFF2-40B4-BE49-F238E27FC236}">
-                <a16:creationId xmlns:a16="http://schemas.microsoft.com/office/drawing/2014/main" id="{F1CE416D-371E-4861-B760-4B1737F02242}"/>
+                <a16:creationId xmlns:a16="http://schemas.microsoft.com/office/drawing/2014/main" id="{2C707169-0241-4FBC-9ED2-AAF6143843B4}"/>
               </a:ext>
             </a:extLst>
           </p:cNvPr>
@@ -8621,7 +8621,7 @@
           <p:cNvPr id="127" name="dp44-implementation-comparison / n111">
             <a:extLst xmlns:a="http://schemas.openxmlformats.org/drawingml/2006/main">
               <a:ext uri="{FF2B5EF4-FFF2-40B4-BE49-F238E27FC236}">
-                <a16:creationId xmlns:a16="http://schemas.microsoft.com/office/drawing/2014/main" id="{F7CF8735-48C1-424F-8DAB-58A6099565E3}"/>
+                <a16:creationId xmlns:a16="http://schemas.microsoft.com/office/drawing/2014/main" id="{78D66535-5F3D-4FB2-8E17-8F0DCE4299EF}"/>
               </a:ext>
             </a:extLst>
           </p:cNvPr>
@@ -8654,7 +8654,7 @@
           <p:cNvPr id="128" name="dp44-implementation-comparison / n112">
             <a:extLst xmlns:a="http://schemas.openxmlformats.org/drawingml/2006/main">
               <a:ext uri="{FF2B5EF4-FFF2-40B4-BE49-F238E27FC236}">
-                <a16:creationId xmlns:a16="http://schemas.microsoft.com/office/drawing/2014/main" id="{72CD3934-25C3-4FA9-AA65-C54A17EF8A66}"/>
+                <a16:creationId xmlns:a16="http://schemas.microsoft.com/office/drawing/2014/main" id="{763EE596-1EB4-4091-8CCC-1BBB7729476C}"/>
               </a:ext>
             </a:extLst>
           </p:cNvPr>
@@ -8687,7 +8687,7 @@
           <p:cNvPr id="129" name="dp44-implementation-comparison / n113">
             <a:extLst xmlns:a="http://schemas.openxmlformats.org/drawingml/2006/main">
               <a:ext uri="{FF2B5EF4-FFF2-40B4-BE49-F238E27FC236}">
-                <a16:creationId xmlns:a16="http://schemas.microsoft.com/office/drawing/2014/main" id="{47A11615-606A-4E90-838D-1F2C2FB70550}"/>
+                <a16:creationId xmlns:a16="http://schemas.microsoft.com/office/drawing/2014/main" id="{1E2B0006-3F1F-4102-BF5A-360EA90F90B8}"/>
               </a:ext>
             </a:extLst>
           </p:cNvPr>
@@ -8720,7 +8720,7 @@
           <p:cNvPr id="130" name="dp44-implementation-comparison / n114">
             <a:extLst xmlns:a="http://schemas.openxmlformats.org/drawingml/2006/main">
               <a:ext uri="{FF2B5EF4-FFF2-40B4-BE49-F238E27FC236}">
-                <a16:creationId xmlns:a16="http://schemas.microsoft.com/office/drawing/2014/main" id="{AB9850E9-9D4E-4BA9-B330-4BCBE1350347}"/>
+                <a16:creationId xmlns:a16="http://schemas.microsoft.com/office/drawing/2014/main" id="{DD7993F8-5D14-4310-A3A2-4B79090C86A2}"/>
               </a:ext>
             </a:extLst>
           </p:cNvPr>
@@ -8753,7 +8753,7 @@
           <p:cNvPr id="131" name="dp44-implementation-comparison / n115 / text 1">
             <a:extLst xmlns:a="http://schemas.openxmlformats.org/drawingml/2006/main">
               <a:ext uri="{FF2B5EF4-FFF2-40B4-BE49-F238E27FC236}">
-                <a16:creationId xmlns:a16="http://schemas.microsoft.com/office/drawing/2014/main" id="{0E978BC4-7F59-4303-A5C6-801D4D7B4D9E}"/>
+                <a16:creationId xmlns:a16="http://schemas.microsoft.com/office/drawing/2014/main" id="{C808D07C-5ED6-4965-B1D7-337CB1398035}"/>
               </a:ext>
             </a:extLst>
           </p:cNvPr>
@@ -8822,7 +8822,7 @@
           <p:cNvPr id="132" name="dp44-implementation-comparison / n116">
             <a:extLst xmlns:a="http://schemas.openxmlformats.org/drawingml/2006/main">
               <a:ext uri="{FF2B5EF4-FFF2-40B4-BE49-F238E27FC236}">
-                <a16:creationId xmlns:a16="http://schemas.microsoft.com/office/drawing/2014/main" id="{279D4E69-3620-484D-A4A8-B6F48DF82F03}"/>
+                <a16:creationId xmlns:a16="http://schemas.microsoft.com/office/drawing/2014/main" id="{17054BE8-3189-49DC-AD36-C35221B36ABD}"/>
               </a:ext>
             </a:extLst>
           </p:cNvPr>
@@ -8855,7 +8855,7 @@
           <p:cNvPr id="133" name="dp44-implementation-comparison / n117 / text 1">
             <a:extLst xmlns:a="http://schemas.openxmlformats.org/drawingml/2006/main">
               <a:ext uri="{FF2B5EF4-FFF2-40B4-BE49-F238E27FC236}">
-                <a16:creationId xmlns:a16="http://schemas.microsoft.com/office/drawing/2014/main" id="{65A8CAA9-E9C1-445A-8649-E4417F9B3256}"/>
+                <a16:creationId xmlns:a16="http://schemas.microsoft.com/office/drawing/2014/main" id="{DF70262F-35DE-400D-B866-0C4AE6849632}"/>
               </a:ext>
             </a:extLst>
           </p:cNvPr>
@@ -8924,7 +8924,7 @@
           <p:cNvPr id="134" name="dp44-implementation-comparison / n118 / path">
             <a:extLst xmlns:a="http://schemas.openxmlformats.org/drawingml/2006/main">
               <a:ext uri="{FF2B5EF4-FFF2-40B4-BE49-F238E27FC236}">
-                <a16:creationId xmlns:a16="http://schemas.microsoft.com/office/drawing/2014/main" id="{DAEE64AF-322C-4F35-8645-031B7FD41A78}"/>
+                <a16:creationId xmlns:a16="http://schemas.microsoft.com/office/drawing/2014/main" id="{EA259E3B-E932-46CC-95D3-50CFEFE20FEA}"/>
               </a:ext>
             </a:extLst>
           </p:cNvPr>
@@ -8970,7 +8970,7 @@
           <p:cNvPr id="135" name="dp44-implementation-comparison / n118 / arrow">
             <a:extLst xmlns:a="http://schemas.openxmlformats.org/drawingml/2006/main">
               <a:ext uri="{FF2B5EF4-FFF2-40B4-BE49-F238E27FC236}">
-                <a16:creationId xmlns:a16="http://schemas.microsoft.com/office/drawing/2014/main" id="{20863FC7-2A78-47F9-86CA-184EF1FDEECC}"/>
+                <a16:creationId xmlns:a16="http://schemas.microsoft.com/office/drawing/2014/main" id="{D89102E1-1FB9-4C3B-BD4B-1E66570A844C}"/>
               </a:ext>
             </a:extLst>
           </p:cNvPr>
@@ -9013,7 +9013,7 @@
           <p:cNvPr id="136" name="dp44-implementation-comparison / n119">
             <a:extLst xmlns:a="http://schemas.openxmlformats.org/drawingml/2006/main">
               <a:ext uri="{FF2B5EF4-FFF2-40B4-BE49-F238E27FC236}">
-                <a16:creationId xmlns:a16="http://schemas.microsoft.com/office/drawing/2014/main" id="{A53ACB33-0287-44B3-BCD3-DF49CC7E9546}"/>
+                <a16:creationId xmlns:a16="http://schemas.microsoft.com/office/drawing/2014/main" id="{BB15DFF1-74F9-4761-9944-819A933B9BF6}"/>
               </a:ext>
             </a:extLst>
           </p:cNvPr>
@@ -9046,7 +9046,7 @@
           <p:cNvPr id="137" name="dp44-implementation-comparison / n120 / text 1">
             <a:extLst xmlns:a="http://schemas.openxmlformats.org/drawingml/2006/main">
               <a:ext uri="{FF2B5EF4-FFF2-40B4-BE49-F238E27FC236}">
-                <a16:creationId xmlns:a16="http://schemas.microsoft.com/office/drawing/2014/main" id="{343ACC15-7A84-4887-A3B4-AB2EC5B447E4}"/>
+                <a16:creationId xmlns:a16="http://schemas.microsoft.com/office/drawing/2014/main" id="{9E8D14F6-3DAD-40A6-BDA7-870F1F3121F7}"/>
               </a:ext>
             </a:extLst>
           </p:cNvPr>
@@ -9115,7 +9115,7 @@
           <p:cNvPr id="138" name="dp44-implementation-comparison / n121">
             <a:extLst xmlns:a="http://schemas.openxmlformats.org/drawingml/2006/main">
               <a:ext uri="{FF2B5EF4-FFF2-40B4-BE49-F238E27FC236}">
-                <a16:creationId xmlns:a16="http://schemas.microsoft.com/office/drawing/2014/main" id="{98E16886-4B6A-4687-9607-08B29987D5A2}"/>
+                <a16:creationId xmlns:a16="http://schemas.microsoft.com/office/drawing/2014/main" id="{147E62B5-0903-4090-8687-8D5716543488}"/>
               </a:ext>
             </a:extLst>
           </p:cNvPr>
@@ -9148,7 +9148,7 @@
           <p:cNvPr id="139" name="dp44-implementation-comparison / n122 / text 1">
             <a:extLst xmlns:a="http://schemas.openxmlformats.org/drawingml/2006/main">
               <a:ext uri="{FF2B5EF4-FFF2-40B4-BE49-F238E27FC236}">
-                <a16:creationId xmlns:a16="http://schemas.microsoft.com/office/drawing/2014/main" id="{6068B36B-547A-4C7E-BCAA-16B67F2390DF}"/>
+                <a16:creationId xmlns:a16="http://schemas.microsoft.com/office/drawing/2014/main" id="{8DA40F7D-A4CF-452D-9661-1EB9D2EDFE9B}"/>
               </a:ext>
             </a:extLst>
           </p:cNvPr>
@@ -9217,7 +9217,7 @@
           <p:cNvPr id="140" name="dp44-implementation-comparison / n123">
             <a:extLst xmlns:a="http://schemas.openxmlformats.org/drawingml/2006/main">
               <a:ext uri="{FF2B5EF4-FFF2-40B4-BE49-F238E27FC236}">
-                <a16:creationId xmlns:a16="http://schemas.microsoft.com/office/drawing/2014/main" id="{E6A1B95D-101C-46BA-95C2-47275BCCDF3D}"/>
+                <a16:creationId xmlns:a16="http://schemas.microsoft.com/office/drawing/2014/main" id="{CE871500-A811-49A0-9603-2E61268B49B9}"/>
               </a:ext>
             </a:extLst>
           </p:cNvPr>
@@ -9250,7 +9250,7 @@
           <p:cNvPr id="141" name="dp44-implementation-comparison / n124 / text 1">
             <a:extLst xmlns:a="http://schemas.openxmlformats.org/drawingml/2006/main">
               <a:ext uri="{FF2B5EF4-FFF2-40B4-BE49-F238E27FC236}">
-                <a16:creationId xmlns:a16="http://schemas.microsoft.com/office/drawing/2014/main" id="{DF85B826-01BE-47FF-9C98-E06BA45E9273}"/>
+                <a16:creationId xmlns:a16="http://schemas.microsoft.com/office/drawing/2014/main" id="{C7BAA4F6-DBA1-4343-A583-6F778C64C3E5}"/>
               </a:ext>
             </a:extLst>
           </p:cNvPr>
@@ -9319,7 +9319,7 @@
           <p:cNvPr id="142" name="dp44-implementation-comparison / n125">
             <a:extLst xmlns:a="http://schemas.openxmlformats.org/drawingml/2006/main">
               <a:ext uri="{FF2B5EF4-FFF2-40B4-BE49-F238E27FC236}">
-                <a16:creationId xmlns:a16="http://schemas.microsoft.com/office/drawing/2014/main" id="{7C4CD356-8166-4353-99E6-F734E5CDC79F}"/>
+                <a16:creationId xmlns:a16="http://schemas.microsoft.com/office/drawing/2014/main" id="{A4B8762B-C373-4BE8-A78F-4A12AD704D29}"/>
               </a:ext>
             </a:extLst>
           </p:cNvPr>
@@ -9352,7 +9352,7 @@
           <p:cNvPr id="143" name="dp44-implementation-comparison / n126">
             <a:extLst xmlns:a="http://schemas.openxmlformats.org/drawingml/2006/main">
               <a:ext uri="{FF2B5EF4-FFF2-40B4-BE49-F238E27FC236}">
-                <a16:creationId xmlns:a16="http://schemas.microsoft.com/office/drawing/2014/main" id="{0C26341C-E2A8-4803-9931-887088A1806B}"/>
+                <a16:creationId xmlns:a16="http://schemas.microsoft.com/office/drawing/2014/main" id="{70D633E4-CB62-47D0-B1B6-A8B8D2CFE000}"/>
               </a:ext>
             </a:extLst>
           </p:cNvPr>
@@ -9385,7 +9385,7 @@
           <p:cNvPr id="144" name="dp44-implementation-comparison / n127">
             <a:extLst xmlns:a="http://schemas.openxmlformats.org/drawingml/2006/main">
               <a:ext uri="{FF2B5EF4-FFF2-40B4-BE49-F238E27FC236}">
-                <a16:creationId xmlns:a16="http://schemas.microsoft.com/office/drawing/2014/main" id="{02A22CB6-94A2-4614-8010-83F004964531}"/>
+                <a16:creationId xmlns:a16="http://schemas.microsoft.com/office/drawing/2014/main" id="{050302AA-0E82-410B-8BC1-06AAE7B24A45}"/>
               </a:ext>
             </a:extLst>
           </p:cNvPr>
@@ -9418,7 +9418,7 @@
           <p:cNvPr id="145" name="dp44-implementation-comparison / n128">
             <a:extLst xmlns:a="http://schemas.openxmlformats.org/drawingml/2006/main">
               <a:ext uri="{FF2B5EF4-FFF2-40B4-BE49-F238E27FC236}">
-                <a16:creationId xmlns:a16="http://schemas.microsoft.com/office/drawing/2014/main" id="{5B65AD69-3C87-4A33-968F-1515BAC8B5E8}"/>
+                <a16:creationId xmlns:a16="http://schemas.microsoft.com/office/drawing/2014/main" id="{93C07CA1-293A-4EC2-8E82-4ADE8BB28AB2}"/>
               </a:ext>
             </a:extLst>
           </p:cNvPr>
@@ -9451,7 +9451,7 @@
           <p:cNvPr id="146" name="dp44-implementation-comparison / n129">
             <a:extLst xmlns:a="http://schemas.openxmlformats.org/drawingml/2006/main">
               <a:ext uri="{FF2B5EF4-FFF2-40B4-BE49-F238E27FC236}">
-                <a16:creationId xmlns:a16="http://schemas.microsoft.com/office/drawing/2014/main" id="{61C4687A-3FAF-4DA1-99A6-3189DD434299}"/>
+                <a16:creationId xmlns:a16="http://schemas.microsoft.com/office/drawing/2014/main" id="{D70E09A8-206C-48DF-8F37-1982DC44F0CF}"/>
               </a:ext>
             </a:extLst>
           </p:cNvPr>
@@ -9484,7 +9484,7 @@
           <p:cNvPr id="147" name="dp44-implementation-comparison / n130 / text 1">
             <a:extLst xmlns:a="http://schemas.openxmlformats.org/drawingml/2006/main">
               <a:ext uri="{FF2B5EF4-FFF2-40B4-BE49-F238E27FC236}">
-                <a16:creationId xmlns:a16="http://schemas.microsoft.com/office/drawing/2014/main" id="{726C0EC5-3B43-4F29-AFC7-57C6BBC9F8C0}"/>
+                <a16:creationId xmlns:a16="http://schemas.microsoft.com/office/drawing/2014/main" id="{BDB02920-09C3-4C60-B5D4-19E57012C68B}"/>
               </a:ext>
             </a:extLst>
           </p:cNvPr>
@@ -9553,7 +9553,7 @@
           <p:cNvPr id="148" name="dp44-implementation-comparison / n131">
             <a:extLst xmlns:a="http://schemas.openxmlformats.org/drawingml/2006/main">
               <a:ext uri="{FF2B5EF4-FFF2-40B4-BE49-F238E27FC236}">
-                <a16:creationId xmlns:a16="http://schemas.microsoft.com/office/drawing/2014/main" id="{A635C2E4-CE36-42D8-95A2-AEED97A2FCA8}"/>
+                <a16:creationId xmlns:a16="http://schemas.microsoft.com/office/drawing/2014/main" id="{521FB23A-4882-43E1-883D-9162B4286558}"/>
               </a:ext>
             </a:extLst>
           </p:cNvPr>
@@ -9586,7 +9586,7 @@
           <p:cNvPr id="149" name="dp44-implementation-comparison / n132">
             <a:extLst xmlns:a="http://schemas.openxmlformats.org/drawingml/2006/main">
               <a:ext uri="{FF2B5EF4-FFF2-40B4-BE49-F238E27FC236}">
-                <a16:creationId xmlns:a16="http://schemas.microsoft.com/office/drawing/2014/main" id="{5BDBEF49-F0A0-462E-80F7-09C51FA8C179}"/>
+                <a16:creationId xmlns:a16="http://schemas.microsoft.com/office/drawing/2014/main" id="{CE1F7A94-0704-416B-AADD-00EECCDF1876}"/>
               </a:ext>
             </a:extLst>
           </p:cNvPr>
@@ -9619,7 +9619,7 @@
           <p:cNvPr id="150" name="dp44-implementation-comparison / n133">
             <a:extLst xmlns:a="http://schemas.openxmlformats.org/drawingml/2006/main">
               <a:ext uri="{FF2B5EF4-FFF2-40B4-BE49-F238E27FC236}">
-                <a16:creationId xmlns:a16="http://schemas.microsoft.com/office/drawing/2014/main" id="{623996D8-B345-4936-9EDF-444E06C39A5B}"/>
+                <a16:creationId xmlns:a16="http://schemas.microsoft.com/office/drawing/2014/main" id="{8B9DC508-D1ED-4913-B4AB-C7A38EA7857A}"/>
               </a:ext>
             </a:extLst>
           </p:cNvPr>
@@ -9652,7 +9652,7 @@
           <p:cNvPr id="151" name="dp44-implementation-comparison / n134">
             <a:extLst xmlns:a="http://schemas.openxmlformats.org/drawingml/2006/main">
               <a:ext uri="{FF2B5EF4-FFF2-40B4-BE49-F238E27FC236}">
-                <a16:creationId xmlns:a16="http://schemas.microsoft.com/office/drawing/2014/main" id="{2F01F0D6-AB36-4275-B9FC-5B587AAC493E}"/>
+                <a16:creationId xmlns:a16="http://schemas.microsoft.com/office/drawing/2014/main" id="{5357C65D-2217-4F9E-8897-21663CADFC58}"/>
               </a:ext>
             </a:extLst>
           </p:cNvPr>
@@ -9685,7 +9685,7 @@
           <p:cNvPr id="152" name="dp44-implementation-comparison / n135">
             <a:extLst xmlns:a="http://schemas.openxmlformats.org/drawingml/2006/main">
               <a:ext uri="{FF2B5EF4-FFF2-40B4-BE49-F238E27FC236}">
-                <a16:creationId xmlns:a16="http://schemas.microsoft.com/office/drawing/2014/main" id="{5893C526-6D8A-43F6-A1E7-5A4A18950A26}"/>
+                <a16:creationId xmlns:a16="http://schemas.microsoft.com/office/drawing/2014/main" id="{BBC9E0F2-8F66-4528-A7EA-973DFE39E48B}"/>
               </a:ext>
             </a:extLst>
           </p:cNvPr>
@@ -9718,7 +9718,7 @@
           <p:cNvPr id="153" name="dp44-implementation-comparison / n136 / text 1">
             <a:extLst xmlns:a="http://schemas.openxmlformats.org/drawingml/2006/main">
               <a:ext uri="{FF2B5EF4-FFF2-40B4-BE49-F238E27FC236}">
-                <a16:creationId xmlns:a16="http://schemas.microsoft.com/office/drawing/2014/main" id="{2EA62365-B2E6-4025-A20F-EFE8E4D12441}"/>
+                <a16:creationId xmlns:a16="http://schemas.microsoft.com/office/drawing/2014/main" id="{6FBCF918-E354-43D6-BB63-C1595D827623}"/>
               </a:ext>
             </a:extLst>
           </p:cNvPr>
@@ -9787,7 +9787,7 @@
           <p:cNvPr id="154" name="dp44-implementation-comparison / n137">
             <a:extLst xmlns:a="http://schemas.openxmlformats.org/drawingml/2006/main">
               <a:ext uri="{FF2B5EF4-FFF2-40B4-BE49-F238E27FC236}">
-                <a16:creationId xmlns:a16="http://schemas.microsoft.com/office/drawing/2014/main" id="{28714094-4DF4-4A5B-AC46-141FC1C7CF8C}"/>
+                <a16:creationId xmlns:a16="http://schemas.microsoft.com/office/drawing/2014/main" id="{109B3F12-5CF2-47D9-86EA-D7D8290C2A4F}"/>
               </a:ext>
             </a:extLst>
           </p:cNvPr>
@@ -9820,7 +9820,7 @@
           <p:cNvPr id="155" name="dp44-implementation-comparison / n138">
             <a:extLst xmlns:a="http://schemas.openxmlformats.org/drawingml/2006/main">
               <a:ext uri="{FF2B5EF4-FFF2-40B4-BE49-F238E27FC236}">
-                <a16:creationId xmlns:a16="http://schemas.microsoft.com/office/drawing/2014/main" id="{C6F09FC3-904B-45B1-A879-428C4AB4A0E4}"/>
+                <a16:creationId xmlns:a16="http://schemas.microsoft.com/office/drawing/2014/main" id="{9E0824D8-41B9-4EBF-9A99-DBDB7EE1174D}"/>
               </a:ext>
             </a:extLst>
           </p:cNvPr>
@@ -9853,7 +9853,7 @@
           <p:cNvPr id="156" name="dp44-implementation-comparison / n139">
             <a:extLst xmlns:a="http://schemas.openxmlformats.org/drawingml/2006/main">
               <a:ext uri="{FF2B5EF4-FFF2-40B4-BE49-F238E27FC236}">
-                <a16:creationId xmlns:a16="http://schemas.microsoft.com/office/drawing/2014/main" id="{CFDF6B3F-C265-41EB-8B1E-F60BEBF168F3}"/>
+                <a16:creationId xmlns:a16="http://schemas.microsoft.com/office/drawing/2014/main" id="{9A6CB52F-AAB7-4068-A606-B506D32D3038}"/>
               </a:ext>
             </a:extLst>
           </p:cNvPr>
@@ -9886,7 +9886,7 @@
           <p:cNvPr id="157" name="dp44-implementation-comparison / n140">
             <a:extLst xmlns:a="http://schemas.openxmlformats.org/drawingml/2006/main">
               <a:ext uri="{FF2B5EF4-FFF2-40B4-BE49-F238E27FC236}">
-                <a16:creationId xmlns:a16="http://schemas.microsoft.com/office/drawing/2014/main" id="{EA96EBD1-D11F-49B8-A8C0-ABFBAE325789}"/>
+                <a16:creationId xmlns:a16="http://schemas.microsoft.com/office/drawing/2014/main" id="{4859415F-E027-4A26-BCD7-79C2C88FB45F}"/>
               </a:ext>
             </a:extLst>
           </p:cNvPr>
@@ -9919,7 +9919,7 @@
           <p:cNvPr id="158" name="dp44-implementation-comparison / n141">
             <a:extLst xmlns:a="http://schemas.openxmlformats.org/drawingml/2006/main">
               <a:ext uri="{FF2B5EF4-FFF2-40B4-BE49-F238E27FC236}">
-                <a16:creationId xmlns:a16="http://schemas.microsoft.com/office/drawing/2014/main" id="{C47F193E-49C8-498E-8A92-D830F2C05AE4}"/>
+                <a16:creationId xmlns:a16="http://schemas.microsoft.com/office/drawing/2014/main" id="{2B01E2B3-DB71-49D7-95E7-B38FB49EE2AE}"/>
               </a:ext>
             </a:extLst>
           </p:cNvPr>
@@ -9952,7 +9952,7 @@
           <p:cNvPr id="159" name="dp44-implementation-comparison / n142 / text 1">
             <a:extLst xmlns:a="http://schemas.openxmlformats.org/drawingml/2006/main">
               <a:ext uri="{FF2B5EF4-FFF2-40B4-BE49-F238E27FC236}">
-                <a16:creationId xmlns:a16="http://schemas.microsoft.com/office/drawing/2014/main" id="{C91D90F2-06F2-4BEE-B310-0454C5CFCF25}"/>
+                <a16:creationId xmlns:a16="http://schemas.microsoft.com/office/drawing/2014/main" id="{FE038B19-2171-474F-8F2E-18AC685CA0D3}"/>
               </a:ext>
             </a:extLst>
           </p:cNvPr>
@@ -10021,7 +10021,7 @@
           <p:cNvPr id="160" name="dp44-implementation-comparison / n143">
             <a:extLst xmlns:a="http://schemas.openxmlformats.org/drawingml/2006/main">
               <a:ext uri="{FF2B5EF4-FFF2-40B4-BE49-F238E27FC236}">
-                <a16:creationId xmlns:a16="http://schemas.microsoft.com/office/drawing/2014/main" id="{CEDC8364-5B4A-4392-95EA-8B4E58EBA741}"/>
+                <a16:creationId xmlns:a16="http://schemas.microsoft.com/office/drawing/2014/main" id="{27CB2DCE-4140-4B33-AB71-D7F25026E583}"/>
               </a:ext>
             </a:extLst>
           </p:cNvPr>
@@ -10054,7 +10054,7 @@
           <p:cNvPr id="161" name="dp44-implementation-comparison / n144 / text 1">
             <a:extLst xmlns:a="http://schemas.openxmlformats.org/drawingml/2006/main">
               <a:ext uri="{FF2B5EF4-FFF2-40B4-BE49-F238E27FC236}">
-                <a16:creationId xmlns:a16="http://schemas.microsoft.com/office/drawing/2014/main" id="{9BB12441-BB30-4AAA-B8CC-2FA355546550}"/>
+                <a16:creationId xmlns:a16="http://schemas.microsoft.com/office/drawing/2014/main" id="{B2BF0A30-FDBF-4BCD-8FE8-DF3309AA0F25}"/>
               </a:ext>
             </a:extLst>
           </p:cNvPr>
@@ -10123,7 +10123,7 @@
           <p:cNvPr id="162" name="dp44-implementation-comparison / n145 / path">
             <a:extLst xmlns:a="http://schemas.openxmlformats.org/drawingml/2006/main">
               <a:ext uri="{FF2B5EF4-FFF2-40B4-BE49-F238E27FC236}">
-                <a16:creationId xmlns:a16="http://schemas.microsoft.com/office/drawing/2014/main" id="{728A68DB-CF2E-4242-9C72-4C3FA1402CFC}"/>
+                <a16:creationId xmlns:a16="http://schemas.microsoft.com/office/drawing/2014/main" id="{0CA496B7-D55A-4377-B866-ED66447D9A85}"/>
               </a:ext>
             </a:extLst>
           </p:cNvPr>
@@ -10169,7 +10169,7 @@
           <p:cNvPr id="163" name="dp44-implementation-comparison / n145 / arrow">
             <a:extLst xmlns:a="http://schemas.openxmlformats.org/drawingml/2006/main">
               <a:ext uri="{FF2B5EF4-FFF2-40B4-BE49-F238E27FC236}">
-                <a16:creationId xmlns:a16="http://schemas.microsoft.com/office/drawing/2014/main" id="{7B20B6A0-3F70-4DB4-93A9-3D97164A720E}"/>
+                <a16:creationId xmlns:a16="http://schemas.microsoft.com/office/drawing/2014/main" id="{2169F7BB-07C5-4D72-A448-717B836E407B}"/>
               </a:ext>
             </a:extLst>
           </p:cNvPr>
@@ -10212,7 +10212,7 @@
           <p:cNvPr id="164" name="dp44-implementation-comparison / n146">
             <a:extLst xmlns:a="http://schemas.openxmlformats.org/drawingml/2006/main">
               <a:ext uri="{FF2B5EF4-FFF2-40B4-BE49-F238E27FC236}">
-                <a16:creationId xmlns:a16="http://schemas.microsoft.com/office/drawing/2014/main" id="{227582D7-BE7A-4F06-B7F2-1403D77C4A9C}"/>
+                <a16:creationId xmlns:a16="http://schemas.microsoft.com/office/drawing/2014/main" id="{2A1BB82E-8ED9-4AC1-911B-A0B1A1FD9CDF}"/>
               </a:ext>
             </a:extLst>
           </p:cNvPr>
@@ -10245,7 +10245,7 @@
           <p:cNvPr id="165" name="dp44-implementation-comparison / n147 / text 1">
             <a:extLst xmlns:a="http://schemas.openxmlformats.org/drawingml/2006/main">
               <a:ext uri="{FF2B5EF4-FFF2-40B4-BE49-F238E27FC236}">
-                <a16:creationId xmlns:a16="http://schemas.microsoft.com/office/drawing/2014/main" id="{09740C40-0680-41BD-8E32-EBDAE0A14106}"/>
+                <a16:creationId xmlns:a16="http://schemas.microsoft.com/office/drawing/2014/main" id="{C8C22E12-BA4E-48AF-8772-EDA36EF02A16}"/>
               </a:ext>
             </a:extLst>
           </p:cNvPr>
@@ -10314,7 +10314,7 @@
           <p:cNvPr id="166" name="dp44-implementation-comparison / n148">
             <a:extLst xmlns:a="http://schemas.openxmlformats.org/drawingml/2006/main">
               <a:ext uri="{FF2B5EF4-FFF2-40B4-BE49-F238E27FC236}">
-                <a16:creationId xmlns:a16="http://schemas.microsoft.com/office/drawing/2014/main" id="{21A6EB1A-56CB-40A9-9853-A2F7EBBADE99}"/>
+                <a16:creationId xmlns:a16="http://schemas.microsoft.com/office/drawing/2014/main" id="{0D084819-478B-4BEE-8D3D-2ADC9241B408}"/>
               </a:ext>
             </a:extLst>
           </p:cNvPr>
@@ -10347,7 +10347,7 @@
           <p:cNvPr id="167" name="dp44-implementation-comparison / n149 / text 1">
             <a:extLst xmlns:a="http://schemas.openxmlformats.org/drawingml/2006/main">
               <a:ext uri="{FF2B5EF4-FFF2-40B4-BE49-F238E27FC236}">
-                <a16:creationId xmlns:a16="http://schemas.microsoft.com/office/drawing/2014/main" id="{22A27920-D4CF-4466-8750-FDE4CC85EB32}"/>
+                <a16:creationId xmlns:a16="http://schemas.microsoft.com/office/drawing/2014/main" id="{3C85A003-6611-4B9E-832E-A5B946026E1F}"/>
               </a:ext>
             </a:extLst>
           </p:cNvPr>
@@ -10416,7 +10416,7 @@
           <p:cNvPr id="168" name="dp44-implementation-comparison / n150">
             <a:extLst xmlns:a="http://schemas.openxmlformats.org/drawingml/2006/main">
               <a:ext uri="{FF2B5EF4-FFF2-40B4-BE49-F238E27FC236}">
-                <a16:creationId xmlns:a16="http://schemas.microsoft.com/office/drawing/2014/main" id="{E76D4F18-F7B5-43C8-915E-6AFFC0B06064}"/>
+                <a16:creationId xmlns:a16="http://schemas.microsoft.com/office/drawing/2014/main" id="{CD529999-A4E6-4554-A9B4-D3AAC46B5C59}"/>
               </a:ext>
             </a:extLst>
           </p:cNvPr>
@@ -10449,7 +10449,7 @@
           <p:cNvPr id="169" name="dp44-implementation-comparison / n151">
             <a:extLst xmlns:a="http://schemas.openxmlformats.org/drawingml/2006/main">
               <a:ext uri="{FF2B5EF4-FFF2-40B4-BE49-F238E27FC236}">
-                <a16:creationId xmlns:a16="http://schemas.microsoft.com/office/drawing/2014/main" id="{CEB3C593-BA58-494D-B771-FF26AC747FB4}"/>
+                <a16:creationId xmlns:a16="http://schemas.microsoft.com/office/drawing/2014/main" id="{D308271D-50BA-4B58-A82A-79685176F9D7}"/>
               </a:ext>
             </a:extLst>
           </p:cNvPr>
@@ -10482,7 +10482,7 @@
           <p:cNvPr id="170" name="dp44-implementation-comparison / n152">
             <a:extLst xmlns:a="http://schemas.openxmlformats.org/drawingml/2006/main">
               <a:ext uri="{FF2B5EF4-FFF2-40B4-BE49-F238E27FC236}">
-                <a16:creationId xmlns:a16="http://schemas.microsoft.com/office/drawing/2014/main" id="{CF4F47D8-A3A5-4EF5-B844-97ABB783BDD5}"/>
+                <a16:creationId xmlns:a16="http://schemas.microsoft.com/office/drawing/2014/main" id="{C8D41169-6141-462A-8866-EA713184CCAA}"/>
               </a:ext>
             </a:extLst>
           </p:cNvPr>
@@ -10515,7 +10515,7 @@
           <p:cNvPr id="171" name="dp44-implementation-comparison / n153">
             <a:extLst xmlns:a="http://schemas.openxmlformats.org/drawingml/2006/main">
               <a:ext uri="{FF2B5EF4-FFF2-40B4-BE49-F238E27FC236}">
-                <a16:creationId xmlns:a16="http://schemas.microsoft.com/office/drawing/2014/main" id="{0A7D4F56-4E95-4373-ADE0-325CA3ADCD38}"/>
+                <a16:creationId xmlns:a16="http://schemas.microsoft.com/office/drawing/2014/main" id="{72091D57-94A6-43F6-86BF-235763A4F8D2}"/>
               </a:ext>
             </a:extLst>
           </p:cNvPr>
@@ -10548,7 +10548,7 @@
           <p:cNvPr id="172" name="dp44-implementation-comparison / n154">
             <a:extLst xmlns:a="http://schemas.openxmlformats.org/drawingml/2006/main">
               <a:ext uri="{FF2B5EF4-FFF2-40B4-BE49-F238E27FC236}">
-                <a16:creationId xmlns:a16="http://schemas.microsoft.com/office/drawing/2014/main" id="{3F7AC839-7A8D-4018-8709-742D057F41B5}"/>
+                <a16:creationId xmlns:a16="http://schemas.microsoft.com/office/drawing/2014/main" id="{79607744-7C5A-4A48-9464-D82A4C301B39}"/>
               </a:ext>
             </a:extLst>
           </p:cNvPr>
@@ -10581,7 +10581,7 @@
           <p:cNvPr id="173" name="dp44-implementation-comparison / n155 / text 1">
             <a:extLst xmlns:a="http://schemas.openxmlformats.org/drawingml/2006/main">
               <a:ext uri="{FF2B5EF4-FFF2-40B4-BE49-F238E27FC236}">
-                <a16:creationId xmlns:a16="http://schemas.microsoft.com/office/drawing/2014/main" id="{B550FA5F-AD51-4582-9F99-EEBCCC68CC16}"/>
+                <a16:creationId xmlns:a16="http://schemas.microsoft.com/office/drawing/2014/main" id="{5F6796B2-A9A4-42A4-AAAE-A3137B446F97}"/>
               </a:ext>
             </a:extLst>
           </p:cNvPr>
@@ -10650,7 +10650,7 @@
           <p:cNvPr id="174" name="dp44-implementation-comparison / n156">
             <a:extLst xmlns:a="http://schemas.openxmlformats.org/drawingml/2006/main">
               <a:ext uri="{FF2B5EF4-FFF2-40B4-BE49-F238E27FC236}">
-                <a16:creationId xmlns:a16="http://schemas.microsoft.com/office/drawing/2014/main" id="{BCD121F3-0691-4C4A-94FB-8E8BD387D335}"/>
+                <a16:creationId xmlns:a16="http://schemas.microsoft.com/office/drawing/2014/main" id="{E58BDE10-12BE-4444-AE13-3D307E479F8B}"/>
               </a:ext>
             </a:extLst>
           </p:cNvPr>
@@ -10683,7 +10683,7 @@
           <p:cNvPr id="175" name="dp44-implementation-comparison / n157">
             <a:extLst xmlns:a="http://schemas.openxmlformats.org/drawingml/2006/main">
               <a:ext uri="{FF2B5EF4-FFF2-40B4-BE49-F238E27FC236}">
-                <a16:creationId xmlns:a16="http://schemas.microsoft.com/office/drawing/2014/main" id="{9C25AA45-9480-4857-B5EA-4BD98822CE56}"/>
+                <a16:creationId xmlns:a16="http://schemas.microsoft.com/office/drawing/2014/main" id="{28DBD0AD-E581-45BE-BA73-C43B06214007}"/>
               </a:ext>
             </a:extLst>
           </p:cNvPr>
@@ -10716,7 +10716,7 @@
           <p:cNvPr id="176" name="dp44-implementation-comparison / n158">
             <a:extLst xmlns:a="http://schemas.openxmlformats.org/drawingml/2006/main">
               <a:ext uri="{FF2B5EF4-FFF2-40B4-BE49-F238E27FC236}">
-                <a16:creationId xmlns:a16="http://schemas.microsoft.com/office/drawing/2014/main" id="{F9BB5F6A-A196-4E86-98AF-D44B098A9A79}"/>
+                <a16:creationId xmlns:a16="http://schemas.microsoft.com/office/drawing/2014/main" id="{A3A9FA7B-DEE1-43DE-9603-40DB2CB98B0A}"/>
               </a:ext>
             </a:extLst>
           </p:cNvPr>
@@ -10749,7 +10749,7 @@
           <p:cNvPr id="177" name="dp44-implementation-comparison / n159">
             <a:extLst xmlns:a="http://schemas.openxmlformats.org/drawingml/2006/main">
               <a:ext uri="{FF2B5EF4-FFF2-40B4-BE49-F238E27FC236}">
-                <a16:creationId xmlns:a16="http://schemas.microsoft.com/office/drawing/2014/main" id="{8F807F80-1D3B-4C88-A696-B186DD21BD91}"/>
+                <a16:creationId xmlns:a16="http://schemas.microsoft.com/office/drawing/2014/main" id="{CE088E17-4CAD-4AE0-AA2F-359E26A0C8C6}"/>
               </a:ext>
             </a:extLst>
           </p:cNvPr>
@@ -10782,7 +10782,7 @@
           <p:cNvPr id="178" name="dp44-implementation-comparison / n160">
             <a:extLst xmlns:a="http://schemas.openxmlformats.org/drawingml/2006/main">
               <a:ext uri="{FF2B5EF4-FFF2-40B4-BE49-F238E27FC236}">
-                <a16:creationId xmlns:a16="http://schemas.microsoft.com/office/drawing/2014/main" id="{2841AB4B-3527-41E1-A603-AEAA6B14B2CB}"/>
+                <a16:creationId xmlns:a16="http://schemas.microsoft.com/office/drawing/2014/main" id="{7D6EC768-F89B-4D7A-A12A-110DC3EC2E58}"/>
               </a:ext>
             </a:extLst>
           </p:cNvPr>
@@ -10815,7 +10815,7 @@
           <p:cNvPr id="179" name="dp44-implementation-comparison / n161 / text 1">
             <a:extLst xmlns:a="http://schemas.openxmlformats.org/drawingml/2006/main">
               <a:ext uri="{FF2B5EF4-FFF2-40B4-BE49-F238E27FC236}">
-                <a16:creationId xmlns:a16="http://schemas.microsoft.com/office/drawing/2014/main" id="{74DA2CDC-EEE9-47B4-9F37-AF7BE09A2A18}"/>
+                <a16:creationId xmlns:a16="http://schemas.microsoft.com/office/drawing/2014/main" id="{C452F4C9-B896-48B2-B00B-3CE034A0BD17}"/>
               </a:ext>
             </a:extLst>
           </p:cNvPr>
@@ -10884,7 +10884,7 @@
           <p:cNvPr id="180" name="dp44-implementation-comparison / n162">
             <a:extLst xmlns:a="http://schemas.openxmlformats.org/drawingml/2006/main">
               <a:ext uri="{FF2B5EF4-FFF2-40B4-BE49-F238E27FC236}">
-                <a16:creationId xmlns:a16="http://schemas.microsoft.com/office/drawing/2014/main" id="{9EA9A7BD-65AD-4545-BAD9-A9071B4F1B90}"/>
+                <a16:creationId xmlns:a16="http://schemas.microsoft.com/office/drawing/2014/main" id="{9D2644A2-2320-44B8-A865-81C8A22F5E56}"/>
               </a:ext>
             </a:extLst>
           </p:cNvPr>
@@ -10917,7 +10917,7 @@
           <p:cNvPr id="181" name="dp44-implementation-comparison / n163">
             <a:extLst xmlns:a="http://schemas.openxmlformats.org/drawingml/2006/main">
               <a:ext uri="{FF2B5EF4-FFF2-40B4-BE49-F238E27FC236}">
-                <a16:creationId xmlns:a16="http://schemas.microsoft.com/office/drawing/2014/main" id="{41AC44E4-37C7-4AEA-B509-61910F725E98}"/>
+                <a16:creationId xmlns:a16="http://schemas.microsoft.com/office/drawing/2014/main" id="{A9ADA347-33FD-4FB1-A3F6-6EB41383B10E}"/>
               </a:ext>
             </a:extLst>
           </p:cNvPr>
@@ -10950,7 +10950,7 @@
           <p:cNvPr id="182" name="dp44-implementation-comparison / n164">
             <a:extLst xmlns:a="http://schemas.openxmlformats.org/drawingml/2006/main">
               <a:ext uri="{FF2B5EF4-FFF2-40B4-BE49-F238E27FC236}">
-                <a16:creationId xmlns:a16="http://schemas.microsoft.com/office/drawing/2014/main" id="{963B28C2-F70B-4B41-B6E9-AADDFDBAD136}"/>
+                <a16:creationId xmlns:a16="http://schemas.microsoft.com/office/drawing/2014/main" id="{23415F49-760F-4B00-9764-0376C6FA1DD7}"/>
               </a:ext>
             </a:extLst>
           </p:cNvPr>
@@ -10983,7 +10983,7 @@
           <p:cNvPr id="183" name="dp44-implementation-comparison / n165">
             <a:extLst xmlns:a="http://schemas.openxmlformats.org/drawingml/2006/main">
               <a:ext uri="{FF2B5EF4-FFF2-40B4-BE49-F238E27FC236}">
-                <a16:creationId xmlns:a16="http://schemas.microsoft.com/office/drawing/2014/main" id="{63FFEA61-DD79-4BAF-8351-E2503015C151}"/>
+                <a16:creationId xmlns:a16="http://schemas.microsoft.com/office/drawing/2014/main" id="{57FD2A73-1EFB-4C52-9DE3-4D1D8DB9ED94}"/>
               </a:ext>
             </a:extLst>
           </p:cNvPr>
@@ -11016,7 +11016,7 @@
           <p:cNvPr id="184" name="dp44-implementation-comparison / n166">
             <a:extLst xmlns:a="http://schemas.openxmlformats.org/drawingml/2006/main">
               <a:ext uri="{FF2B5EF4-FFF2-40B4-BE49-F238E27FC236}">
-                <a16:creationId xmlns:a16="http://schemas.microsoft.com/office/drawing/2014/main" id="{E1C0E7EB-FC10-4341-9FD9-FC57BD634798}"/>
+                <a16:creationId xmlns:a16="http://schemas.microsoft.com/office/drawing/2014/main" id="{41E73458-8C6D-41DD-8EA9-8B393A8FF775}"/>
               </a:ext>
             </a:extLst>
           </p:cNvPr>
@@ -11049,7 +11049,7 @@
           <p:cNvPr id="185" name="dp44-implementation-comparison / n167 / text 1">
             <a:extLst xmlns:a="http://schemas.openxmlformats.org/drawingml/2006/main">
               <a:ext uri="{FF2B5EF4-FFF2-40B4-BE49-F238E27FC236}">
-                <a16:creationId xmlns:a16="http://schemas.microsoft.com/office/drawing/2014/main" id="{C702D8BB-5478-4FE9-B05A-798C6CA31B8F}"/>
+                <a16:creationId xmlns:a16="http://schemas.microsoft.com/office/drawing/2014/main" id="{100BDC16-D52F-4972-A95B-9A722CE06624}"/>
               </a:ext>
             </a:extLst>
           </p:cNvPr>
@@ -11118,7 +11118,7 @@
           <p:cNvPr id="186" name="dp44-implementation-comparison / n168">
             <a:extLst xmlns:a="http://schemas.openxmlformats.org/drawingml/2006/main">
               <a:ext uri="{FF2B5EF4-FFF2-40B4-BE49-F238E27FC236}">
-                <a16:creationId xmlns:a16="http://schemas.microsoft.com/office/drawing/2014/main" id="{E0456B8E-66BE-47E4-88F1-20C6C0FBD01C}"/>
+                <a16:creationId xmlns:a16="http://schemas.microsoft.com/office/drawing/2014/main" id="{130B2985-1624-4F7E-AB0F-B6BDE94EB058}"/>
               </a:ext>
             </a:extLst>
           </p:cNvPr>
@@ -11151,7 +11151,7 @@
           <p:cNvPr id="187" name="dp44-implementation-comparison / n169 / text 1">
             <a:extLst xmlns:a="http://schemas.openxmlformats.org/drawingml/2006/main">
               <a:ext uri="{FF2B5EF4-FFF2-40B4-BE49-F238E27FC236}">
-                <a16:creationId xmlns:a16="http://schemas.microsoft.com/office/drawing/2014/main" id="{4A3528D6-B505-42A7-8922-FDB35DB9DD42}"/>
+                <a16:creationId xmlns:a16="http://schemas.microsoft.com/office/drawing/2014/main" id="{61790563-8D59-4A44-9ADF-985286B7E987}"/>
               </a:ext>
             </a:extLst>
           </p:cNvPr>
@@ -11220,7 +11220,7 @@
           <p:cNvPr id="188" name="dp44-implementation-comparison / n170 / path">
             <a:extLst xmlns:a="http://schemas.openxmlformats.org/drawingml/2006/main">
               <a:ext uri="{FF2B5EF4-FFF2-40B4-BE49-F238E27FC236}">
-                <a16:creationId xmlns:a16="http://schemas.microsoft.com/office/drawing/2014/main" id="{483C52B6-D2D2-4D93-A67B-A88DD8720986}"/>
+                <a16:creationId xmlns:a16="http://schemas.microsoft.com/office/drawing/2014/main" id="{3713F355-39EF-4D61-86C7-7215852F8BBE}"/>
               </a:ext>
             </a:extLst>
           </p:cNvPr>
@@ -11260,7 +11260,7 @@
           <p:cNvPr id="189" name="dp44-implementation-comparison / n170 / arrow">
             <a:extLst xmlns:a="http://schemas.openxmlformats.org/drawingml/2006/main">
               <a:ext uri="{FF2B5EF4-FFF2-40B4-BE49-F238E27FC236}">
-                <a16:creationId xmlns:a16="http://schemas.microsoft.com/office/drawing/2014/main" id="{E09D779C-FDB7-4133-8005-F5832F1BB1DA}"/>
+                <a16:creationId xmlns:a16="http://schemas.microsoft.com/office/drawing/2014/main" id="{28B03D4A-F9C2-4110-8230-5E65ADD7BB49}"/>
               </a:ext>
             </a:extLst>
           </p:cNvPr>
@@ -11303,28 +11303,28 @@
           <p:cNvPr id="190" name="dp44-implementation-comparison / n171 / path">
             <a:extLst xmlns:a="http://schemas.openxmlformats.org/drawingml/2006/main">
               <a:ext uri="{FF2B5EF4-FFF2-40B4-BE49-F238E27FC236}">
-                <a16:creationId xmlns:a16="http://schemas.microsoft.com/office/drawing/2014/main" id="{A4FB05C5-5929-48B7-91E9-FAA615EC6D23}"/>
-              </a:ext>
-            </a:extLst>
-          </p:cNvPr>
-          <p:cNvSpPr>
-            <a:spLocks xmlns:a="http://schemas.openxmlformats.org/drawingml/2006/main" noGrp="1"/>
-          </p:cNvSpPr>
-          <p:nvPr/>
-        </p:nvSpPr>
-        <p:spPr>
-          <a:xfrm xmlns:a="http://schemas.openxmlformats.org/drawingml/2006/main">
-            <a:off x="12477750" y="4972050"/>
-            <a:ext cx="3200400" cy="628650"/>
+                <a16:creationId xmlns:a16="http://schemas.microsoft.com/office/drawing/2014/main" id="{26635A38-FEFE-4CB6-9063-1346AC3E77D3}"/>
+              </a:ext>
+            </a:extLst>
+          </p:cNvPr>
+          <p:cNvSpPr>
+            <a:spLocks xmlns:a="http://schemas.openxmlformats.org/drawingml/2006/main" noGrp="1"/>
+          </p:cNvSpPr>
+          <p:nvPr/>
+        </p:nvSpPr>
+        <p:spPr>
+          <a:xfrm xmlns:a="http://schemas.openxmlformats.org/drawingml/2006/main">
+            <a:off x="11811000" y="4972050"/>
+            <a:ext cx="3867150" cy="628650"/>
           </a:xfrm>
           <a:custGeom xmlns:a="http://schemas.openxmlformats.org/drawingml/2006/main">
             <a:pathLst>
-              <a:path w="3200400" h="628650">
+              <a:path w="3867150" h="628650">
                 <a:moveTo>
-                  <a:pt x="3200400" y="0"/>
+                  <a:pt x="3867150" y="0"/>
                 </a:moveTo>
                 <a:lnTo>
-                  <a:pt x="3200400" y="161925"/>
+                  <a:pt x="3867150" y="161925"/>
                 </a:lnTo>
                 <a:lnTo>
                   <a:pt x="0" y="161925"/>
@@ -11349,18 +11349,18 @@
           <p:cNvPr id="191" name="dp44-implementation-comparison / n171 / arrow">
             <a:extLst xmlns:a="http://schemas.openxmlformats.org/drawingml/2006/main">
               <a:ext uri="{FF2B5EF4-FFF2-40B4-BE49-F238E27FC236}">
-                <a16:creationId xmlns:a16="http://schemas.microsoft.com/office/drawing/2014/main" id="{69685FF1-97D4-4476-90B7-A4C0C8949362}"/>
-              </a:ext>
-            </a:extLst>
-          </p:cNvPr>
-          <p:cNvSpPr>
-            <a:spLocks xmlns:a="http://schemas.openxmlformats.org/drawingml/2006/main" noGrp="1"/>
-          </p:cNvSpPr>
-          <p:nvPr/>
-        </p:nvSpPr>
-        <p:spPr>
-          <a:xfrm xmlns:a="http://schemas.openxmlformats.org/drawingml/2006/main">
-            <a:off x="12416790" y="5478780"/>
+                <a16:creationId xmlns:a16="http://schemas.microsoft.com/office/drawing/2014/main" id="{EF12B08B-0417-4477-A3D7-86B07E98F703}"/>
+              </a:ext>
+            </a:extLst>
+          </p:cNvPr>
+          <p:cNvSpPr>
+            <a:spLocks xmlns:a="http://schemas.openxmlformats.org/drawingml/2006/main" noGrp="1"/>
+          </p:cNvSpPr>
+          <p:nvPr/>
+        </p:nvSpPr>
+        <p:spPr>
+          <a:xfrm xmlns:a="http://schemas.openxmlformats.org/drawingml/2006/main">
+            <a:off x="11750040" y="5478780"/>
             <a:ext cx="121920" cy="121920"/>
           </a:xfrm>
           <a:custGeom xmlns:a="http://schemas.openxmlformats.org/drawingml/2006/main">
@@ -11392,28 +11392,37 @@
           <p:cNvPr id="192" name="dp44-implementation-comparison / n172 / path">
             <a:extLst xmlns:a="http://schemas.openxmlformats.org/drawingml/2006/main">
               <a:ext uri="{FF2B5EF4-FFF2-40B4-BE49-F238E27FC236}">
-                <a16:creationId xmlns:a16="http://schemas.microsoft.com/office/drawing/2014/main" id="{FBA147CE-945C-4BE0-9BF1-C4EF4C063769}"/>
-              </a:ext>
-            </a:extLst>
-          </p:cNvPr>
-          <p:cNvSpPr>
-            <a:spLocks xmlns:a="http://schemas.openxmlformats.org/drawingml/2006/main" noGrp="1"/>
-          </p:cNvSpPr>
-          <p:nvPr/>
-        </p:nvSpPr>
-        <p:spPr>
-          <a:xfrm xmlns:a="http://schemas.openxmlformats.org/drawingml/2006/main">
-            <a:off x="13525500" y="6248400"/>
-            <a:ext cx="209550" cy="953"/>
+                <a16:creationId xmlns:a16="http://schemas.microsoft.com/office/drawing/2014/main" id="{F2583646-06D2-48D0-BD9D-3CF82B3EF76C}"/>
+              </a:ext>
+            </a:extLst>
+          </p:cNvPr>
+          <p:cNvSpPr>
+            <a:spLocks xmlns:a="http://schemas.openxmlformats.org/drawingml/2006/main" noGrp="1"/>
+          </p:cNvSpPr>
+          <p:nvPr/>
+        </p:nvSpPr>
+        <p:spPr>
+          <a:xfrm xmlns:a="http://schemas.openxmlformats.org/drawingml/2006/main">
+            <a:off x="13525500" y="5838825"/>
+            <a:ext cx="2152650" cy="409575"/>
           </a:xfrm>
           <a:custGeom xmlns:a="http://schemas.openxmlformats.org/drawingml/2006/main">
             <a:pathLst>
-              <a:path w="209550" h="953">
+              <a:path w="2152650" h="409575">
                 <a:moveTo>
-                  <a:pt x="0" y="0"/>
+                  <a:pt x="0" y="409575"/>
                 </a:moveTo>
                 <a:lnTo>
-                  <a:pt x="209550" y="0"/>
+                  <a:pt x="171450" y="409575"/>
+                </a:lnTo>
+                <a:lnTo>
+                  <a:pt x="171450" y="0"/>
+                </a:lnTo>
+                <a:lnTo>
+                  <a:pt x="2152650" y="0"/>
+                </a:lnTo>
+                <a:lnTo>
+                  <a:pt x="2152650" y="161925"/>
                 </a:lnTo>
               </a:path>
             </a:pathLst>
@@ -11432,18 +11441,1148 @@
           <p:cNvPr id="193" name="dp44-implementation-comparison / n172 / arrow">
             <a:extLst xmlns:a="http://schemas.openxmlformats.org/drawingml/2006/main">
               <a:ext uri="{FF2B5EF4-FFF2-40B4-BE49-F238E27FC236}">
-                <a16:creationId xmlns:a16="http://schemas.microsoft.com/office/drawing/2014/main" id="{23744343-E18C-41E2-A7AC-A50B6074E17E}"/>
-              </a:ext>
-            </a:extLst>
-          </p:cNvPr>
-          <p:cNvSpPr>
-            <a:spLocks xmlns:a="http://schemas.openxmlformats.org/drawingml/2006/main" noGrp="1"/>
-          </p:cNvSpPr>
-          <p:nvPr/>
-        </p:nvSpPr>
-        <p:spPr>
-          <a:xfrm xmlns:a="http://schemas.openxmlformats.org/drawingml/2006/main">
-            <a:off x="13613130" y="6187440"/>
+                <a16:creationId xmlns:a16="http://schemas.microsoft.com/office/drawing/2014/main" id="{39440E9E-D65A-49AF-92EB-521B5592ECF0}"/>
+              </a:ext>
+            </a:extLst>
+          </p:cNvPr>
+          <p:cNvSpPr>
+            <a:spLocks xmlns:a="http://schemas.openxmlformats.org/drawingml/2006/main" noGrp="1"/>
+          </p:cNvSpPr>
+          <p:nvPr/>
+        </p:nvSpPr>
+        <p:spPr>
+          <a:xfrm xmlns:a="http://schemas.openxmlformats.org/drawingml/2006/main">
+            <a:off x="15617190" y="5878830"/>
+            <a:ext cx="121920" cy="121920"/>
+          </a:xfrm>
+          <a:custGeom xmlns:a="http://schemas.openxmlformats.org/drawingml/2006/main">
+            <a:pathLst>
+              <a:path w="121920" h="121920">
+                <a:moveTo>
+                  <a:pt x="0" y="0"/>
+                </a:moveTo>
+                <a:lnTo>
+                  <a:pt x="60960" y="121920"/>
+                </a:lnTo>
+                <a:lnTo>
+                  <a:pt x="121920" y="0"/>
+                </a:lnTo>
+              </a:path>
+            </a:pathLst>
+          </a:custGeom>
+          <a:noFill xmlns:a="http://schemas.openxmlformats.org/drawingml/2006/main"/>
+          <a:ln xmlns:a="http://schemas.openxmlformats.org/drawingml/2006/main" w="24384">
+            <a:solidFill>
+              <a:srgbClr val="2858A5"/>
+            </a:solidFill>
+            <a:prstDash val="solid"/>
+          </a:ln>
+        </p:spPr>
+      </p:sp>
+      <p:sp>
+        <p:nvSpPr>
+          <p:cNvPr id="194" name="dp44-implementation-comparison / n173 / path">
+            <a:extLst xmlns:a="http://schemas.openxmlformats.org/drawingml/2006/main">
+              <a:ext uri="{FF2B5EF4-FFF2-40B4-BE49-F238E27FC236}">
+                <a16:creationId xmlns:a16="http://schemas.microsoft.com/office/drawing/2014/main" id="{8C115B19-9492-474A-B42C-7F5EFC65E474}"/>
+              </a:ext>
+            </a:extLst>
+          </p:cNvPr>
+          <p:cNvSpPr>
+            <a:spLocks xmlns:a="http://schemas.openxmlformats.org/drawingml/2006/main" noGrp="1"/>
+          </p:cNvSpPr>
+          <p:nvPr/>
+        </p:nvSpPr>
+        <p:spPr>
+          <a:xfrm xmlns:a="http://schemas.openxmlformats.org/drawingml/2006/main">
+            <a:off x="15678150" y="4972050"/>
+            <a:ext cx="1295400" cy="1028700"/>
+          </a:xfrm>
+          <a:custGeom xmlns:a="http://schemas.openxmlformats.org/drawingml/2006/main">
+            <a:pathLst>
+              <a:path w="1295400" h="1028700">
+                <a:moveTo>
+                  <a:pt x="0" y="0"/>
+                </a:moveTo>
+                <a:lnTo>
+                  <a:pt x="0" y="238125"/>
+                </a:lnTo>
+                <a:lnTo>
+                  <a:pt x="1295400" y="238125"/>
+                </a:lnTo>
+                <a:lnTo>
+                  <a:pt x="1295400" y="1028700"/>
+                </a:lnTo>
+              </a:path>
+            </a:pathLst>
+          </a:custGeom>
+          <a:noFill xmlns:a="http://schemas.openxmlformats.org/drawingml/2006/main"/>
+          <a:ln xmlns:a="http://schemas.openxmlformats.org/drawingml/2006/main" w="19050">
+            <a:solidFill>
+              <a:srgbClr val="2858A5"/>
+            </a:solidFill>
+            <a:prstDash val="solid"/>
+          </a:ln>
+        </p:spPr>
+      </p:sp>
+      <p:sp>
+        <p:nvSpPr>
+          <p:cNvPr id="195" name="dp44-implementation-comparison / n173 / arrow">
+            <a:extLst xmlns:a="http://schemas.openxmlformats.org/drawingml/2006/main">
+              <a:ext uri="{FF2B5EF4-FFF2-40B4-BE49-F238E27FC236}">
+                <a16:creationId xmlns:a16="http://schemas.microsoft.com/office/drawing/2014/main" id="{F1687FBD-ACF7-49AA-B26D-37B24486A200}"/>
+              </a:ext>
+            </a:extLst>
+          </p:cNvPr>
+          <p:cNvSpPr>
+            <a:spLocks xmlns:a="http://schemas.openxmlformats.org/drawingml/2006/main" noGrp="1"/>
+          </p:cNvSpPr>
+          <p:nvPr/>
+        </p:nvSpPr>
+        <p:spPr>
+          <a:xfrm xmlns:a="http://schemas.openxmlformats.org/drawingml/2006/main">
+            <a:off x="16912590" y="5878830"/>
+            <a:ext cx="121920" cy="121920"/>
+          </a:xfrm>
+          <a:custGeom xmlns:a="http://schemas.openxmlformats.org/drawingml/2006/main">
+            <a:pathLst>
+              <a:path w="121920" h="121920">
+                <a:moveTo>
+                  <a:pt x="0" y="0"/>
+                </a:moveTo>
+                <a:lnTo>
+                  <a:pt x="60960" y="121920"/>
+                </a:lnTo>
+                <a:lnTo>
+                  <a:pt x="121920" y="0"/>
+                </a:lnTo>
+              </a:path>
+            </a:pathLst>
+          </a:custGeom>
+          <a:noFill xmlns:a="http://schemas.openxmlformats.org/drawingml/2006/main"/>
+          <a:ln xmlns:a="http://schemas.openxmlformats.org/drawingml/2006/main" w="24384">
+            <a:solidFill>
+              <a:srgbClr val="2858A5"/>
+            </a:solidFill>
+            <a:prstDash val="solid"/>
+          </a:ln>
+        </p:spPr>
+      </p:sp>
+      <p:sp>
+        <p:nvSpPr>
+          <p:cNvPr id="196" name="dp44-implementation-comparison / n174 / path">
+            <a:extLst xmlns:a="http://schemas.openxmlformats.org/drawingml/2006/main">
+              <a:ext uri="{FF2B5EF4-FFF2-40B4-BE49-F238E27FC236}">
+                <a16:creationId xmlns:a16="http://schemas.microsoft.com/office/drawing/2014/main" id="{7B95A32B-001E-4D66-B5DD-EF9EE68074A4}"/>
+              </a:ext>
+            </a:extLst>
+          </p:cNvPr>
+          <p:cNvSpPr>
+            <a:spLocks xmlns:a="http://schemas.openxmlformats.org/drawingml/2006/main" noGrp="1"/>
+          </p:cNvSpPr>
+          <p:nvPr/>
+        </p:nvSpPr>
+        <p:spPr>
+          <a:xfrm xmlns:a="http://schemas.openxmlformats.org/drawingml/2006/main">
+            <a:off x="12954000" y="4972050"/>
+            <a:ext cx="4733925" cy="1266825"/>
+          </a:xfrm>
+          <a:custGeom xmlns:a="http://schemas.openxmlformats.org/drawingml/2006/main">
+            <a:pathLst>
+              <a:path w="4733925" h="1266825">
+                <a:moveTo>
+                  <a:pt x="0" y="0"/>
+                </a:moveTo>
+                <a:lnTo>
+                  <a:pt x="0" y="95250"/>
+                </a:lnTo>
+                <a:lnTo>
+                  <a:pt x="4733925" y="95250"/>
+                </a:lnTo>
+                <a:lnTo>
+                  <a:pt x="4733925" y="1266825"/>
+                </a:lnTo>
+                <a:lnTo>
+                  <a:pt x="4572000" y="1266825"/>
+                </a:lnTo>
+              </a:path>
+            </a:pathLst>
+          </a:custGeom>
+          <a:noFill xmlns:a="http://schemas.openxmlformats.org/drawingml/2006/main"/>
+          <a:ln xmlns:a="http://schemas.openxmlformats.org/drawingml/2006/main" w="19050">
+            <a:solidFill>
+              <a:srgbClr val="2858A5"/>
+            </a:solidFill>
+            <a:prstDash val="solid"/>
+          </a:ln>
+        </p:spPr>
+      </p:sp>
+      <p:sp>
+        <p:nvSpPr>
+          <p:cNvPr id="197" name="dp44-implementation-comparison / n174 / arrow">
+            <a:extLst xmlns:a="http://schemas.openxmlformats.org/drawingml/2006/main">
+              <a:ext uri="{FF2B5EF4-FFF2-40B4-BE49-F238E27FC236}">
+                <a16:creationId xmlns:a16="http://schemas.microsoft.com/office/drawing/2014/main" id="{AA2D7968-0B5C-47AA-83D0-BA1D384108F8}"/>
+              </a:ext>
+            </a:extLst>
+          </p:cNvPr>
+          <p:cNvSpPr>
+            <a:spLocks xmlns:a="http://schemas.openxmlformats.org/drawingml/2006/main" noGrp="1"/>
+          </p:cNvSpPr>
+          <p:nvPr/>
+        </p:nvSpPr>
+        <p:spPr>
+          <a:xfrm xmlns:a="http://schemas.openxmlformats.org/drawingml/2006/main">
+            <a:off x="17526000" y="6177915"/>
+            <a:ext cx="121920" cy="121920"/>
+          </a:xfrm>
+          <a:custGeom xmlns:a="http://schemas.openxmlformats.org/drawingml/2006/main">
+            <a:pathLst>
+              <a:path w="121920" h="121920">
+                <a:moveTo>
+                  <a:pt x="121920" y="0"/>
+                </a:moveTo>
+                <a:lnTo>
+                  <a:pt x="0" y="60960"/>
+                </a:lnTo>
+                <a:lnTo>
+                  <a:pt x="121920" y="121920"/>
+                </a:lnTo>
+              </a:path>
+            </a:pathLst>
+          </a:custGeom>
+          <a:noFill xmlns:a="http://schemas.openxmlformats.org/drawingml/2006/main"/>
+          <a:ln xmlns:a="http://schemas.openxmlformats.org/drawingml/2006/main" w="24384">
+            <a:solidFill>
+              <a:srgbClr val="2858A5"/>
+            </a:solidFill>
+            <a:prstDash val="solid"/>
+          </a:ln>
+        </p:spPr>
+      </p:sp>
+      <p:sp>
+        <p:nvSpPr>
+          <p:cNvPr id="198" name="dp44-implementation-comparison / n175 / path">
+            <a:extLst xmlns:a="http://schemas.openxmlformats.org/drawingml/2006/main">
+              <a:ext uri="{FF2B5EF4-FFF2-40B4-BE49-F238E27FC236}">
+                <a16:creationId xmlns:a16="http://schemas.microsoft.com/office/drawing/2014/main" id="{7409D589-CDE5-40BD-BCBE-D7A11D2E0AC8}"/>
+              </a:ext>
+            </a:extLst>
+          </p:cNvPr>
+          <p:cNvSpPr>
+            <a:spLocks xmlns:a="http://schemas.openxmlformats.org/drawingml/2006/main" noGrp="1"/>
+          </p:cNvSpPr>
+          <p:nvPr/>
+        </p:nvSpPr>
+        <p:spPr>
+          <a:xfrm xmlns:a="http://schemas.openxmlformats.org/drawingml/2006/main">
+            <a:off x="15678150" y="7334250"/>
+            <a:ext cx="953" cy="200025"/>
+          </a:xfrm>
+          <a:custGeom xmlns:a="http://schemas.openxmlformats.org/drawingml/2006/main">
+            <a:pathLst>
+              <a:path w="953" h="200025">
+                <a:moveTo>
+                  <a:pt x="0" y="0"/>
+                </a:moveTo>
+                <a:lnTo>
+                  <a:pt x="0" y="200025"/>
+                </a:lnTo>
+              </a:path>
+            </a:pathLst>
+          </a:custGeom>
+          <a:noFill xmlns:a="http://schemas.openxmlformats.org/drawingml/2006/main"/>
+          <a:ln xmlns:a="http://schemas.openxmlformats.org/drawingml/2006/main" w="19050">
+            <a:solidFill>
+              <a:srgbClr val="2858A5"/>
+            </a:solidFill>
+            <a:prstDash val="solid"/>
+          </a:ln>
+        </p:spPr>
+      </p:sp>
+      <p:sp>
+        <p:nvSpPr>
+          <p:cNvPr id="199" name="dp44-implementation-comparison / n175 / arrow">
+            <a:extLst xmlns:a="http://schemas.openxmlformats.org/drawingml/2006/main">
+              <a:ext uri="{FF2B5EF4-FFF2-40B4-BE49-F238E27FC236}">
+                <a16:creationId xmlns:a16="http://schemas.microsoft.com/office/drawing/2014/main" id="{3350961C-2E9D-4DDD-BD3D-713957569B56}"/>
+              </a:ext>
+            </a:extLst>
+          </p:cNvPr>
+          <p:cNvSpPr>
+            <a:spLocks xmlns:a="http://schemas.openxmlformats.org/drawingml/2006/main" noGrp="1"/>
+          </p:cNvSpPr>
+          <p:nvPr/>
+        </p:nvSpPr>
+        <p:spPr>
+          <a:xfrm xmlns:a="http://schemas.openxmlformats.org/drawingml/2006/main">
+            <a:off x="15617190" y="7412355"/>
+            <a:ext cx="121920" cy="121920"/>
+          </a:xfrm>
+          <a:custGeom xmlns:a="http://schemas.openxmlformats.org/drawingml/2006/main">
+            <a:pathLst>
+              <a:path w="121920" h="121920">
+                <a:moveTo>
+                  <a:pt x="0" y="0"/>
+                </a:moveTo>
+                <a:lnTo>
+                  <a:pt x="60960" y="121920"/>
+                </a:lnTo>
+                <a:lnTo>
+                  <a:pt x="121920" y="0"/>
+                </a:lnTo>
+              </a:path>
+            </a:pathLst>
+          </a:custGeom>
+          <a:noFill xmlns:a="http://schemas.openxmlformats.org/drawingml/2006/main"/>
+          <a:ln xmlns:a="http://schemas.openxmlformats.org/drawingml/2006/main" w="24384">
+            <a:solidFill>
+              <a:srgbClr val="2858A5"/>
+            </a:solidFill>
+            <a:prstDash val="solid"/>
+          </a:ln>
+        </p:spPr>
+      </p:sp>
+      <p:sp>
+        <p:nvSpPr>
+          <p:cNvPr id="200" name="dp44-implementation-comparison / n176 / text 1">
+            <a:extLst xmlns:a="http://schemas.openxmlformats.org/drawingml/2006/main">
+              <a:ext uri="{FF2B5EF4-FFF2-40B4-BE49-F238E27FC236}">
+                <a16:creationId xmlns:a16="http://schemas.microsoft.com/office/drawing/2014/main" id="{0524BF6F-E499-46BE-8E0B-72E2290CC138}"/>
+              </a:ext>
+            </a:extLst>
+          </p:cNvPr>
+          <p:cNvSpPr>
+            <a:spLocks xmlns:a="http://schemas.openxmlformats.org/drawingml/2006/main" noGrp="1"/>
+          </p:cNvSpPr>
+          <p:nvPr/>
+        </p:nvSpPr>
+        <p:spPr>
+          <a:xfrm xmlns:a="http://schemas.openxmlformats.org/drawingml/2006/main">
+            <a:off x="12668250" y="7458075"/>
+            <a:ext cx="2857500" cy="220980"/>
+          </a:xfrm>
+          <a:prstGeom xmlns:a="http://schemas.openxmlformats.org/drawingml/2006/main" prst="rect">
+            <a:avLst/>
+          </a:prstGeom>
+          <a:noFill xmlns:a="http://schemas.openxmlformats.org/drawingml/2006/main"/>
+          <a:ln xmlns:a="http://schemas.openxmlformats.org/drawingml/2006/main" w="0">
+            <a:noFill/>
+            <a:prstDash val="solid"/>
+          </a:ln>
+        </p:spPr>
+        <p:txBody>
+          <a:bodyPr xmlns:a="http://schemas.openxmlformats.org/drawingml/2006/main" wrap="none" lIns="0" tIns="0" rIns="0" bIns="0" anchor="t">
+            <a:noAutofit/>
+          </a:bodyPr>
+          <a:lstStyle xmlns:a="http://schemas.openxmlformats.org/drawingml/2006/main">
+            <a:defPPr algn="l">
+              <a:defRPr sz="1200" b="0">
+                <a:solidFill>
+                  <a:srgbClr val="2858A5"/>
+                </a:solidFill>
+                <a:latin typeface="Calibri"/>
+                <a:ea typeface="Calibri"/>
+                <a:cs typeface="Calibri"/>
+              </a:defRPr>
+            </a:defPPr>
+          </a:lstStyle>
+          <a:p xmlns:a="http://schemas.openxmlformats.org/drawingml/2006/main">
+            <a:pPr algn="l">
+              <a:defRPr sz="1200" b="0">
+                <a:solidFill>
+                  <a:srgbClr val="2858A5"/>
+                </a:solidFill>
+                <a:latin typeface="Calibri"/>
+                <a:ea typeface="Calibri"/>
+                <a:cs typeface="Calibri"/>
+              </a:defRPr>
+            </a:pPr>
+            <a:r>
+              <a:rPr sz="1200" b="0">
+                <a:solidFill>
+                  <a:srgbClr val="2858A5"/>
+                </a:solidFill>
+                <a:latin typeface="Calibri"/>
+                <a:ea typeface="Calibri"/>
+                <a:cs typeface="Calibri"/>
+              </a:rPr>
+              <a:t>eligible → Publication Control</a:t>
+            </a:r>
+          </a:p>
+        </p:txBody>
+      </p:sp>
+      <p:sp>
+        <p:nvSpPr>
+          <p:cNvPr id="201" name="dp44-implementation-comparison / n177 / text 1">
+            <a:extLst xmlns:a="http://schemas.openxmlformats.org/drawingml/2006/main">
+              <a:ext uri="{FF2B5EF4-FFF2-40B4-BE49-F238E27FC236}">
+                <a16:creationId xmlns:a16="http://schemas.microsoft.com/office/drawing/2014/main" id="{21CC0CB2-2C6B-4EF5-8898-94C87C02701B}"/>
+              </a:ext>
+            </a:extLst>
+          </p:cNvPr>
+          <p:cNvSpPr>
+            <a:spLocks xmlns:a="http://schemas.openxmlformats.org/drawingml/2006/main" noGrp="1"/>
+          </p:cNvSpPr>
+          <p:nvPr/>
+        </p:nvSpPr>
+        <p:spPr>
+          <a:xfrm xmlns:a="http://schemas.openxmlformats.org/drawingml/2006/main">
+            <a:off x="9667875" y="7848600"/>
+            <a:ext cx="7953375" cy="248602"/>
+          </a:xfrm>
+          <a:prstGeom xmlns:a="http://schemas.openxmlformats.org/drawingml/2006/main" prst="rect">
+            <a:avLst/>
+          </a:prstGeom>
+          <a:noFill xmlns:a="http://schemas.openxmlformats.org/drawingml/2006/main"/>
+          <a:ln xmlns:a="http://schemas.openxmlformats.org/drawingml/2006/main" w="0">
+            <a:noFill/>
+            <a:prstDash val="solid"/>
+          </a:ln>
+        </p:spPr>
+        <p:txBody>
+          <a:bodyPr xmlns:a="http://schemas.openxmlformats.org/drawingml/2006/main" wrap="none" lIns="0" tIns="0" rIns="0" bIns="0" anchor="t">
+            <a:noAutofit/>
+          </a:bodyPr>
+          <a:lstStyle xmlns:a="http://schemas.openxmlformats.org/drawingml/2006/main">
+            <a:defPPr algn="l">
+              <a:defRPr sz="1350" b="1">
+                <a:solidFill>
+                  <a:srgbClr val="18232E"/>
+                </a:solidFill>
+                <a:latin typeface="Calibri"/>
+                <a:ea typeface="Calibri"/>
+                <a:cs typeface="Calibri"/>
+              </a:defRPr>
+            </a:defPPr>
+          </a:lstStyle>
+          <a:p xmlns:a="http://schemas.openxmlformats.org/drawingml/2006/main">
+            <a:pPr algn="l">
+              <a:defRPr sz="1350" b="1">
+                <a:solidFill>
+                  <a:srgbClr val="18232E"/>
+                </a:solidFill>
+                <a:latin typeface="Calibri"/>
+                <a:ea typeface="Calibri"/>
+                <a:cs typeface="Calibri"/>
+              </a:defRPr>
+            </a:pPr>
+            <a:r>
+              <a:rPr sz="1350" b="1">
+                <a:solidFill>
+                  <a:srgbClr val="18232E"/>
+                </a:solidFill>
+                <a:latin typeface="Calibri"/>
+                <a:ea typeface="Calibri"/>
+                <a:cs typeface="Calibri"/>
+              </a:rPr>
+              <a:t>J1 늦은 완료: Composer Done Queue에서 자기 Job 무효 검사 후 폐기</a:t>
+            </a:r>
+          </a:p>
+        </p:txBody>
+      </p:sp>
+      <p:sp>
+        <p:nvSpPr>
+          <p:cNvPr id="202" name="dp44-implementation-comparison / n178 / text 1">
+            <a:extLst xmlns:a="http://schemas.openxmlformats.org/drawingml/2006/main">
+              <a:ext uri="{FF2B5EF4-FFF2-40B4-BE49-F238E27FC236}">
+                <a16:creationId xmlns:a16="http://schemas.microsoft.com/office/drawing/2014/main" id="{3205E201-A206-47CA-915F-6B4FFE01B821}"/>
+              </a:ext>
+            </a:extLst>
+          </p:cNvPr>
+          <p:cNvSpPr>
+            <a:spLocks xmlns:a="http://schemas.openxmlformats.org/drawingml/2006/main" noGrp="1"/>
+          </p:cNvSpPr>
+          <p:nvPr/>
+        </p:nvSpPr>
+        <p:spPr>
+          <a:xfrm xmlns:a="http://schemas.openxmlformats.org/drawingml/2006/main">
+            <a:off x="9667875" y="8096250"/>
+            <a:ext cx="7953375" cy="234791"/>
+          </a:xfrm>
+          <a:prstGeom xmlns:a="http://schemas.openxmlformats.org/drawingml/2006/main" prst="rect">
+            <a:avLst/>
+          </a:prstGeom>
+          <a:noFill xmlns:a="http://schemas.openxmlformats.org/drawingml/2006/main"/>
+          <a:ln xmlns:a="http://schemas.openxmlformats.org/drawingml/2006/main" w="0">
+            <a:noFill/>
+            <a:prstDash val="solid"/>
+          </a:ln>
+        </p:spPr>
+        <p:txBody>
+          <a:bodyPr xmlns:a="http://schemas.openxmlformats.org/drawingml/2006/main" wrap="none" lIns="0" tIns="0" rIns="0" bIns="0" anchor="t">
+            <a:noAutofit/>
+          </a:bodyPr>
+          <a:lstStyle xmlns:a="http://schemas.openxmlformats.org/drawingml/2006/main">
+            <a:defPPr algn="l">
+              <a:defRPr sz="1275" b="0">
+                <a:solidFill>
+                  <a:srgbClr val="5F6B77"/>
+                </a:solidFill>
+                <a:latin typeface="Calibri"/>
+                <a:ea typeface="Calibri"/>
+                <a:cs typeface="Calibri"/>
+              </a:defRPr>
+            </a:defPPr>
+          </a:lstStyle>
+          <a:p xmlns:a="http://schemas.openxmlformats.org/drawingml/2006/main">
+            <a:pPr algn="l">
+              <a:defRPr sz="1275" b="0">
+                <a:solidFill>
+                  <a:srgbClr val="5F6B77"/>
+                </a:solidFill>
+                <a:latin typeface="Calibri"/>
+                <a:ea typeface="Calibri"/>
+                <a:cs typeface="Calibri"/>
+              </a:defRPr>
+            </a:pPr>
+            <a:r>
+              <a:rPr sz="1275" b="0">
+                <a:solidFill>
+                  <a:srgbClr val="5F6B77"/>
+                </a:solidFill>
+                <a:latin typeface="Calibri"/>
+                <a:ea typeface="Calibri"/>
+                <a:cs typeface="Calibri"/>
+              </a:rPr>
+              <a:t>후보와 조건은 Join의 별도 Queue에 도착하며 ID와 revision으로 결합</a:t>
+            </a:r>
+          </a:p>
+        </p:txBody>
+      </p:sp>
+      <p:sp>
+        <p:nvSpPr>
+          <p:cNvPr id="203" name="dp44-implementation-comparison / n179">
+            <a:extLst xmlns:a="http://schemas.openxmlformats.org/drawingml/2006/main">
+              <a:ext uri="{FF2B5EF4-FFF2-40B4-BE49-F238E27FC236}">
+                <a16:creationId xmlns:a16="http://schemas.microsoft.com/office/drawing/2014/main" id="{CF04AAC4-A702-4233-8B4F-0560FCB3B55A}"/>
+              </a:ext>
+            </a:extLst>
+          </p:cNvPr>
+          <p:cNvSpPr>
+            <a:spLocks xmlns:a="http://schemas.openxmlformats.org/drawingml/2006/main" noGrp="1"/>
+          </p:cNvSpPr>
+          <p:nvPr/>
+        </p:nvSpPr>
+        <p:spPr>
+          <a:xfrm xmlns:a="http://schemas.openxmlformats.org/drawingml/2006/main">
+            <a:off x="514350" y="8382000"/>
+            <a:ext cx="17259300" cy="638175"/>
+          </a:xfrm>
+          <a:prstGeom xmlns:a="http://schemas.openxmlformats.org/drawingml/2006/main" prst="rect">
+            <a:avLst/>
+          </a:prstGeom>
+          <a:solidFill xmlns:a="http://schemas.openxmlformats.org/drawingml/2006/main">
+            <a:srgbClr val="F4F7FA"/>
+          </a:solidFill>
+          <a:ln xmlns:a="http://schemas.openxmlformats.org/drawingml/2006/main" w="16193">
+            <a:solidFill>
+              <a:srgbClr val="CDD6DE"/>
+            </a:solidFill>
+            <a:prstDash val="solid"/>
+          </a:ln>
+        </p:spPr>
+      </p:sp>
+      <p:sp>
+        <p:nvSpPr>
+          <p:cNvPr id="204" name="dp44-implementation-comparison / n180 / text 1">
+            <a:extLst xmlns:a="http://schemas.openxmlformats.org/drawingml/2006/main">
+              <a:ext uri="{FF2B5EF4-FFF2-40B4-BE49-F238E27FC236}">
+                <a16:creationId xmlns:a16="http://schemas.microsoft.com/office/drawing/2014/main" id="{D1DF7E0E-846B-496D-AADC-591986AC03F9}"/>
+              </a:ext>
+            </a:extLst>
+          </p:cNvPr>
+          <p:cNvSpPr>
+            <a:spLocks xmlns:a="http://schemas.openxmlformats.org/drawingml/2006/main" noGrp="1"/>
+          </p:cNvSpPr>
+          <p:nvPr/>
+        </p:nvSpPr>
+        <p:spPr>
+          <a:xfrm xmlns:a="http://schemas.openxmlformats.org/drawingml/2006/main">
+            <a:off x="666750" y="8486775"/>
+            <a:ext cx="2190750" cy="262414"/>
+          </a:xfrm>
+          <a:prstGeom xmlns:a="http://schemas.openxmlformats.org/drawingml/2006/main" prst="rect">
+            <a:avLst/>
+          </a:prstGeom>
+          <a:noFill xmlns:a="http://schemas.openxmlformats.org/drawingml/2006/main"/>
+          <a:ln xmlns:a="http://schemas.openxmlformats.org/drawingml/2006/main" w="0">
+            <a:noFill/>
+            <a:prstDash val="solid"/>
+          </a:ln>
+        </p:spPr>
+        <p:txBody>
+          <a:bodyPr xmlns:a="http://schemas.openxmlformats.org/drawingml/2006/main" wrap="none" lIns="0" tIns="0" rIns="0" bIns="0" anchor="t">
+            <a:noAutofit/>
+          </a:bodyPr>
+          <a:lstStyle xmlns:a="http://schemas.openxmlformats.org/drawingml/2006/main">
+            <a:defPPr algn="l">
+              <a:defRPr sz="1425" b="1">
+                <a:solidFill>
+                  <a:srgbClr val="18232E"/>
+                </a:solidFill>
+                <a:latin typeface="Calibri"/>
+                <a:ea typeface="Calibri"/>
+                <a:cs typeface="Calibri"/>
+              </a:defRPr>
+            </a:defPPr>
+          </a:lstStyle>
+          <a:p xmlns:a="http://schemas.openxmlformats.org/drawingml/2006/main">
+            <a:pPr algn="l">
+              <a:defRPr sz="1425" b="1">
+                <a:solidFill>
+                  <a:srgbClr val="18232E"/>
+                </a:solidFill>
+                <a:latin typeface="Calibri"/>
+                <a:ea typeface="Calibri"/>
+                <a:cs typeface="Calibri"/>
+              </a:defRPr>
+            </a:pPr>
+            <a:r>
+              <a:rPr sz="1425" b="1">
+                <a:solidFill>
+                  <a:srgbClr val="18232E"/>
+                </a:solidFill>
+                <a:latin typeface="Calibri"/>
+                <a:ea typeface="Calibri"/>
+                <a:cs typeface="Calibri"/>
+              </a:rPr>
+              <a:t>양안 공통 최종 전달</a:t>
+            </a:r>
+          </a:p>
+        </p:txBody>
+      </p:sp>
+      <p:sp>
+        <p:nvSpPr>
+          <p:cNvPr id="205" name="dp44-implementation-comparison / n181 / text 1">
+            <a:extLst xmlns:a="http://schemas.openxmlformats.org/drawingml/2006/main">
+              <a:ext uri="{FF2B5EF4-FFF2-40B4-BE49-F238E27FC236}">
+                <a16:creationId xmlns:a16="http://schemas.microsoft.com/office/drawing/2014/main" id="{B6576458-D0B1-4880-850A-D5E0316B0FCC}"/>
+              </a:ext>
+            </a:extLst>
+          </p:cNvPr>
+          <p:cNvSpPr>
+            <a:spLocks xmlns:a="http://schemas.openxmlformats.org/drawingml/2006/main" noGrp="1"/>
+          </p:cNvSpPr>
+          <p:nvPr/>
+        </p:nvSpPr>
+        <p:spPr>
+          <a:xfrm xmlns:a="http://schemas.openxmlformats.org/drawingml/2006/main">
+            <a:off x="3000375" y="8486775"/>
+            <a:ext cx="14620875" cy="262414"/>
+          </a:xfrm>
+          <a:prstGeom xmlns:a="http://schemas.openxmlformats.org/drawingml/2006/main" prst="rect">
+            <a:avLst/>
+          </a:prstGeom>
+          <a:noFill xmlns:a="http://schemas.openxmlformats.org/drawingml/2006/main"/>
+          <a:ln xmlns:a="http://schemas.openxmlformats.org/drawingml/2006/main" w="0">
+            <a:noFill/>
+            <a:prstDash val="solid"/>
+          </a:ln>
+        </p:spPr>
+        <p:txBody>
+          <a:bodyPr xmlns:a="http://schemas.openxmlformats.org/drawingml/2006/main" wrap="none" lIns="0" tIns="0" rIns="0" bIns="0" anchor="t">
+            <a:noAutofit/>
+          </a:bodyPr>
+          <a:lstStyle xmlns:a="http://schemas.openxmlformats.org/drawingml/2006/main">
+            <a:defPPr algn="l">
+              <a:defRPr sz="1425" b="0">
+                <a:solidFill>
+                  <a:srgbClr val="18232E"/>
+                </a:solidFill>
+                <a:latin typeface="Calibri"/>
+                <a:ea typeface="Calibri"/>
+                <a:cs typeface="Calibri"/>
+              </a:defRPr>
+            </a:defPPr>
+          </a:lstStyle>
+          <a:p xmlns:a="http://schemas.openxmlformats.org/drawingml/2006/main">
+            <a:pPr algn="l">
+              <a:defRPr sz="1425" b="0">
+                <a:solidFill>
+                  <a:srgbClr val="18232E"/>
+                </a:solidFill>
+                <a:latin typeface="Calibri"/>
+                <a:ea typeface="Calibri"/>
+                <a:cs typeface="Calibri"/>
+              </a:defRPr>
+            </a:pPr>
+            <a:r>
+              <a:rPr sz="1425" b="0">
+                <a:solidFill>
+                  <a:srgbClr val="18232E"/>
+                </a:solidFill>
+                <a:latin typeface="Calibri"/>
+                <a:ea typeface="Calibri"/>
+                <a:cs typeface="Calibri"/>
+              </a:rPr>
+              <a:t>Publication Control 현재성 및 권한 확인 → Interaction Manager 실제 표시와 재생 → ActualReceipt → Presented</a:t>
+            </a:r>
+          </a:p>
+        </p:txBody>
+      </p:sp>
+      <p:sp>
+        <p:nvSpPr>
+          <p:cNvPr id="206" name="dp44-implementation-comparison / n182 / text 1">
+            <a:extLst xmlns:a="http://schemas.openxmlformats.org/drawingml/2006/main">
+              <a:ext uri="{FF2B5EF4-FFF2-40B4-BE49-F238E27FC236}">
+                <a16:creationId xmlns:a16="http://schemas.microsoft.com/office/drawing/2014/main" id="{09B47BFB-2AC9-45E6-BB4D-D39AD8717D74}"/>
+              </a:ext>
+            </a:extLst>
+          </p:cNvPr>
+          <p:cNvSpPr>
+            <a:spLocks xmlns:a="http://schemas.openxmlformats.org/drawingml/2006/main" noGrp="1"/>
+          </p:cNvSpPr>
+          <p:nvPr/>
+        </p:nvSpPr>
+        <p:spPr>
+          <a:xfrm xmlns:a="http://schemas.openxmlformats.org/drawingml/2006/main">
+            <a:off x="666750" y="8743950"/>
+            <a:ext cx="16906875" cy="234791"/>
+          </a:xfrm>
+          <a:prstGeom xmlns:a="http://schemas.openxmlformats.org/drawingml/2006/main" prst="rect">
+            <a:avLst/>
+          </a:prstGeom>
+          <a:noFill xmlns:a="http://schemas.openxmlformats.org/drawingml/2006/main"/>
+          <a:ln xmlns:a="http://schemas.openxmlformats.org/drawingml/2006/main" w="0">
+            <a:noFill/>
+            <a:prstDash val="solid"/>
+          </a:ln>
+        </p:spPr>
+        <p:txBody>
+          <a:bodyPr xmlns:a="http://schemas.openxmlformats.org/drawingml/2006/main" wrap="none" lIns="0" tIns="0" rIns="0" bIns="0" anchor="t">
+            <a:noAutofit/>
+          </a:bodyPr>
+          <a:lstStyle xmlns:a="http://schemas.openxmlformats.org/drawingml/2006/main">
+            <a:defPPr algn="l">
+              <a:defRPr sz="1275" b="0">
+                <a:solidFill>
+                  <a:srgbClr val="5F6B77"/>
+                </a:solidFill>
+                <a:latin typeface="Calibri"/>
+                <a:ea typeface="Calibri"/>
+                <a:cs typeface="Calibri"/>
+              </a:defRPr>
+            </a:defPPr>
+          </a:lstStyle>
+          <a:p xmlns:a="http://schemas.openxmlformats.org/drawingml/2006/main">
+            <a:pPr algn="l">
+              <a:defRPr sz="1275" b="0">
+                <a:solidFill>
+                  <a:srgbClr val="5F6B77"/>
+                </a:solidFill>
+                <a:latin typeface="Calibri"/>
+                <a:ea typeface="Calibri"/>
+                <a:cs typeface="Calibri"/>
+              </a:defRPr>
+            </a:pPr>
+            <a:r>
+              <a:rPr sz="1275" b="0">
+                <a:solidFill>
+                  <a:srgbClr val="5F6B77"/>
+                </a:solidFill>
+                <a:latin typeface="Calibri"/>
+                <a:ea typeface="Calibri"/>
+                <a:cs typeface="Calibri"/>
+              </a:rPr>
+              <a:t>발화 감지는 즉시 출력 중단과 관련 게시 hold를 유발한다. Task나 Job 취소는 정정 의도 채택 후 별도로 판단한다.</a:t>
+            </a:r>
+          </a:p>
+        </p:txBody>
+      </p:sp>
+      <p:sp>
+        <p:nvSpPr>
+          <p:cNvPr id="207" name="dp44-implementation-comparison / n183">
+            <a:extLst xmlns:a="http://schemas.openxmlformats.org/drawingml/2006/main">
+              <a:ext uri="{FF2B5EF4-FFF2-40B4-BE49-F238E27FC236}">
+                <a16:creationId xmlns:a16="http://schemas.microsoft.com/office/drawing/2014/main" id="{833C0BCE-2FB5-4FD2-A017-3C0DD7CC00B3}"/>
+              </a:ext>
+            </a:extLst>
+          </p:cNvPr>
+          <p:cNvSpPr>
+            <a:spLocks xmlns:a="http://schemas.openxmlformats.org/drawingml/2006/main" noGrp="1"/>
+          </p:cNvSpPr>
+          <p:nvPr/>
+        </p:nvSpPr>
+        <p:spPr>
+          <a:xfrm xmlns:a="http://schemas.openxmlformats.org/drawingml/2006/main">
+            <a:off x="514350" y="9286875"/>
+            <a:ext cx="1695450" cy="438150"/>
+          </a:xfrm>
+          <a:prstGeom xmlns:a="http://schemas.openxmlformats.org/drawingml/2006/main" prst="rect">
+            <a:avLst/>
+          </a:prstGeom>
+          <a:solidFill xmlns:a="http://schemas.openxmlformats.org/drawingml/2006/main">
+            <a:srgbClr val="FFFFFF"/>
+          </a:solidFill>
+          <a:ln xmlns:a="http://schemas.openxmlformats.org/drawingml/2006/main" w="16193">
+            <a:solidFill>
+              <a:srgbClr val="B8753F"/>
+            </a:solidFill>
+            <a:prstDash val="solid"/>
+          </a:ln>
+        </p:spPr>
+      </p:sp>
+      <p:sp>
+        <p:nvSpPr>
+          <p:cNvPr id="208" name="dp44-implementation-comparison / n184 / text 1">
+            <a:extLst xmlns:a="http://schemas.openxmlformats.org/drawingml/2006/main">
+              <a:ext uri="{FF2B5EF4-FFF2-40B4-BE49-F238E27FC236}">
+                <a16:creationId xmlns:a16="http://schemas.microsoft.com/office/drawing/2014/main" id="{E0944747-2111-4093-B856-72B5FAEECC6E}"/>
+              </a:ext>
+            </a:extLst>
+          </p:cNvPr>
+          <p:cNvSpPr>
+            <a:spLocks xmlns:a="http://schemas.openxmlformats.org/drawingml/2006/main" noGrp="1"/>
+          </p:cNvSpPr>
+          <p:nvPr/>
+        </p:nvSpPr>
+        <p:spPr>
+          <a:xfrm xmlns:a="http://schemas.openxmlformats.org/drawingml/2006/main">
+            <a:off x="600075" y="9353550"/>
+            <a:ext cx="1524000" cy="220980"/>
+          </a:xfrm>
+          <a:prstGeom xmlns:a="http://schemas.openxmlformats.org/drawingml/2006/main" prst="rect">
+            <a:avLst/>
+          </a:prstGeom>
+          <a:noFill xmlns:a="http://schemas.openxmlformats.org/drawingml/2006/main"/>
+          <a:ln xmlns:a="http://schemas.openxmlformats.org/drawingml/2006/main" w="0">
+            <a:noFill/>
+            <a:prstDash val="solid"/>
+          </a:ln>
+        </p:spPr>
+        <p:txBody>
+          <a:bodyPr xmlns:a="http://schemas.openxmlformats.org/drawingml/2006/main" wrap="none" lIns="0" tIns="0" rIns="0" bIns="0" anchor="t">
+            <a:noAutofit/>
+          </a:bodyPr>
+          <a:lstStyle xmlns:a="http://schemas.openxmlformats.org/drawingml/2006/main">
+            <a:defPPr algn="l">
+              <a:defRPr sz="1200" b="1">
+                <a:solidFill>
+                  <a:srgbClr val="18232E"/>
+                </a:solidFill>
+                <a:latin typeface="Calibri"/>
+                <a:ea typeface="Calibri"/>
+                <a:cs typeface="Calibri"/>
+              </a:defRPr>
+            </a:defPPr>
+          </a:lstStyle>
+          <a:p xmlns:a="http://schemas.openxmlformats.org/drawingml/2006/main">
+            <a:pPr algn="l">
+              <a:defRPr sz="1200" b="1">
+                <a:solidFill>
+                  <a:srgbClr val="18232E"/>
+                </a:solidFill>
+                <a:latin typeface="Calibri"/>
+                <a:ea typeface="Calibri"/>
+                <a:cs typeface="Calibri"/>
+              </a:defRPr>
+            </a:pPr>
+            <a:r>
+              <a:rPr sz="1200" b="1">
+                <a:solidFill>
+                  <a:srgbClr val="18232E"/>
+                </a:solidFill>
+                <a:latin typeface="Calibri"/>
+                <a:ea typeface="Calibri"/>
+                <a:cs typeface="Calibri"/>
+              </a:rPr>
+              <a:t>Queue</a:t>
+            </a:r>
+          </a:p>
+        </p:txBody>
+      </p:sp>
+      <p:sp>
+        <p:nvSpPr>
+          <p:cNvPr id="209" name="dp44-implementation-comparison / n185">
+            <a:extLst xmlns:a="http://schemas.openxmlformats.org/drawingml/2006/main">
+              <a:ext uri="{FF2B5EF4-FFF2-40B4-BE49-F238E27FC236}">
+                <a16:creationId xmlns:a16="http://schemas.microsoft.com/office/drawing/2014/main" id="{7631E87E-819C-4581-BE74-BE58407181BE}"/>
+              </a:ext>
+            </a:extLst>
+          </p:cNvPr>
+          <p:cNvSpPr>
+            <a:spLocks xmlns:a="http://schemas.openxmlformats.org/drawingml/2006/main" noGrp="1"/>
+          </p:cNvSpPr>
+          <p:nvPr/>
+        </p:nvSpPr>
+        <p:spPr>
+          <a:xfrm xmlns:a="http://schemas.openxmlformats.org/drawingml/2006/main">
+            <a:off x="1409700" y="9515475"/>
+            <a:ext cx="142875" cy="142875"/>
+          </a:xfrm>
+          <a:prstGeom xmlns:a="http://schemas.openxmlformats.org/drawingml/2006/main" prst="rect">
+            <a:avLst/>
+          </a:prstGeom>
+          <a:solidFill xmlns:a="http://schemas.openxmlformats.org/drawingml/2006/main">
+            <a:srgbClr val="FFFFFF"/>
+          </a:solidFill>
+          <a:ln xmlns:a="http://schemas.openxmlformats.org/drawingml/2006/main" w="16193">
+            <a:solidFill>
+              <a:srgbClr val="5F6B77"/>
+            </a:solidFill>
+            <a:prstDash val="solid"/>
+          </a:ln>
+        </p:spPr>
+      </p:sp>
+      <p:sp>
+        <p:nvSpPr>
+          <p:cNvPr id="210" name="dp44-implementation-comparison / n186">
+            <a:extLst xmlns:a="http://schemas.openxmlformats.org/drawingml/2006/main">
+              <a:ext uri="{FF2B5EF4-FFF2-40B4-BE49-F238E27FC236}">
+                <a16:creationId xmlns:a16="http://schemas.microsoft.com/office/drawing/2014/main" id="{85D2A975-5C3D-43F6-BE9E-602C3E8E9A09}"/>
+              </a:ext>
+            </a:extLst>
+          </p:cNvPr>
+          <p:cNvSpPr>
+            <a:spLocks xmlns:a="http://schemas.openxmlformats.org/drawingml/2006/main" noGrp="1"/>
+          </p:cNvSpPr>
+          <p:nvPr/>
+        </p:nvSpPr>
+        <p:spPr>
+          <a:xfrm xmlns:a="http://schemas.openxmlformats.org/drawingml/2006/main">
+            <a:off x="1590675" y="9515475"/>
+            <a:ext cx="142875" cy="142875"/>
+          </a:xfrm>
+          <a:prstGeom xmlns:a="http://schemas.openxmlformats.org/drawingml/2006/main" prst="rect">
+            <a:avLst/>
+          </a:prstGeom>
+          <a:solidFill xmlns:a="http://schemas.openxmlformats.org/drawingml/2006/main">
+            <a:srgbClr val="FFFFFF"/>
+          </a:solidFill>
+          <a:ln xmlns:a="http://schemas.openxmlformats.org/drawingml/2006/main" w="16193">
+            <a:solidFill>
+              <a:srgbClr val="5F6B77"/>
+            </a:solidFill>
+            <a:prstDash val="solid"/>
+          </a:ln>
+        </p:spPr>
+      </p:sp>
+      <p:sp>
+        <p:nvSpPr>
+          <p:cNvPr id="211" name="dp44-implementation-comparison / n187">
+            <a:extLst xmlns:a="http://schemas.openxmlformats.org/drawingml/2006/main">
+              <a:ext uri="{FF2B5EF4-FFF2-40B4-BE49-F238E27FC236}">
+                <a16:creationId xmlns:a16="http://schemas.microsoft.com/office/drawing/2014/main" id="{A1A1AC90-C898-418E-AB3A-C9CE694F06E8}"/>
+              </a:ext>
+            </a:extLst>
+          </p:cNvPr>
+          <p:cNvSpPr>
+            <a:spLocks xmlns:a="http://schemas.openxmlformats.org/drawingml/2006/main" noGrp="1"/>
+          </p:cNvSpPr>
+          <p:nvPr/>
+        </p:nvSpPr>
+        <p:spPr>
+          <a:xfrm xmlns:a="http://schemas.openxmlformats.org/drawingml/2006/main">
+            <a:off x="1771650" y="9515475"/>
+            <a:ext cx="142875" cy="142875"/>
+          </a:xfrm>
+          <a:prstGeom xmlns:a="http://schemas.openxmlformats.org/drawingml/2006/main" prst="rect">
+            <a:avLst/>
+          </a:prstGeom>
+          <a:solidFill xmlns:a="http://schemas.openxmlformats.org/drawingml/2006/main">
+            <a:srgbClr val="FFFFFF"/>
+          </a:solidFill>
+          <a:ln xmlns:a="http://schemas.openxmlformats.org/drawingml/2006/main" w="16193">
+            <a:solidFill>
+              <a:srgbClr val="5F6B77"/>
+            </a:solidFill>
+            <a:prstDash val="solid"/>
+          </a:ln>
+        </p:spPr>
+      </p:sp>
+      <p:sp>
+        <p:nvSpPr>
+          <p:cNvPr id="212" name="dp44-implementation-comparison / n188">
+            <a:extLst xmlns:a="http://schemas.openxmlformats.org/drawingml/2006/main">
+              <a:ext uri="{FF2B5EF4-FFF2-40B4-BE49-F238E27FC236}">
+                <a16:creationId xmlns:a16="http://schemas.microsoft.com/office/drawing/2014/main" id="{E9DBD3FF-C900-4D63-A4F2-117AC47A8A52}"/>
+              </a:ext>
+            </a:extLst>
+          </p:cNvPr>
+          <p:cNvSpPr>
+            <a:spLocks xmlns:a="http://schemas.openxmlformats.org/drawingml/2006/main" noGrp="1"/>
+          </p:cNvSpPr>
+          <p:nvPr/>
+        </p:nvSpPr>
+        <p:spPr>
+          <a:xfrm xmlns:a="http://schemas.openxmlformats.org/drawingml/2006/main">
+            <a:off x="1952625" y="9515475"/>
+            <a:ext cx="142875" cy="142875"/>
+          </a:xfrm>
+          <a:prstGeom xmlns:a="http://schemas.openxmlformats.org/drawingml/2006/main" prst="rect">
+            <a:avLst/>
+          </a:prstGeom>
+          <a:solidFill xmlns:a="http://schemas.openxmlformats.org/drawingml/2006/main">
+            <a:srgbClr val="FFFFFF"/>
+          </a:solidFill>
+          <a:ln xmlns:a="http://schemas.openxmlformats.org/drawingml/2006/main" w="16193">
+            <a:solidFill>
+              <a:srgbClr val="5F6B77"/>
+            </a:solidFill>
+            <a:prstDash val="solid"/>
+          </a:ln>
+        </p:spPr>
+      </p:sp>
+      <p:sp>
+        <p:nvSpPr>
+          <p:cNvPr id="213" name="dp44-implementation-comparison / n189">
+            <a:extLst xmlns:a="http://schemas.openxmlformats.org/drawingml/2006/main">
+              <a:ext uri="{FF2B5EF4-FFF2-40B4-BE49-F238E27FC236}">
+                <a16:creationId xmlns:a16="http://schemas.microsoft.com/office/drawing/2014/main" id="{DBAAAC52-9C5A-4E2E-9C9C-E57D8E3775D1}"/>
+              </a:ext>
+            </a:extLst>
+          </p:cNvPr>
+          <p:cNvSpPr>
+            <a:spLocks xmlns:a="http://schemas.openxmlformats.org/drawingml/2006/main" noGrp="1"/>
+          </p:cNvSpPr>
+          <p:nvPr/>
+        </p:nvSpPr>
+        <p:spPr>
+          <a:xfrm xmlns:a="http://schemas.openxmlformats.org/drawingml/2006/main">
+            <a:off x="2476500" y="9286875"/>
+            <a:ext cx="1695450" cy="438150"/>
+          </a:xfrm>
+          <a:prstGeom xmlns:a="http://schemas.openxmlformats.org/drawingml/2006/main" prst="can">
+            <a:avLst/>
+          </a:prstGeom>
+          <a:solidFill xmlns:a="http://schemas.openxmlformats.org/drawingml/2006/main">
+            <a:srgbClr val="FFFFFF"/>
+          </a:solidFill>
+          <a:ln xmlns:a="http://schemas.openxmlformats.org/drawingml/2006/main" w="16193">
+            <a:solidFill>
+              <a:srgbClr val="B8753F"/>
+            </a:solidFill>
+            <a:prstDash val="solid"/>
+          </a:ln>
+        </p:spPr>
+      </p:sp>
+      <p:sp>
+        <p:nvSpPr>
+          <p:cNvPr id="214" name="dp44-implementation-comparison / n190 / text 1">
+            <a:extLst xmlns:a="http://schemas.openxmlformats.org/drawingml/2006/main">
+              <a:ext uri="{FF2B5EF4-FFF2-40B4-BE49-F238E27FC236}">
+                <a16:creationId xmlns:a16="http://schemas.microsoft.com/office/drawing/2014/main" id="{859CA400-AFDF-4250-A420-7912626F4A12}"/>
+              </a:ext>
+            </a:extLst>
+          </p:cNvPr>
+          <p:cNvSpPr>
+            <a:spLocks xmlns:a="http://schemas.openxmlformats.org/drawingml/2006/main" noGrp="1"/>
+          </p:cNvSpPr>
+          <p:nvPr/>
+        </p:nvSpPr>
+        <p:spPr>
+          <a:xfrm xmlns:a="http://schemas.openxmlformats.org/drawingml/2006/main">
+            <a:off x="2562225" y="9458325"/>
+            <a:ext cx="1524000" cy="207169"/>
+          </a:xfrm>
+          <a:prstGeom xmlns:a="http://schemas.openxmlformats.org/drawingml/2006/main" prst="rect">
+            <a:avLst/>
+          </a:prstGeom>
+          <a:noFill xmlns:a="http://schemas.openxmlformats.org/drawingml/2006/main"/>
+          <a:ln xmlns:a="http://schemas.openxmlformats.org/drawingml/2006/main" w="0">
+            <a:noFill/>
+            <a:prstDash val="solid"/>
+          </a:ln>
+        </p:spPr>
+        <p:txBody>
+          <a:bodyPr xmlns:a="http://schemas.openxmlformats.org/drawingml/2006/main" wrap="none" lIns="0" tIns="0" rIns="0" bIns="0" anchor="t">
+            <a:noAutofit/>
+          </a:bodyPr>
+          <a:lstStyle xmlns:a="http://schemas.openxmlformats.org/drawingml/2006/main">
+            <a:defPPr algn="l">
+              <a:defRPr sz="1125" b="0">
+                <a:solidFill>
+                  <a:srgbClr val="18232E"/>
+                </a:solidFill>
+                <a:latin typeface="Calibri"/>
+                <a:ea typeface="Calibri"/>
+                <a:cs typeface="Calibri"/>
+              </a:defRPr>
+            </a:defPPr>
+          </a:lstStyle>
+          <a:p xmlns:a="http://schemas.openxmlformats.org/drawingml/2006/main">
+            <a:pPr algn="l">
+              <a:defRPr sz="1125" b="0">
+                <a:solidFill>
+                  <a:srgbClr val="18232E"/>
+                </a:solidFill>
+                <a:latin typeface="Calibri"/>
+                <a:ea typeface="Calibri"/>
+                <a:cs typeface="Calibri"/>
+              </a:defRPr>
+            </a:pPr>
+            <a:r>
+              <a:rPr sz="1125" b="0">
+                <a:solidFill>
+                  <a:srgbClr val="18232E"/>
+                </a:solidFill>
+                <a:latin typeface="Calibri"/>
+                <a:ea typeface="Calibri"/>
+                <a:cs typeface="Calibri"/>
+              </a:rPr>
+              <a:t>상태 원통</a:t>
+            </a:r>
+          </a:p>
+        </p:txBody>
+      </p:sp>
+      <p:sp>
+        <p:nvSpPr>
+          <p:cNvPr id="215" name="dp44-implementation-comparison / n191 / path">
+            <a:extLst xmlns:a="http://schemas.openxmlformats.org/drawingml/2006/main">
+              <a:ext uri="{FF2B5EF4-FFF2-40B4-BE49-F238E27FC236}">
+                <a16:creationId xmlns:a16="http://schemas.microsoft.com/office/drawing/2014/main" id="{7A097A19-80A8-4809-AE2A-4A10EDA0AC90}"/>
+              </a:ext>
+            </a:extLst>
+          </p:cNvPr>
+          <p:cNvSpPr>
+            <a:spLocks xmlns:a="http://schemas.openxmlformats.org/drawingml/2006/main" noGrp="1"/>
+          </p:cNvSpPr>
+          <p:nvPr/>
+        </p:nvSpPr>
+        <p:spPr>
+          <a:xfrm xmlns:a="http://schemas.openxmlformats.org/drawingml/2006/main">
+            <a:off x="4476750" y="9505950"/>
+            <a:ext cx="619125" cy="953"/>
+          </a:xfrm>
+          <a:custGeom xmlns:a="http://schemas.openxmlformats.org/drawingml/2006/main">
+            <a:pathLst>
+              <a:path w="619125" h="953">
+                <a:moveTo>
+                  <a:pt x="0" y="0"/>
+                </a:moveTo>
+                <a:lnTo>
+                  <a:pt x="619125" y="0"/>
+                </a:lnTo>
+              </a:path>
+            </a:pathLst>
+          </a:custGeom>
+          <a:noFill xmlns:a="http://schemas.openxmlformats.org/drawingml/2006/main"/>
+          <a:ln xmlns:a="http://schemas.openxmlformats.org/drawingml/2006/main" w="19050">
+            <a:solidFill>
+              <a:srgbClr val="2858A5"/>
+            </a:solidFill>
+            <a:prstDash val="solid"/>
+          </a:ln>
+        </p:spPr>
+      </p:sp>
+      <p:sp>
+        <p:nvSpPr>
+          <p:cNvPr id="216" name="dp44-implementation-comparison / n191 / arrow">
+            <a:extLst xmlns:a="http://schemas.openxmlformats.org/drawingml/2006/main">
+              <a:ext uri="{FF2B5EF4-FFF2-40B4-BE49-F238E27FC236}">
+                <a16:creationId xmlns:a16="http://schemas.microsoft.com/office/drawing/2014/main" id="{A00E5E5A-B377-4F25-B1E4-3BC0209E0313}"/>
+              </a:ext>
+            </a:extLst>
+          </p:cNvPr>
+          <p:cNvSpPr>
+            <a:spLocks xmlns:a="http://schemas.openxmlformats.org/drawingml/2006/main" noGrp="1"/>
+          </p:cNvSpPr>
+          <p:nvPr/>
+        </p:nvSpPr>
+        <p:spPr>
+          <a:xfrm xmlns:a="http://schemas.openxmlformats.org/drawingml/2006/main">
+            <a:off x="4973955" y="9444990"/>
             <a:ext cx="121920" cy="121920"/>
           </a:xfrm>
           <a:custGeom xmlns:a="http://schemas.openxmlformats.org/drawingml/2006/main">
@@ -11472,326 +12611,22 @@
       </p:sp>
       <p:sp>
         <p:nvSpPr>
-          <p:cNvPr id="194" name="dp44-implementation-comparison / n173 / path">
-            <a:extLst xmlns:a="http://schemas.openxmlformats.org/drawingml/2006/main">
-              <a:ext uri="{FF2B5EF4-FFF2-40B4-BE49-F238E27FC236}">
-                <a16:creationId xmlns:a16="http://schemas.microsoft.com/office/drawing/2014/main" id="{E18711FA-50E9-4357-9B85-2C89E6B97D3D}"/>
-              </a:ext>
-            </a:extLst>
-          </p:cNvPr>
-          <p:cNvSpPr>
-            <a:spLocks xmlns:a="http://schemas.openxmlformats.org/drawingml/2006/main" noGrp="1"/>
-          </p:cNvSpPr>
-          <p:nvPr/>
-        </p:nvSpPr>
-        <p:spPr>
-          <a:xfrm xmlns:a="http://schemas.openxmlformats.org/drawingml/2006/main">
-            <a:off x="15678150" y="4972050"/>
-            <a:ext cx="953" cy="628650"/>
-          </a:xfrm>
-          <a:custGeom xmlns:a="http://schemas.openxmlformats.org/drawingml/2006/main">
-            <a:pathLst>
-              <a:path w="953" h="628650">
-                <a:moveTo>
-                  <a:pt x="0" y="0"/>
-                </a:moveTo>
-                <a:lnTo>
-                  <a:pt x="0" y="628650"/>
-                </a:lnTo>
-              </a:path>
-            </a:pathLst>
-          </a:custGeom>
-          <a:noFill xmlns:a="http://schemas.openxmlformats.org/drawingml/2006/main"/>
-          <a:ln xmlns:a="http://schemas.openxmlformats.org/drawingml/2006/main" w="19050">
-            <a:solidFill>
-              <a:srgbClr val="2858A5"/>
-            </a:solidFill>
-            <a:prstDash val="solid"/>
-          </a:ln>
-        </p:spPr>
-      </p:sp>
-      <p:sp>
-        <p:nvSpPr>
-          <p:cNvPr id="195" name="dp44-implementation-comparison / n173 / arrow">
-            <a:extLst xmlns:a="http://schemas.openxmlformats.org/drawingml/2006/main">
-              <a:ext uri="{FF2B5EF4-FFF2-40B4-BE49-F238E27FC236}">
-                <a16:creationId xmlns:a16="http://schemas.microsoft.com/office/drawing/2014/main" id="{F054D957-6526-4855-B11F-FB776C9D0E60}"/>
-              </a:ext>
-            </a:extLst>
-          </p:cNvPr>
-          <p:cNvSpPr>
-            <a:spLocks xmlns:a="http://schemas.openxmlformats.org/drawingml/2006/main" noGrp="1"/>
-          </p:cNvSpPr>
-          <p:nvPr/>
-        </p:nvSpPr>
-        <p:spPr>
-          <a:xfrm xmlns:a="http://schemas.openxmlformats.org/drawingml/2006/main">
-            <a:off x="15617190" y="5478780"/>
-            <a:ext cx="121920" cy="121920"/>
-          </a:xfrm>
-          <a:custGeom xmlns:a="http://schemas.openxmlformats.org/drawingml/2006/main">
-            <a:pathLst>
-              <a:path w="121920" h="121920">
-                <a:moveTo>
-                  <a:pt x="0" y="0"/>
-                </a:moveTo>
-                <a:lnTo>
-                  <a:pt x="60960" y="121920"/>
-                </a:lnTo>
-                <a:lnTo>
-                  <a:pt x="121920" y="0"/>
-                </a:lnTo>
-              </a:path>
-            </a:pathLst>
-          </a:custGeom>
-          <a:noFill xmlns:a="http://schemas.openxmlformats.org/drawingml/2006/main"/>
-          <a:ln xmlns:a="http://schemas.openxmlformats.org/drawingml/2006/main" w="24384">
-            <a:solidFill>
-              <a:srgbClr val="2858A5"/>
-            </a:solidFill>
-            <a:prstDash val="solid"/>
-          </a:ln>
-        </p:spPr>
-      </p:sp>
-      <p:sp>
-        <p:nvSpPr>
-          <p:cNvPr id="196" name="dp44-implementation-comparison / n174 / path">
-            <a:extLst xmlns:a="http://schemas.openxmlformats.org/drawingml/2006/main">
-              <a:ext uri="{FF2B5EF4-FFF2-40B4-BE49-F238E27FC236}">
-                <a16:creationId xmlns:a16="http://schemas.microsoft.com/office/drawing/2014/main" id="{84AC5D22-EAC9-480D-99BF-8F21276FB568}"/>
-              </a:ext>
-            </a:extLst>
-          </p:cNvPr>
-          <p:cNvSpPr>
-            <a:spLocks xmlns:a="http://schemas.openxmlformats.org/drawingml/2006/main" noGrp="1"/>
-          </p:cNvSpPr>
-          <p:nvPr/>
-        </p:nvSpPr>
-        <p:spPr>
-          <a:xfrm xmlns:a="http://schemas.openxmlformats.org/drawingml/2006/main">
-            <a:off x="15678150" y="7334250"/>
-            <a:ext cx="953" cy="200025"/>
-          </a:xfrm>
-          <a:custGeom xmlns:a="http://schemas.openxmlformats.org/drawingml/2006/main">
-            <a:pathLst>
-              <a:path w="953" h="200025">
-                <a:moveTo>
-                  <a:pt x="0" y="0"/>
-                </a:moveTo>
-                <a:lnTo>
-                  <a:pt x="0" y="200025"/>
-                </a:lnTo>
-              </a:path>
-            </a:pathLst>
-          </a:custGeom>
-          <a:noFill xmlns:a="http://schemas.openxmlformats.org/drawingml/2006/main"/>
-          <a:ln xmlns:a="http://schemas.openxmlformats.org/drawingml/2006/main" w="19050">
-            <a:solidFill>
-              <a:srgbClr val="2858A5"/>
-            </a:solidFill>
-            <a:prstDash val="solid"/>
-          </a:ln>
-        </p:spPr>
-      </p:sp>
-      <p:sp>
-        <p:nvSpPr>
-          <p:cNvPr id="197" name="dp44-implementation-comparison / n174 / arrow">
-            <a:extLst xmlns:a="http://schemas.openxmlformats.org/drawingml/2006/main">
-              <a:ext uri="{FF2B5EF4-FFF2-40B4-BE49-F238E27FC236}">
-                <a16:creationId xmlns:a16="http://schemas.microsoft.com/office/drawing/2014/main" id="{FA83C895-81A9-40A2-B86C-04FA153E91D6}"/>
-              </a:ext>
-            </a:extLst>
-          </p:cNvPr>
-          <p:cNvSpPr>
-            <a:spLocks xmlns:a="http://schemas.openxmlformats.org/drawingml/2006/main" noGrp="1"/>
-          </p:cNvSpPr>
-          <p:nvPr/>
-        </p:nvSpPr>
-        <p:spPr>
-          <a:xfrm xmlns:a="http://schemas.openxmlformats.org/drawingml/2006/main">
-            <a:off x="15617190" y="7412355"/>
-            <a:ext cx="121920" cy="121920"/>
-          </a:xfrm>
-          <a:custGeom xmlns:a="http://schemas.openxmlformats.org/drawingml/2006/main">
-            <a:pathLst>
-              <a:path w="121920" h="121920">
-                <a:moveTo>
-                  <a:pt x="0" y="0"/>
-                </a:moveTo>
-                <a:lnTo>
-                  <a:pt x="60960" y="121920"/>
-                </a:lnTo>
-                <a:lnTo>
-                  <a:pt x="121920" y="0"/>
-                </a:lnTo>
-              </a:path>
-            </a:pathLst>
-          </a:custGeom>
-          <a:noFill xmlns:a="http://schemas.openxmlformats.org/drawingml/2006/main"/>
-          <a:ln xmlns:a="http://schemas.openxmlformats.org/drawingml/2006/main" w="24384">
-            <a:solidFill>
-              <a:srgbClr val="2858A5"/>
-            </a:solidFill>
-            <a:prstDash val="solid"/>
-          </a:ln>
-        </p:spPr>
-      </p:sp>
-      <p:sp>
-        <p:nvSpPr>
-          <p:cNvPr id="198" name="dp44-implementation-comparison / n175 / text 1">
-            <a:extLst xmlns:a="http://schemas.openxmlformats.org/drawingml/2006/main">
-              <a:ext uri="{FF2B5EF4-FFF2-40B4-BE49-F238E27FC236}">
-                <a16:creationId xmlns:a16="http://schemas.microsoft.com/office/drawing/2014/main" id="{E4C461DD-F13A-40E7-ABCF-8A10A72B22B5}"/>
-              </a:ext>
-            </a:extLst>
-          </p:cNvPr>
-          <p:cNvSpPr>
-            <a:spLocks xmlns:a="http://schemas.openxmlformats.org/drawingml/2006/main" noGrp="1"/>
-          </p:cNvSpPr>
-          <p:nvPr/>
-        </p:nvSpPr>
-        <p:spPr>
-          <a:xfrm xmlns:a="http://schemas.openxmlformats.org/drawingml/2006/main">
-            <a:off x="12668250" y="7458075"/>
-            <a:ext cx="2857500" cy="220980"/>
-          </a:xfrm>
-          <a:prstGeom xmlns:a="http://schemas.openxmlformats.org/drawingml/2006/main" prst="rect">
-            <a:avLst/>
-          </a:prstGeom>
-          <a:noFill xmlns:a="http://schemas.openxmlformats.org/drawingml/2006/main"/>
-          <a:ln xmlns:a="http://schemas.openxmlformats.org/drawingml/2006/main" w="0">
-            <a:noFill/>
-            <a:prstDash val="solid"/>
-          </a:ln>
-        </p:spPr>
-        <p:txBody>
-          <a:bodyPr xmlns:a="http://schemas.openxmlformats.org/drawingml/2006/main" wrap="none" lIns="0" tIns="0" rIns="0" bIns="0" anchor="t">
-            <a:noAutofit/>
-          </a:bodyPr>
-          <a:lstStyle xmlns:a="http://schemas.openxmlformats.org/drawingml/2006/main">
-            <a:defPPr algn="l">
-              <a:defRPr sz="1200" b="0">
-                <a:solidFill>
-                  <a:srgbClr val="2858A5"/>
-                </a:solidFill>
-                <a:latin typeface="Calibri"/>
-                <a:ea typeface="Calibri"/>
-                <a:cs typeface="Calibri"/>
-              </a:defRPr>
-            </a:defPPr>
-          </a:lstStyle>
-          <a:p xmlns:a="http://schemas.openxmlformats.org/drawingml/2006/main">
-            <a:pPr algn="l">
-              <a:defRPr sz="1200" b="0">
-                <a:solidFill>
-                  <a:srgbClr val="2858A5"/>
-                </a:solidFill>
-                <a:latin typeface="Calibri"/>
-                <a:ea typeface="Calibri"/>
-                <a:cs typeface="Calibri"/>
-              </a:defRPr>
-            </a:pPr>
-            <a:r>
-              <a:rPr sz="1200" b="0">
-                <a:solidFill>
-                  <a:srgbClr val="2858A5"/>
-                </a:solidFill>
-                <a:latin typeface="Calibri"/>
-                <a:ea typeface="Calibri"/>
-                <a:cs typeface="Calibri"/>
-              </a:rPr>
-              <a:t>eligible → Publication Control</a:t>
-            </a:r>
-          </a:p>
-        </p:txBody>
-      </p:sp>
-      <p:sp>
-        <p:nvSpPr>
-          <p:cNvPr id="199" name="dp44-implementation-comparison / n176 / text 1">
-            <a:extLst xmlns:a="http://schemas.openxmlformats.org/drawingml/2006/main">
-              <a:ext uri="{FF2B5EF4-FFF2-40B4-BE49-F238E27FC236}">
-                <a16:creationId xmlns:a16="http://schemas.microsoft.com/office/drawing/2014/main" id="{0CBA1341-7B75-438E-B5A0-5DDF252B6E44}"/>
-              </a:ext>
-            </a:extLst>
-          </p:cNvPr>
-          <p:cNvSpPr>
-            <a:spLocks xmlns:a="http://schemas.openxmlformats.org/drawingml/2006/main" noGrp="1"/>
-          </p:cNvSpPr>
-          <p:nvPr/>
-        </p:nvSpPr>
-        <p:spPr>
-          <a:xfrm xmlns:a="http://schemas.openxmlformats.org/drawingml/2006/main">
-            <a:off x="9667875" y="7848600"/>
-            <a:ext cx="7953375" cy="248602"/>
-          </a:xfrm>
-          <a:prstGeom xmlns:a="http://schemas.openxmlformats.org/drawingml/2006/main" prst="rect">
-            <a:avLst/>
-          </a:prstGeom>
-          <a:noFill xmlns:a="http://schemas.openxmlformats.org/drawingml/2006/main"/>
-          <a:ln xmlns:a="http://schemas.openxmlformats.org/drawingml/2006/main" w="0">
-            <a:noFill/>
-            <a:prstDash val="solid"/>
-          </a:ln>
-        </p:spPr>
-        <p:txBody>
-          <a:bodyPr xmlns:a="http://schemas.openxmlformats.org/drawingml/2006/main" wrap="none" lIns="0" tIns="0" rIns="0" bIns="0" anchor="t">
-            <a:noAutofit/>
-          </a:bodyPr>
-          <a:lstStyle xmlns:a="http://schemas.openxmlformats.org/drawingml/2006/main">
-            <a:defPPr algn="l">
-              <a:defRPr sz="1350" b="1">
-                <a:solidFill>
-                  <a:srgbClr val="18232E"/>
-                </a:solidFill>
-                <a:latin typeface="Calibri"/>
-                <a:ea typeface="Calibri"/>
-                <a:cs typeface="Calibri"/>
-              </a:defRPr>
-            </a:defPPr>
-          </a:lstStyle>
-          <a:p xmlns:a="http://schemas.openxmlformats.org/drawingml/2006/main">
-            <a:pPr algn="l">
-              <a:defRPr sz="1350" b="1">
-                <a:solidFill>
-                  <a:srgbClr val="18232E"/>
-                </a:solidFill>
-                <a:latin typeface="Calibri"/>
-                <a:ea typeface="Calibri"/>
-                <a:cs typeface="Calibri"/>
-              </a:defRPr>
-            </a:pPr>
-            <a:r>
-              <a:rPr sz="1350" b="1">
-                <a:solidFill>
-                  <a:srgbClr val="18232E"/>
-                </a:solidFill>
-                <a:latin typeface="Calibri"/>
-                <a:ea typeface="Calibri"/>
-                <a:cs typeface="Calibri"/>
-              </a:rPr>
-              <a:t>J1 늦은 완료: Composer Done Queue에서 자기 Job 무효 검사 후 폐기</a:t>
-            </a:r>
-          </a:p>
-        </p:txBody>
-      </p:sp>
-      <p:sp>
-        <p:nvSpPr>
-          <p:cNvPr id="200" name="dp44-implementation-comparison / n177 / text 1">
-            <a:extLst xmlns:a="http://schemas.openxmlformats.org/drawingml/2006/main">
-              <a:ext uri="{FF2B5EF4-FFF2-40B4-BE49-F238E27FC236}">
-                <a16:creationId xmlns:a16="http://schemas.microsoft.com/office/drawing/2014/main" id="{F74DF091-5885-4B66-91DC-C7B42C8EF28F}"/>
-              </a:ext>
-            </a:extLst>
-          </p:cNvPr>
-          <p:cNvSpPr>
-            <a:spLocks xmlns:a="http://schemas.openxmlformats.org/drawingml/2006/main" noGrp="1"/>
-          </p:cNvSpPr>
-          <p:nvPr/>
-        </p:nvSpPr>
-        <p:spPr>
-          <a:xfrm xmlns:a="http://schemas.openxmlformats.org/drawingml/2006/main">
-            <a:off x="9667875" y="8096250"/>
-            <a:ext cx="7953375" cy="234791"/>
+          <p:cNvPr id="217" name="dp44-implementation-comparison / n192 / text 1">
+            <a:extLst xmlns:a="http://schemas.openxmlformats.org/drawingml/2006/main">
+              <a:ext uri="{FF2B5EF4-FFF2-40B4-BE49-F238E27FC236}">
+                <a16:creationId xmlns:a16="http://schemas.microsoft.com/office/drawing/2014/main" id="{CE08482A-2BF3-44DA-8BE1-22C8BA417DED}"/>
+              </a:ext>
+            </a:extLst>
+          </p:cNvPr>
+          <p:cNvSpPr>
+            <a:spLocks xmlns:a="http://schemas.openxmlformats.org/drawingml/2006/main" noGrp="1"/>
+          </p:cNvSpPr>
+          <p:nvPr/>
+        </p:nvSpPr>
+        <p:spPr>
+          <a:xfrm xmlns:a="http://schemas.openxmlformats.org/drawingml/2006/main">
+            <a:off x="5191125" y="9353550"/>
+            <a:ext cx="1238250" cy="234791"/>
           </a:xfrm>
           <a:prstGeom xmlns:a="http://schemas.openxmlformats.org/drawingml/2006/main" prst="rect">
             <a:avLst/>
@@ -11810,7 +12645,7 @@
             <a:defPPr algn="l">
               <a:defRPr sz="1275" b="0">
                 <a:solidFill>
-                  <a:srgbClr val="5F6B77"/>
+                  <a:srgbClr val="18232E"/>
                 </a:solidFill>
                 <a:latin typeface="Calibri"/>
                 <a:ea typeface="Calibri"/>
@@ -11822,7 +12657,7 @@
             <a:pPr algn="l">
               <a:defRPr sz="1275" b="0">
                 <a:solidFill>
-                  <a:srgbClr val="5F6B77"/>
+                  <a:srgbClr val="18232E"/>
                 </a:solidFill>
                 <a:latin typeface="Calibri"/>
                 <a:ea typeface="Calibri"/>
@@ -11832,610 +12667,34 @@
             <a:r>
               <a:rPr sz="1275" b="0">
                 <a:solidFill>
-                  <a:srgbClr val="5F6B77"/>
+                  <a:srgbClr val="18232E"/>
                 </a:solidFill>
                 <a:latin typeface="Calibri"/>
                 <a:ea typeface="Calibri"/>
                 <a:cs typeface="Calibri"/>
               </a:rPr>
-              <a:t>후보와 조건은 Join의 별도 Queue에 도착하며 ID와 revision으로 결합</a:t>
+              <a:t>enqueue</a:t>
             </a:r>
           </a:p>
         </p:txBody>
       </p:sp>
       <p:sp>
         <p:nvSpPr>
-          <p:cNvPr id="201" name="dp44-implementation-comparison / n178">
-            <a:extLst xmlns:a="http://schemas.openxmlformats.org/drawingml/2006/main">
-              <a:ext uri="{FF2B5EF4-FFF2-40B4-BE49-F238E27FC236}">
-                <a16:creationId xmlns:a16="http://schemas.microsoft.com/office/drawing/2014/main" id="{9D07384D-EB69-4A4C-A5CE-8585F128FC73}"/>
-              </a:ext>
-            </a:extLst>
-          </p:cNvPr>
-          <p:cNvSpPr>
-            <a:spLocks xmlns:a="http://schemas.openxmlformats.org/drawingml/2006/main" noGrp="1"/>
-          </p:cNvSpPr>
-          <p:nvPr/>
-        </p:nvSpPr>
-        <p:spPr>
-          <a:xfrm xmlns:a="http://schemas.openxmlformats.org/drawingml/2006/main">
-            <a:off x="514350" y="8382000"/>
-            <a:ext cx="17259300" cy="638175"/>
-          </a:xfrm>
-          <a:prstGeom xmlns:a="http://schemas.openxmlformats.org/drawingml/2006/main" prst="rect">
-            <a:avLst/>
-          </a:prstGeom>
-          <a:solidFill xmlns:a="http://schemas.openxmlformats.org/drawingml/2006/main">
-            <a:srgbClr val="F4F7FA"/>
-          </a:solidFill>
-          <a:ln xmlns:a="http://schemas.openxmlformats.org/drawingml/2006/main" w="16193">
-            <a:solidFill>
-              <a:srgbClr val="CDD6DE"/>
-            </a:solidFill>
-            <a:prstDash val="solid"/>
-          </a:ln>
-        </p:spPr>
-      </p:sp>
-      <p:sp>
-        <p:nvSpPr>
-          <p:cNvPr id="202" name="dp44-implementation-comparison / n179 / text 1">
-            <a:extLst xmlns:a="http://schemas.openxmlformats.org/drawingml/2006/main">
-              <a:ext uri="{FF2B5EF4-FFF2-40B4-BE49-F238E27FC236}">
-                <a16:creationId xmlns:a16="http://schemas.microsoft.com/office/drawing/2014/main" id="{34A51FB7-4554-4E5D-A54C-9D326A9DDF3C}"/>
-              </a:ext>
-            </a:extLst>
-          </p:cNvPr>
-          <p:cNvSpPr>
-            <a:spLocks xmlns:a="http://schemas.openxmlformats.org/drawingml/2006/main" noGrp="1"/>
-          </p:cNvSpPr>
-          <p:nvPr/>
-        </p:nvSpPr>
-        <p:spPr>
-          <a:xfrm xmlns:a="http://schemas.openxmlformats.org/drawingml/2006/main">
-            <a:off x="666750" y="8486775"/>
-            <a:ext cx="2190750" cy="262414"/>
-          </a:xfrm>
-          <a:prstGeom xmlns:a="http://schemas.openxmlformats.org/drawingml/2006/main" prst="rect">
-            <a:avLst/>
-          </a:prstGeom>
-          <a:noFill xmlns:a="http://schemas.openxmlformats.org/drawingml/2006/main"/>
-          <a:ln xmlns:a="http://schemas.openxmlformats.org/drawingml/2006/main" w="0">
-            <a:noFill/>
-            <a:prstDash val="solid"/>
-          </a:ln>
-        </p:spPr>
-        <p:txBody>
-          <a:bodyPr xmlns:a="http://schemas.openxmlformats.org/drawingml/2006/main" wrap="none" lIns="0" tIns="0" rIns="0" bIns="0" anchor="t">
-            <a:noAutofit/>
-          </a:bodyPr>
-          <a:lstStyle xmlns:a="http://schemas.openxmlformats.org/drawingml/2006/main">
-            <a:defPPr algn="l">
-              <a:defRPr sz="1425" b="1">
-                <a:solidFill>
-                  <a:srgbClr val="18232E"/>
-                </a:solidFill>
-                <a:latin typeface="Calibri"/>
-                <a:ea typeface="Calibri"/>
-                <a:cs typeface="Calibri"/>
-              </a:defRPr>
-            </a:defPPr>
-          </a:lstStyle>
-          <a:p xmlns:a="http://schemas.openxmlformats.org/drawingml/2006/main">
-            <a:pPr algn="l">
-              <a:defRPr sz="1425" b="1">
-                <a:solidFill>
-                  <a:srgbClr val="18232E"/>
-                </a:solidFill>
-                <a:latin typeface="Calibri"/>
-                <a:ea typeface="Calibri"/>
-                <a:cs typeface="Calibri"/>
-              </a:defRPr>
-            </a:pPr>
-            <a:r>
-              <a:rPr sz="1425" b="1">
-                <a:solidFill>
-                  <a:srgbClr val="18232E"/>
-                </a:solidFill>
-                <a:latin typeface="Calibri"/>
-                <a:ea typeface="Calibri"/>
-                <a:cs typeface="Calibri"/>
-              </a:rPr>
-              <a:t>양안 공통 최종 전달</a:t>
-            </a:r>
-          </a:p>
-        </p:txBody>
-      </p:sp>
-      <p:sp>
-        <p:nvSpPr>
-          <p:cNvPr id="203" name="dp44-implementation-comparison / n180 / text 1">
-            <a:extLst xmlns:a="http://schemas.openxmlformats.org/drawingml/2006/main">
-              <a:ext uri="{FF2B5EF4-FFF2-40B4-BE49-F238E27FC236}">
-                <a16:creationId xmlns:a16="http://schemas.microsoft.com/office/drawing/2014/main" id="{8F1D2CB1-46B8-49CA-91D0-036484815199}"/>
-              </a:ext>
-            </a:extLst>
-          </p:cNvPr>
-          <p:cNvSpPr>
-            <a:spLocks xmlns:a="http://schemas.openxmlformats.org/drawingml/2006/main" noGrp="1"/>
-          </p:cNvSpPr>
-          <p:nvPr/>
-        </p:nvSpPr>
-        <p:spPr>
-          <a:xfrm xmlns:a="http://schemas.openxmlformats.org/drawingml/2006/main">
-            <a:off x="3000375" y="8486775"/>
-            <a:ext cx="14620875" cy="262414"/>
-          </a:xfrm>
-          <a:prstGeom xmlns:a="http://schemas.openxmlformats.org/drawingml/2006/main" prst="rect">
-            <a:avLst/>
-          </a:prstGeom>
-          <a:noFill xmlns:a="http://schemas.openxmlformats.org/drawingml/2006/main"/>
-          <a:ln xmlns:a="http://schemas.openxmlformats.org/drawingml/2006/main" w="0">
-            <a:noFill/>
-            <a:prstDash val="solid"/>
-          </a:ln>
-        </p:spPr>
-        <p:txBody>
-          <a:bodyPr xmlns:a="http://schemas.openxmlformats.org/drawingml/2006/main" wrap="none" lIns="0" tIns="0" rIns="0" bIns="0" anchor="t">
-            <a:noAutofit/>
-          </a:bodyPr>
-          <a:lstStyle xmlns:a="http://schemas.openxmlformats.org/drawingml/2006/main">
-            <a:defPPr algn="l">
-              <a:defRPr sz="1425" b="0">
-                <a:solidFill>
-                  <a:srgbClr val="18232E"/>
-                </a:solidFill>
-                <a:latin typeface="Calibri"/>
-                <a:ea typeface="Calibri"/>
-                <a:cs typeface="Calibri"/>
-              </a:defRPr>
-            </a:defPPr>
-          </a:lstStyle>
-          <a:p xmlns:a="http://schemas.openxmlformats.org/drawingml/2006/main">
-            <a:pPr algn="l">
-              <a:defRPr sz="1425" b="0">
-                <a:solidFill>
-                  <a:srgbClr val="18232E"/>
-                </a:solidFill>
-                <a:latin typeface="Calibri"/>
-                <a:ea typeface="Calibri"/>
-                <a:cs typeface="Calibri"/>
-              </a:defRPr>
-            </a:pPr>
-            <a:r>
-              <a:rPr sz="1425" b="0">
-                <a:solidFill>
-                  <a:srgbClr val="18232E"/>
-                </a:solidFill>
-                <a:latin typeface="Calibri"/>
-                <a:ea typeface="Calibri"/>
-                <a:cs typeface="Calibri"/>
-              </a:rPr>
-              <a:t>Publication Control 현재성 및 권한 확인 → Interaction Manager 실제 표시와 재생 → ActualReceipt → Presented</a:t>
-            </a:r>
-          </a:p>
-        </p:txBody>
-      </p:sp>
-      <p:sp>
-        <p:nvSpPr>
-          <p:cNvPr id="204" name="dp44-implementation-comparison / n181 / text 1">
-            <a:extLst xmlns:a="http://schemas.openxmlformats.org/drawingml/2006/main">
-              <a:ext uri="{FF2B5EF4-FFF2-40B4-BE49-F238E27FC236}">
-                <a16:creationId xmlns:a16="http://schemas.microsoft.com/office/drawing/2014/main" id="{71466A0B-2DD2-46C1-8B88-6214164C0CBF}"/>
-              </a:ext>
-            </a:extLst>
-          </p:cNvPr>
-          <p:cNvSpPr>
-            <a:spLocks xmlns:a="http://schemas.openxmlformats.org/drawingml/2006/main" noGrp="1"/>
-          </p:cNvSpPr>
-          <p:nvPr/>
-        </p:nvSpPr>
-        <p:spPr>
-          <a:xfrm xmlns:a="http://schemas.openxmlformats.org/drawingml/2006/main">
-            <a:off x="666750" y="8743950"/>
-            <a:ext cx="16906875" cy="234791"/>
-          </a:xfrm>
-          <a:prstGeom xmlns:a="http://schemas.openxmlformats.org/drawingml/2006/main" prst="rect">
-            <a:avLst/>
-          </a:prstGeom>
-          <a:noFill xmlns:a="http://schemas.openxmlformats.org/drawingml/2006/main"/>
-          <a:ln xmlns:a="http://schemas.openxmlformats.org/drawingml/2006/main" w="0">
-            <a:noFill/>
-            <a:prstDash val="solid"/>
-          </a:ln>
-        </p:spPr>
-        <p:txBody>
-          <a:bodyPr xmlns:a="http://schemas.openxmlformats.org/drawingml/2006/main" wrap="none" lIns="0" tIns="0" rIns="0" bIns="0" anchor="t">
-            <a:noAutofit/>
-          </a:bodyPr>
-          <a:lstStyle xmlns:a="http://schemas.openxmlformats.org/drawingml/2006/main">
-            <a:defPPr algn="l">
-              <a:defRPr sz="1275" b="0">
-                <a:solidFill>
-                  <a:srgbClr val="5F6B77"/>
-                </a:solidFill>
-                <a:latin typeface="Calibri"/>
-                <a:ea typeface="Calibri"/>
-                <a:cs typeface="Calibri"/>
-              </a:defRPr>
-            </a:defPPr>
-          </a:lstStyle>
-          <a:p xmlns:a="http://schemas.openxmlformats.org/drawingml/2006/main">
-            <a:pPr algn="l">
-              <a:defRPr sz="1275" b="0">
-                <a:solidFill>
-                  <a:srgbClr val="5F6B77"/>
-                </a:solidFill>
-                <a:latin typeface="Calibri"/>
-                <a:ea typeface="Calibri"/>
-                <a:cs typeface="Calibri"/>
-              </a:defRPr>
-            </a:pPr>
-            <a:r>
-              <a:rPr sz="1275" b="0">
-                <a:solidFill>
-                  <a:srgbClr val="5F6B77"/>
-                </a:solidFill>
-                <a:latin typeface="Calibri"/>
-                <a:ea typeface="Calibri"/>
-                <a:cs typeface="Calibri"/>
-              </a:rPr>
-              <a:t>발화 감지는 즉시 출력 중단과 관련 게시 hold를 유발한다. Task나 Job 취소는 정정 의도 채택 후 별도로 판단한다.</a:t>
-            </a:r>
-          </a:p>
-        </p:txBody>
-      </p:sp>
-      <p:sp>
-        <p:nvSpPr>
-          <p:cNvPr id="205" name="dp44-implementation-comparison / n182">
-            <a:extLst xmlns:a="http://schemas.openxmlformats.org/drawingml/2006/main">
-              <a:ext uri="{FF2B5EF4-FFF2-40B4-BE49-F238E27FC236}">
-                <a16:creationId xmlns:a16="http://schemas.microsoft.com/office/drawing/2014/main" id="{D5CBDE6B-F438-423B-9F7F-FF53356359C4}"/>
-              </a:ext>
-            </a:extLst>
-          </p:cNvPr>
-          <p:cNvSpPr>
-            <a:spLocks xmlns:a="http://schemas.openxmlformats.org/drawingml/2006/main" noGrp="1"/>
-          </p:cNvSpPr>
-          <p:nvPr/>
-        </p:nvSpPr>
-        <p:spPr>
-          <a:xfrm xmlns:a="http://schemas.openxmlformats.org/drawingml/2006/main">
-            <a:off x="514350" y="9286875"/>
-            <a:ext cx="1695450" cy="438150"/>
-          </a:xfrm>
-          <a:prstGeom xmlns:a="http://schemas.openxmlformats.org/drawingml/2006/main" prst="rect">
-            <a:avLst/>
-          </a:prstGeom>
-          <a:solidFill xmlns:a="http://schemas.openxmlformats.org/drawingml/2006/main">
-            <a:srgbClr val="FFFFFF"/>
-          </a:solidFill>
-          <a:ln xmlns:a="http://schemas.openxmlformats.org/drawingml/2006/main" w="16193">
-            <a:solidFill>
-              <a:srgbClr val="B8753F"/>
-            </a:solidFill>
-            <a:prstDash val="solid"/>
-          </a:ln>
-        </p:spPr>
-      </p:sp>
-      <p:sp>
-        <p:nvSpPr>
-          <p:cNvPr id="206" name="dp44-implementation-comparison / n183 / text 1">
-            <a:extLst xmlns:a="http://schemas.openxmlformats.org/drawingml/2006/main">
-              <a:ext uri="{FF2B5EF4-FFF2-40B4-BE49-F238E27FC236}">
-                <a16:creationId xmlns:a16="http://schemas.microsoft.com/office/drawing/2014/main" id="{7A70CF74-C266-4CFF-9EB0-DAE893EDCB89}"/>
-              </a:ext>
-            </a:extLst>
-          </p:cNvPr>
-          <p:cNvSpPr>
-            <a:spLocks xmlns:a="http://schemas.openxmlformats.org/drawingml/2006/main" noGrp="1"/>
-          </p:cNvSpPr>
-          <p:nvPr/>
-        </p:nvSpPr>
-        <p:spPr>
-          <a:xfrm xmlns:a="http://schemas.openxmlformats.org/drawingml/2006/main">
-            <a:off x="600075" y="9353550"/>
-            <a:ext cx="1524000" cy="220980"/>
-          </a:xfrm>
-          <a:prstGeom xmlns:a="http://schemas.openxmlformats.org/drawingml/2006/main" prst="rect">
-            <a:avLst/>
-          </a:prstGeom>
-          <a:noFill xmlns:a="http://schemas.openxmlformats.org/drawingml/2006/main"/>
-          <a:ln xmlns:a="http://schemas.openxmlformats.org/drawingml/2006/main" w="0">
-            <a:noFill/>
-            <a:prstDash val="solid"/>
-          </a:ln>
-        </p:spPr>
-        <p:txBody>
-          <a:bodyPr xmlns:a="http://schemas.openxmlformats.org/drawingml/2006/main" wrap="none" lIns="0" tIns="0" rIns="0" bIns="0" anchor="t">
-            <a:noAutofit/>
-          </a:bodyPr>
-          <a:lstStyle xmlns:a="http://schemas.openxmlformats.org/drawingml/2006/main">
-            <a:defPPr algn="l">
-              <a:defRPr sz="1200" b="1">
-                <a:solidFill>
-                  <a:srgbClr val="18232E"/>
-                </a:solidFill>
-                <a:latin typeface="Calibri"/>
-                <a:ea typeface="Calibri"/>
-                <a:cs typeface="Calibri"/>
-              </a:defRPr>
-            </a:defPPr>
-          </a:lstStyle>
-          <a:p xmlns:a="http://schemas.openxmlformats.org/drawingml/2006/main">
-            <a:pPr algn="l">
-              <a:defRPr sz="1200" b="1">
-                <a:solidFill>
-                  <a:srgbClr val="18232E"/>
-                </a:solidFill>
-                <a:latin typeface="Calibri"/>
-                <a:ea typeface="Calibri"/>
-                <a:cs typeface="Calibri"/>
-              </a:defRPr>
-            </a:pPr>
-            <a:r>
-              <a:rPr sz="1200" b="1">
-                <a:solidFill>
-                  <a:srgbClr val="18232E"/>
-                </a:solidFill>
-                <a:latin typeface="Calibri"/>
-                <a:ea typeface="Calibri"/>
-                <a:cs typeface="Calibri"/>
-              </a:rPr>
-              <a:t>Queue</a:t>
-            </a:r>
-          </a:p>
-        </p:txBody>
-      </p:sp>
-      <p:sp>
-        <p:nvSpPr>
-          <p:cNvPr id="207" name="dp44-implementation-comparison / n184">
-            <a:extLst xmlns:a="http://schemas.openxmlformats.org/drawingml/2006/main">
-              <a:ext uri="{FF2B5EF4-FFF2-40B4-BE49-F238E27FC236}">
-                <a16:creationId xmlns:a16="http://schemas.microsoft.com/office/drawing/2014/main" id="{E4BD2E90-1C1E-4616-8DD7-D8637DEB1BC3}"/>
-              </a:ext>
-            </a:extLst>
-          </p:cNvPr>
-          <p:cNvSpPr>
-            <a:spLocks xmlns:a="http://schemas.openxmlformats.org/drawingml/2006/main" noGrp="1"/>
-          </p:cNvSpPr>
-          <p:nvPr/>
-        </p:nvSpPr>
-        <p:spPr>
-          <a:xfrm xmlns:a="http://schemas.openxmlformats.org/drawingml/2006/main">
-            <a:off x="1409700" y="9515475"/>
-            <a:ext cx="142875" cy="142875"/>
-          </a:xfrm>
-          <a:prstGeom xmlns:a="http://schemas.openxmlformats.org/drawingml/2006/main" prst="rect">
-            <a:avLst/>
-          </a:prstGeom>
-          <a:solidFill xmlns:a="http://schemas.openxmlformats.org/drawingml/2006/main">
-            <a:srgbClr val="FFFFFF"/>
-          </a:solidFill>
-          <a:ln xmlns:a="http://schemas.openxmlformats.org/drawingml/2006/main" w="16193">
-            <a:solidFill>
-              <a:srgbClr val="5F6B77"/>
-            </a:solidFill>
-            <a:prstDash val="solid"/>
-          </a:ln>
-        </p:spPr>
-      </p:sp>
-      <p:sp>
-        <p:nvSpPr>
-          <p:cNvPr id="208" name="dp44-implementation-comparison / n185">
-            <a:extLst xmlns:a="http://schemas.openxmlformats.org/drawingml/2006/main">
-              <a:ext uri="{FF2B5EF4-FFF2-40B4-BE49-F238E27FC236}">
-                <a16:creationId xmlns:a16="http://schemas.microsoft.com/office/drawing/2014/main" id="{1880E16A-2A70-4262-BFC3-C5E3B9F782F2}"/>
-              </a:ext>
-            </a:extLst>
-          </p:cNvPr>
-          <p:cNvSpPr>
-            <a:spLocks xmlns:a="http://schemas.openxmlformats.org/drawingml/2006/main" noGrp="1"/>
-          </p:cNvSpPr>
-          <p:nvPr/>
-        </p:nvSpPr>
-        <p:spPr>
-          <a:xfrm xmlns:a="http://schemas.openxmlformats.org/drawingml/2006/main">
-            <a:off x="1590675" y="9515475"/>
-            <a:ext cx="142875" cy="142875"/>
-          </a:xfrm>
-          <a:prstGeom xmlns:a="http://schemas.openxmlformats.org/drawingml/2006/main" prst="rect">
-            <a:avLst/>
-          </a:prstGeom>
-          <a:solidFill xmlns:a="http://schemas.openxmlformats.org/drawingml/2006/main">
-            <a:srgbClr val="FFFFFF"/>
-          </a:solidFill>
-          <a:ln xmlns:a="http://schemas.openxmlformats.org/drawingml/2006/main" w="16193">
-            <a:solidFill>
-              <a:srgbClr val="5F6B77"/>
-            </a:solidFill>
-            <a:prstDash val="solid"/>
-          </a:ln>
-        </p:spPr>
-      </p:sp>
-      <p:sp>
-        <p:nvSpPr>
-          <p:cNvPr id="209" name="dp44-implementation-comparison / n186">
-            <a:extLst xmlns:a="http://schemas.openxmlformats.org/drawingml/2006/main">
-              <a:ext uri="{FF2B5EF4-FFF2-40B4-BE49-F238E27FC236}">
-                <a16:creationId xmlns:a16="http://schemas.microsoft.com/office/drawing/2014/main" id="{E1B0C30B-4A2D-4343-943B-A9A23D255AD5}"/>
-              </a:ext>
-            </a:extLst>
-          </p:cNvPr>
-          <p:cNvSpPr>
-            <a:spLocks xmlns:a="http://schemas.openxmlformats.org/drawingml/2006/main" noGrp="1"/>
-          </p:cNvSpPr>
-          <p:nvPr/>
-        </p:nvSpPr>
-        <p:spPr>
-          <a:xfrm xmlns:a="http://schemas.openxmlformats.org/drawingml/2006/main">
-            <a:off x="1771650" y="9515475"/>
-            <a:ext cx="142875" cy="142875"/>
-          </a:xfrm>
-          <a:prstGeom xmlns:a="http://schemas.openxmlformats.org/drawingml/2006/main" prst="rect">
-            <a:avLst/>
-          </a:prstGeom>
-          <a:solidFill xmlns:a="http://schemas.openxmlformats.org/drawingml/2006/main">
-            <a:srgbClr val="FFFFFF"/>
-          </a:solidFill>
-          <a:ln xmlns:a="http://schemas.openxmlformats.org/drawingml/2006/main" w="16193">
-            <a:solidFill>
-              <a:srgbClr val="5F6B77"/>
-            </a:solidFill>
-            <a:prstDash val="solid"/>
-          </a:ln>
-        </p:spPr>
-      </p:sp>
-      <p:sp>
-        <p:nvSpPr>
-          <p:cNvPr id="210" name="dp44-implementation-comparison / n187">
-            <a:extLst xmlns:a="http://schemas.openxmlformats.org/drawingml/2006/main">
-              <a:ext uri="{FF2B5EF4-FFF2-40B4-BE49-F238E27FC236}">
-                <a16:creationId xmlns:a16="http://schemas.microsoft.com/office/drawing/2014/main" id="{044AF4D0-DFA6-444E-9C26-566903C699F4}"/>
-              </a:ext>
-            </a:extLst>
-          </p:cNvPr>
-          <p:cNvSpPr>
-            <a:spLocks xmlns:a="http://schemas.openxmlformats.org/drawingml/2006/main" noGrp="1"/>
-          </p:cNvSpPr>
-          <p:nvPr/>
-        </p:nvSpPr>
-        <p:spPr>
-          <a:xfrm xmlns:a="http://schemas.openxmlformats.org/drawingml/2006/main">
-            <a:off x="1952625" y="9515475"/>
-            <a:ext cx="142875" cy="142875"/>
-          </a:xfrm>
-          <a:prstGeom xmlns:a="http://schemas.openxmlformats.org/drawingml/2006/main" prst="rect">
-            <a:avLst/>
-          </a:prstGeom>
-          <a:solidFill xmlns:a="http://schemas.openxmlformats.org/drawingml/2006/main">
-            <a:srgbClr val="FFFFFF"/>
-          </a:solidFill>
-          <a:ln xmlns:a="http://schemas.openxmlformats.org/drawingml/2006/main" w="16193">
-            <a:solidFill>
-              <a:srgbClr val="5F6B77"/>
-            </a:solidFill>
-            <a:prstDash val="solid"/>
-          </a:ln>
-        </p:spPr>
-      </p:sp>
-      <p:sp>
-        <p:nvSpPr>
-          <p:cNvPr id="211" name="dp44-implementation-comparison / n188">
-            <a:extLst xmlns:a="http://schemas.openxmlformats.org/drawingml/2006/main">
-              <a:ext uri="{FF2B5EF4-FFF2-40B4-BE49-F238E27FC236}">
-                <a16:creationId xmlns:a16="http://schemas.microsoft.com/office/drawing/2014/main" id="{55D7987A-3B60-42AD-BF57-462A6BD6F7BE}"/>
-              </a:ext>
-            </a:extLst>
-          </p:cNvPr>
-          <p:cNvSpPr>
-            <a:spLocks xmlns:a="http://schemas.openxmlformats.org/drawingml/2006/main" noGrp="1"/>
-          </p:cNvSpPr>
-          <p:nvPr/>
-        </p:nvSpPr>
-        <p:spPr>
-          <a:xfrm xmlns:a="http://schemas.openxmlformats.org/drawingml/2006/main">
-            <a:off x="2476500" y="9286875"/>
-            <a:ext cx="1695450" cy="438150"/>
-          </a:xfrm>
-          <a:prstGeom xmlns:a="http://schemas.openxmlformats.org/drawingml/2006/main" prst="can">
-            <a:avLst/>
-          </a:prstGeom>
-          <a:solidFill xmlns:a="http://schemas.openxmlformats.org/drawingml/2006/main">
-            <a:srgbClr val="FFFFFF"/>
-          </a:solidFill>
-          <a:ln xmlns:a="http://schemas.openxmlformats.org/drawingml/2006/main" w="16193">
-            <a:solidFill>
-              <a:srgbClr val="B8753F"/>
-            </a:solidFill>
-            <a:prstDash val="solid"/>
-          </a:ln>
-        </p:spPr>
-      </p:sp>
-      <p:sp>
-        <p:nvSpPr>
-          <p:cNvPr id="212" name="dp44-implementation-comparison / n189 / text 1">
-            <a:extLst xmlns:a="http://schemas.openxmlformats.org/drawingml/2006/main">
-              <a:ext uri="{FF2B5EF4-FFF2-40B4-BE49-F238E27FC236}">
-                <a16:creationId xmlns:a16="http://schemas.microsoft.com/office/drawing/2014/main" id="{2DA6AE18-DBB0-4363-8213-6C24A1DA1AB2}"/>
-              </a:ext>
-            </a:extLst>
-          </p:cNvPr>
-          <p:cNvSpPr>
-            <a:spLocks xmlns:a="http://schemas.openxmlformats.org/drawingml/2006/main" noGrp="1"/>
-          </p:cNvSpPr>
-          <p:nvPr/>
-        </p:nvSpPr>
-        <p:spPr>
-          <a:xfrm xmlns:a="http://schemas.openxmlformats.org/drawingml/2006/main">
-            <a:off x="2562225" y="9458325"/>
-            <a:ext cx="1524000" cy="207169"/>
-          </a:xfrm>
-          <a:prstGeom xmlns:a="http://schemas.openxmlformats.org/drawingml/2006/main" prst="rect">
-            <a:avLst/>
-          </a:prstGeom>
-          <a:noFill xmlns:a="http://schemas.openxmlformats.org/drawingml/2006/main"/>
-          <a:ln xmlns:a="http://schemas.openxmlformats.org/drawingml/2006/main" w="0">
-            <a:noFill/>
-            <a:prstDash val="solid"/>
-          </a:ln>
-        </p:spPr>
-        <p:txBody>
-          <a:bodyPr xmlns:a="http://schemas.openxmlformats.org/drawingml/2006/main" wrap="none" lIns="0" tIns="0" rIns="0" bIns="0" anchor="t">
-            <a:noAutofit/>
-          </a:bodyPr>
-          <a:lstStyle xmlns:a="http://schemas.openxmlformats.org/drawingml/2006/main">
-            <a:defPPr algn="l">
-              <a:defRPr sz="1125" b="0">
-                <a:solidFill>
-                  <a:srgbClr val="18232E"/>
-                </a:solidFill>
-                <a:latin typeface="Calibri"/>
-                <a:ea typeface="Calibri"/>
-                <a:cs typeface="Calibri"/>
-              </a:defRPr>
-            </a:defPPr>
-          </a:lstStyle>
-          <a:p xmlns:a="http://schemas.openxmlformats.org/drawingml/2006/main">
-            <a:pPr algn="l">
-              <a:defRPr sz="1125" b="0">
-                <a:solidFill>
-                  <a:srgbClr val="18232E"/>
-                </a:solidFill>
-                <a:latin typeface="Calibri"/>
-                <a:ea typeface="Calibri"/>
-                <a:cs typeface="Calibri"/>
-              </a:defRPr>
-            </a:pPr>
-            <a:r>
-              <a:rPr sz="1125" b="0">
-                <a:solidFill>
-                  <a:srgbClr val="18232E"/>
-                </a:solidFill>
-                <a:latin typeface="Calibri"/>
-                <a:ea typeface="Calibri"/>
-                <a:cs typeface="Calibri"/>
-              </a:rPr>
-              <a:t>상태 원통</a:t>
-            </a:r>
-          </a:p>
-        </p:txBody>
-      </p:sp>
-      <p:sp>
-        <p:nvSpPr>
-          <p:cNvPr id="213" name="dp44-implementation-comparison / n190 / path">
-            <a:extLst xmlns:a="http://schemas.openxmlformats.org/drawingml/2006/main">
-              <a:ext uri="{FF2B5EF4-FFF2-40B4-BE49-F238E27FC236}">
-                <a16:creationId xmlns:a16="http://schemas.microsoft.com/office/drawing/2014/main" id="{2CFEABFE-2F38-4D60-B323-82190695F102}"/>
-              </a:ext>
-            </a:extLst>
-          </p:cNvPr>
-          <p:cNvSpPr>
-            <a:spLocks xmlns:a="http://schemas.openxmlformats.org/drawingml/2006/main" noGrp="1"/>
-          </p:cNvSpPr>
-          <p:nvPr/>
-        </p:nvSpPr>
-        <p:spPr>
-          <a:xfrm xmlns:a="http://schemas.openxmlformats.org/drawingml/2006/main">
-            <a:off x="4476750" y="9505950"/>
+          <p:cNvPr id="218" name="dp44-implementation-comparison / n193 / path">
+            <a:extLst xmlns:a="http://schemas.openxmlformats.org/drawingml/2006/main">
+              <a:ext uri="{FF2B5EF4-FFF2-40B4-BE49-F238E27FC236}">
+                <a16:creationId xmlns:a16="http://schemas.microsoft.com/office/drawing/2014/main" id="{02F2C009-264C-4203-8C02-C8C200758BAE}"/>
+              </a:ext>
+            </a:extLst>
+          </p:cNvPr>
+          <p:cNvSpPr>
+            <a:spLocks xmlns:a="http://schemas.openxmlformats.org/drawingml/2006/main" noGrp="1"/>
+          </p:cNvSpPr>
+          <p:nvPr/>
+        </p:nvSpPr>
+        <p:spPr>
+          <a:xfrm xmlns:a="http://schemas.openxmlformats.org/drawingml/2006/main">
+            <a:off x="6572250" y="9505950"/>
             <a:ext cx="619125" cy="953"/>
           </a:xfrm>
           <a:custGeom xmlns:a="http://schemas.openxmlformats.org/drawingml/2006/main">
@@ -12455,27 +12714,27 @@
             <a:solidFill>
               <a:srgbClr val="2858A5"/>
             </a:solidFill>
-            <a:prstDash val="solid"/>
-          </a:ln>
-        </p:spPr>
-      </p:sp>
-      <p:sp>
-        <p:nvSpPr>
-          <p:cNvPr id="214" name="dp44-implementation-comparison / n190 / arrow">
-            <a:extLst xmlns:a="http://schemas.openxmlformats.org/drawingml/2006/main">
-              <a:ext uri="{FF2B5EF4-FFF2-40B4-BE49-F238E27FC236}">
-                <a16:creationId xmlns:a16="http://schemas.microsoft.com/office/drawing/2014/main" id="{B78EDEBA-7C1E-46C6-B830-8071AB7FBEAA}"/>
-              </a:ext>
-            </a:extLst>
-          </p:cNvPr>
-          <p:cNvSpPr>
-            <a:spLocks xmlns:a="http://schemas.openxmlformats.org/drawingml/2006/main" noGrp="1"/>
-          </p:cNvSpPr>
-          <p:nvPr/>
-        </p:nvSpPr>
-        <p:spPr>
-          <a:xfrm xmlns:a="http://schemas.openxmlformats.org/drawingml/2006/main">
-            <a:off x="4973955" y="9444990"/>
+            <a:prstDash val="dash"/>
+          </a:ln>
+        </p:spPr>
+      </p:sp>
+      <p:sp>
+        <p:nvSpPr>
+          <p:cNvPr id="219" name="dp44-implementation-comparison / n193 / arrow">
+            <a:extLst xmlns:a="http://schemas.openxmlformats.org/drawingml/2006/main">
+              <a:ext uri="{FF2B5EF4-FFF2-40B4-BE49-F238E27FC236}">
+                <a16:creationId xmlns:a16="http://schemas.microsoft.com/office/drawing/2014/main" id="{3A771203-45F2-4F0D-B420-8E08E1446459}"/>
+              </a:ext>
+            </a:extLst>
+          </p:cNvPr>
+          <p:cNvSpPr>
+            <a:spLocks xmlns:a="http://schemas.openxmlformats.org/drawingml/2006/main" noGrp="1"/>
+          </p:cNvSpPr>
+          <p:nvPr/>
+        </p:nvSpPr>
+        <p:spPr>
+          <a:xfrm xmlns:a="http://schemas.openxmlformats.org/drawingml/2006/main">
+            <a:off x="7069455" y="9444990"/>
             <a:ext cx="121920" cy="121920"/>
           </a:xfrm>
           <a:custGeom xmlns:a="http://schemas.openxmlformats.org/drawingml/2006/main">
@@ -12504,22 +12763,22 @@
       </p:sp>
       <p:sp>
         <p:nvSpPr>
-          <p:cNvPr id="215" name="dp44-implementation-comparison / n191 / text 1">
-            <a:extLst xmlns:a="http://schemas.openxmlformats.org/drawingml/2006/main">
-              <a:ext uri="{FF2B5EF4-FFF2-40B4-BE49-F238E27FC236}">
-                <a16:creationId xmlns:a16="http://schemas.microsoft.com/office/drawing/2014/main" id="{F7E24ECE-B495-4FCE-A989-0E8E1AB56A8E}"/>
-              </a:ext>
-            </a:extLst>
-          </p:cNvPr>
-          <p:cNvSpPr>
-            <a:spLocks xmlns:a="http://schemas.openxmlformats.org/drawingml/2006/main" noGrp="1"/>
-          </p:cNvSpPr>
-          <p:nvPr/>
-        </p:nvSpPr>
-        <p:spPr>
-          <a:xfrm xmlns:a="http://schemas.openxmlformats.org/drawingml/2006/main">
-            <a:off x="5191125" y="9353550"/>
-            <a:ext cx="1238250" cy="234791"/>
+          <p:cNvPr id="220" name="dp44-implementation-comparison / n194 / text 1">
+            <a:extLst xmlns:a="http://schemas.openxmlformats.org/drawingml/2006/main">
+              <a:ext uri="{FF2B5EF4-FFF2-40B4-BE49-F238E27FC236}">
+                <a16:creationId xmlns:a16="http://schemas.microsoft.com/office/drawing/2014/main" id="{635F1603-F01C-446C-9B77-EEF38DDDDC71}"/>
+              </a:ext>
+            </a:extLst>
+          </p:cNvPr>
+          <p:cNvSpPr>
+            <a:spLocks xmlns:a="http://schemas.openxmlformats.org/drawingml/2006/main" noGrp="1"/>
+          </p:cNvSpPr>
+          <p:nvPr/>
+        </p:nvSpPr>
+        <p:spPr>
+          <a:xfrm xmlns:a="http://schemas.openxmlformats.org/drawingml/2006/main">
+            <a:off x="7286625" y="9353550"/>
+            <a:ext cx="1666875" cy="234791"/>
           </a:xfrm>
           <a:prstGeom xmlns:a="http://schemas.openxmlformats.org/drawingml/2006/main" prst="rect">
             <a:avLst/>
@@ -12566,28 +12825,28 @@
                 <a:ea typeface="Calibri"/>
                 <a:cs typeface="Calibri"/>
               </a:rPr>
-              <a:t>enqueue</a:t>
+              <a:t>완료 callback</a:t>
             </a:r>
           </a:p>
         </p:txBody>
       </p:sp>
       <p:sp>
         <p:nvSpPr>
-          <p:cNvPr id="216" name="dp44-implementation-comparison / n192 / path">
-            <a:extLst xmlns:a="http://schemas.openxmlformats.org/drawingml/2006/main">
-              <a:ext uri="{FF2B5EF4-FFF2-40B4-BE49-F238E27FC236}">
-                <a16:creationId xmlns:a16="http://schemas.microsoft.com/office/drawing/2014/main" id="{C830D0B6-7A83-4E2B-A948-CECADAD46CDB}"/>
-              </a:ext>
-            </a:extLst>
-          </p:cNvPr>
-          <p:cNvSpPr>
-            <a:spLocks xmlns:a="http://schemas.openxmlformats.org/drawingml/2006/main" noGrp="1"/>
-          </p:cNvSpPr>
-          <p:nvPr/>
-        </p:nvSpPr>
-        <p:spPr>
-          <a:xfrm xmlns:a="http://schemas.openxmlformats.org/drawingml/2006/main">
-            <a:off x="6572250" y="9505950"/>
+          <p:cNvPr id="221" name="dp44-implementation-comparison / n195 / path">
+            <a:extLst xmlns:a="http://schemas.openxmlformats.org/drawingml/2006/main">
+              <a:ext uri="{FF2B5EF4-FFF2-40B4-BE49-F238E27FC236}">
+                <a16:creationId xmlns:a16="http://schemas.microsoft.com/office/drawing/2014/main" id="{AFCC0866-04A2-4868-9E10-05D0D51C6B3E}"/>
+              </a:ext>
+            </a:extLst>
+          </p:cNvPr>
+          <p:cNvSpPr>
+            <a:spLocks xmlns:a="http://schemas.openxmlformats.org/drawingml/2006/main" noGrp="1"/>
+          </p:cNvSpPr>
+          <p:nvPr/>
+        </p:nvSpPr>
+        <p:spPr>
+          <a:xfrm xmlns:a="http://schemas.openxmlformats.org/drawingml/2006/main">
+            <a:off x="9239250" y="9505950"/>
             <a:ext cx="619125" cy="953"/>
           </a:xfrm>
           <a:custGeom xmlns:a="http://schemas.openxmlformats.org/drawingml/2006/main">
@@ -12605,7 +12864,7 @@
           <a:noFill xmlns:a="http://schemas.openxmlformats.org/drawingml/2006/main"/>
           <a:ln xmlns:a="http://schemas.openxmlformats.org/drawingml/2006/main" w="19050">
             <a:solidFill>
-              <a:srgbClr val="2858A5"/>
+              <a:srgbClr val="B63732"/>
             </a:solidFill>
             <a:prstDash val="dash"/>
           </a:ln>
@@ -12613,21 +12872,21 @@
       </p:sp>
       <p:sp>
         <p:nvSpPr>
-          <p:cNvPr id="217" name="dp44-implementation-comparison / n192 / arrow">
-            <a:extLst xmlns:a="http://schemas.openxmlformats.org/drawingml/2006/main">
-              <a:ext uri="{FF2B5EF4-FFF2-40B4-BE49-F238E27FC236}">
-                <a16:creationId xmlns:a16="http://schemas.microsoft.com/office/drawing/2014/main" id="{D557B9F3-EE60-4B4C-87BE-E7C60CFD8872}"/>
-              </a:ext>
-            </a:extLst>
-          </p:cNvPr>
-          <p:cNvSpPr>
-            <a:spLocks xmlns:a="http://schemas.openxmlformats.org/drawingml/2006/main" noGrp="1"/>
-          </p:cNvSpPr>
-          <p:nvPr/>
-        </p:nvSpPr>
-        <p:spPr>
-          <a:xfrm xmlns:a="http://schemas.openxmlformats.org/drawingml/2006/main">
-            <a:off x="7069455" y="9444990"/>
+          <p:cNvPr id="222" name="dp44-implementation-comparison / n195 / arrow">
+            <a:extLst xmlns:a="http://schemas.openxmlformats.org/drawingml/2006/main">
+              <a:ext uri="{FF2B5EF4-FFF2-40B4-BE49-F238E27FC236}">
+                <a16:creationId xmlns:a16="http://schemas.microsoft.com/office/drawing/2014/main" id="{4E18D680-8939-40A1-AE90-27051551AEF5}"/>
+              </a:ext>
+            </a:extLst>
+          </p:cNvPr>
+          <p:cNvSpPr>
+            <a:spLocks xmlns:a="http://schemas.openxmlformats.org/drawingml/2006/main" noGrp="1"/>
+          </p:cNvSpPr>
+          <p:nvPr/>
+        </p:nvSpPr>
+        <p:spPr>
+          <a:xfrm xmlns:a="http://schemas.openxmlformats.org/drawingml/2006/main">
+            <a:off x="9736455" y="9444990"/>
             <a:ext cx="121920" cy="121920"/>
           </a:xfrm>
           <a:custGeom xmlns:a="http://schemas.openxmlformats.org/drawingml/2006/main">
@@ -12648,30 +12907,30 @@
           <a:noFill xmlns:a="http://schemas.openxmlformats.org/drawingml/2006/main"/>
           <a:ln xmlns:a="http://schemas.openxmlformats.org/drawingml/2006/main" w="24384">
             <a:solidFill>
-              <a:srgbClr val="2858A5"/>
-            </a:solidFill>
-            <a:prstDash val="solid"/>
-          </a:ln>
-        </p:spPr>
-      </p:sp>
-      <p:sp>
-        <p:nvSpPr>
-          <p:cNvPr id="218" name="dp44-implementation-comparison / n193 / text 1">
-            <a:extLst xmlns:a="http://schemas.openxmlformats.org/drawingml/2006/main">
-              <a:ext uri="{FF2B5EF4-FFF2-40B4-BE49-F238E27FC236}">
-                <a16:creationId xmlns:a16="http://schemas.microsoft.com/office/drawing/2014/main" id="{734B0704-F399-4ACB-9309-CB805F923A7A}"/>
-              </a:ext>
-            </a:extLst>
-          </p:cNvPr>
-          <p:cNvSpPr>
-            <a:spLocks xmlns:a="http://schemas.openxmlformats.org/drawingml/2006/main" noGrp="1"/>
-          </p:cNvSpPr>
-          <p:nvPr/>
-        </p:nvSpPr>
-        <p:spPr>
-          <a:xfrm xmlns:a="http://schemas.openxmlformats.org/drawingml/2006/main">
-            <a:off x="7286625" y="9353550"/>
-            <a:ext cx="1666875" cy="234791"/>
+              <a:srgbClr val="B63732"/>
+            </a:solidFill>
+            <a:prstDash val="solid"/>
+          </a:ln>
+        </p:spPr>
+      </p:sp>
+      <p:sp>
+        <p:nvSpPr>
+          <p:cNvPr id="223" name="dp44-implementation-comparison / n196 / text 1">
+            <a:extLst xmlns:a="http://schemas.openxmlformats.org/drawingml/2006/main">
+              <a:ext uri="{FF2B5EF4-FFF2-40B4-BE49-F238E27FC236}">
+                <a16:creationId xmlns:a16="http://schemas.microsoft.com/office/drawing/2014/main" id="{A022AE46-99AB-4DDD-A223-864487A9C4C7}"/>
+              </a:ext>
+            </a:extLst>
+          </p:cNvPr>
+          <p:cNvSpPr>
+            <a:spLocks xmlns:a="http://schemas.openxmlformats.org/drawingml/2006/main" noGrp="1"/>
+          </p:cNvSpPr>
+          <p:nvPr/>
+        </p:nvSpPr>
+        <p:spPr>
+          <a:xfrm xmlns:a="http://schemas.openxmlformats.org/drawingml/2006/main">
+            <a:off x="9953625" y="9353550"/>
+            <a:ext cx="1762125" cy="234791"/>
           </a:xfrm>
           <a:prstGeom xmlns:a="http://schemas.openxmlformats.org/drawingml/2006/main" prst="rect">
             <a:avLst/>
@@ -12718,112 +12977,29 @@
                 <a:ea typeface="Calibri"/>
                 <a:cs typeface="Calibri"/>
               </a:rPr>
-              <a:t>완료 callback</a:t>
+              <a:t>제어와 취소</a:t>
             </a:r>
           </a:p>
         </p:txBody>
       </p:sp>
       <p:sp>
         <p:nvSpPr>
-          <p:cNvPr id="219" name="dp44-implementation-comparison / n194 / path">
-            <a:extLst xmlns:a="http://schemas.openxmlformats.org/drawingml/2006/main">
-              <a:ext uri="{FF2B5EF4-FFF2-40B4-BE49-F238E27FC236}">
-                <a16:creationId xmlns:a16="http://schemas.microsoft.com/office/drawing/2014/main" id="{9F376EB2-B66E-47C9-822D-625D17F1EF2D}"/>
-              </a:ext>
-            </a:extLst>
-          </p:cNvPr>
-          <p:cNvSpPr>
-            <a:spLocks xmlns:a="http://schemas.openxmlformats.org/drawingml/2006/main" noGrp="1"/>
-          </p:cNvSpPr>
-          <p:nvPr/>
-        </p:nvSpPr>
-        <p:spPr>
-          <a:xfrm xmlns:a="http://schemas.openxmlformats.org/drawingml/2006/main">
-            <a:off x="9239250" y="9505950"/>
-            <a:ext cx="619125" cy="953"/>
-          </a:xfrm>
-          <a:custGeom xmlns:a="http://schemas.openxmlformats.org/drawingml/2006/main">
-            <a:pathLst>
-              <a:path w="619125" h="953">
-                <a:moveTo>
-                  <a:pt x="0" y="0"/>
-                </a:moveTo>
-                <a:lnTo>
-                  <a:pt x="619125" y="0"/>
-                </a:lnTo>
-              </a:path>
-            </a:pathLst>
-          </a:custGeom>
-          <a:noFill xmlns:a="http://schemas.openxmlformats.org/drawingml/2006/main"/>
-          <a:ln xmlns:a="http://schemas.openxmlformats.org/drawingml/2006/main" w="19050">
-            <a:solidFill>
-              <a:srgbClr val="B63732"/>
-            </a:solidFill>
-            <a:prstDash val="dash"/>
-          </a:ln>
-        </p:spPr>
-      </p:sp>
-      <p:sp>
-        <p:nvSpPr>
-          <p:cNvPr id="220" name="dp44-implementation-comparison / n194 / arrow">
-            <a:extLst xmlns:a="http://schemas.openxmlformats.org/drawingml/2006/main">
-              <a:ext uri="{FF2B5EF4-FFF2-40B4-BE49-F238E27FC236}">
-                <a16:creationId xmlns:a16="http://schemas.microsoft.com/office/drawing/2014/main" id="{02AFF28E-E4CC-4E1D-8F0E-E83786776EA1}"/>
-              </a:ext>
-            </a:extLst>
-          </p:cNvPr>
-          <p:cNvSpPr>
-            <a:spLocks xmlns:a="http://schemas.openxmlformats.org/drawingml/2006/main" noGrp="1"/>
-          </p:cNvSpPr>
-          <p:nvPr/>
-        </p:nvSpPr>
-        <p:spPr>
-          <a:xfrm xmlns:a="http://schemas.openxmlformats.org/drawingml/2006/main">
-            <a:off x="9736455" y="9444990"/>
-            <a:ext cx="121920" cy="121920"/>
-          </a:xfrm>
-          <a:custGeom xmlns:a="http://schemas.openxmlformats.org/drawingml/2006/main">
-            <a:pathLst>
-              <a:path w="121920" h="121920">
-                <a:moveTo>
-                  <a:pt x="0" y="121920"/>
-                </a:moveTo>
-                <a:lnTo>
-                  <a:pt x="121920" y="60960"/>
-                </a:lnTo>
-                <a:lnTo>
-                  <a:pt x="0" y="0"/>
-                </a:lnTo>
-              </a:path>
-            </a:pathLst>
-          </a:custGeom>
-          <a:noFill xmlns:a="http://schemas.openxmlformats.org/drawingml/2006/main"/>
-          <a:ln xmlns:a="http://schemas.openxmlformats.org/drawingml/2006/main" w="24384">
-            <a:solidFill>
-              <a:srgbClr val="B63732"/>
-            </a:solidFill>
-            <a:prstDash val="solid"/>
-          </a:ln>
-        </p:spPr>
-      </p:sp>
-      <p:sp>
-        <p:nvSpPr>
-          <p:cNvPr id="221" name="dp44-implementation-comparison / n195 / text 1">
-            <a:extLst xmlns:a="http://schemas.openxmlformats.org/drawingml/2006/main">
-              <a:ext uri="{FF2B5EF4-FFF2-40B4-BE49-F238E27FC236}">
-                <a16:creationId xmlns:a16="http://schemas.microsoft.com/office/drawing/2014/main" id="{D02D396D-CA20-4B21-93A6-880DF44874E8}"/>
-              </a:ext>
-            </a:extLst>
-          </p:cNvPr>
-          <p:cNvSpPr>
-            <a:spLocks xmlns:a="http://schemas.openxmlformats.org/drawingml/2006/main" noGrp="1"/>
-          </p:cNvSpPr>
-          <p:nvPr/>
-        </p:nvSpPr>
-        <p:spPr>
-          <a:xfrm xmlns:a="http://schemas.openxmlformats.org/drawingml/2006/main">
-            <a:off x="9953625" y="9353550"/>
-            <a:ext cx="1762125" cy="234791"/>
+          <p:cNvPr id="224" name="dp44-implementation-comparison / n197 / text 1">
+            <a:extLst xmlns:a="http://schemas.openxmlformats.org/drawingml/2006/main">
+              <a:ext uri="{FF2B5EF4-FFF2-40B4-BE49-F238E27FC236}">
+                <a16:creationId xmlns:a16="http://schemas.microsoft.com/office/drawing/2014/main" id="{1A84F19E-68C7-446A-9FDC-695DBB2CA9DE}"/>
+              </a:ext>
+            </a:extLst>
+          </p:cNvPr>
+          <p:cNvSpPr>
+            <a:spLocks xmlns:a="http://schemas.openxmlformats.org/drawingml/2006/main" noGrp="1"/>
+          </p:cNvSpPr>
+          <p:nvPr/>
+        </p:nvSpPr>
+        <p:spPr>
+          <a:xfrm xmlns:a="http://schemas.openxmlformats.org/drawingml/2006/main">
+            <a:off x="12096750" y="9353550"/>
+            <a:ext cx="5476875" cy="234791"/>
           </a:xfrm>
           <a:prstGeom xmlns:a="http://schemas.openxmlformats.org/drawingml/2006/main" prst="rect">
             <a:avLst/>
@@ -12842,7 +13018,7 @@
             <a:defPPr algn="l">
               <a:defRPr sz="1275" b="0">
                 <a:solidFill>
-                  <a:srgbClr val="18232E"/>
+                  <a:srgbClr val="5F6B77"/>
                 </a:solidFill>
                 <a:latin typeface="Calibri"/>
                 <a:ea typeface="Calibri"/>
@@ -12854,75 +13030,6 @@
             <a:pPr algn="l">
               <a:defRPr sz="1275" b="0">
                 <a:solidFill>
-                  <a:srgbClr val="18232E"/>
-                </a:solidFill>
-                <a:latin typeface="Calibri"/>
-                <a:ea typeface="Calibri"/>
-                <a:cs typeface="Calibri"/>
-              </a:defRPr>
-            </a:pPr>
-            <a:r>
-              <a:rPr sz="1275" b="0">
-                <a:solidFill>
-                  <a:srgbClr val="18232E"/>
-                </a:solidFill>
-                <a:latin typeface="Calibri"/>
-                <a:ea typeface="Calibri"/>
-                <a:cs typeface="Calibri"/>
-              </a:rPr>
-              <a:t>제어와 취소</a:t>
-            </a:r>
-          </a:p>
-        </p:txBody>
-      </p:sp>
-      <p:sp>
-        <p:nvSpPr>
-          <p:cNvPr id="222" name="dp44-implementation-comparison / n196 / text 1">
-            <a:extLst xmlns:a="http://schemas.openxmlformats.org/drawingml/2006/main">
-              <a:ext uri="{FF2B5EF4-FFF2-40B4-BE49-F238E27FC236}">
-                <a16:creationId xmlns:a16="http://schemas.microsoft.com/office/drawing/2014/main" id="{1A9E7947-6B8B-40AF-9429-A456DD6FDEC3}"/>
-              </a:ext>
-            </a:extLst>
-          </p:cNvPr>
-          <p:cNvSpPr>
-            <a:spLocks xmlns:a="http://schemas.openxmlformats.org/drawingml/2006/main" noGrp="1"/>
-          </p:cNvSpPr>
-          <p:nvPr/>
-        </p:nvSpPr>
-        <p:spPr>
-          <a:xfrm xmlns:a="http://schemas.openxmlformats.org/drawingml/2006/main">
-            <a:off x="12096750" y="9353550"/>
-            <a:ext cx="5476875" cy="234791"/>
-          </a:xfrm>
-          <a:prstGeom xmlns:a="http://schemas.openxmlformats.org/drawingml/2006/main" prst="rect">
-            <a:avLst/>
-          </a:prstGeom>
-          <a:noFill xmlns:a="http://schemas.openxmlformats.org/drawingml/2006/main"/>
-          <a:ln xmlns:a="http://schemas.openxmlformats.org/drawingml/2006/main" w="0">
-            <a:noFill/>
-            <a:prstDash val="solid"/>
-          </a:ln>
-        </p:spPr>
-        <p:txBody>
-          <a:bodyPr xmlns:a="http://schemas.openxmlformats.org/drawingml/2006/main" wrap="none" lIns="0" tIns="0" rIns="0" bIns="0" anchor="t">
-            <a:noAutofit/>
-          </a:bodyPr>
-          <a:lstStyle xmlns:a="http://schemas.openxmlformats.org/drawingml/2006/main">
-            <a:defPPr algn="l">
-              <a:defRPr sz="1275" b="0">
-                <a:solidFill>
-                  <a:srgbClr val="5F6B77"/>
-                </a:solidFill>
-                <a:latin typeface="Calibri"/>
-                <a:ea typeface="Calibri"/>
-                <a:cs typeface="Calibri"/>
-              </a:defRPr>
-            </a:defPPr>
-          </a:lstStyle>
-          <a:p xmlns:a="http://schemas.openxmlformats.org/drawingml/2006/main">
-            <a:pPr algn="l">
-              <a:defRPr sz="1275" b="0">
-                <a:solidFill>
                   <a:srgbClr val="5F6B77"/>
                 </a:solidFill>
                 <a:latin typeface="Calibri"/>
@@ -12947,7 +13054,7 @@
     </p:spTree>
     <p:extLst>
       <p:ext uri="{BB962C8B-B14F-4D97-AF65-F5344CB8AC3E}">
-        <p14:creationId xmlns:p14="http://schemas.microsoft.com/office/powerpoint/2010/main" val="1484228948"/>
+        <p14:creationId xmlns:p14="http://schemas.microsoft.com/office/powerpoint/2010/main" val="2074085821"/>
       </p:ext>
     </p:extLst>
   </p:cSld>

</xml_diff>